<commit_message>
Remove promotional filler throughout the Jetson presentation
</commit_message>
<xml_diff>
--- a/docs/Jetson_Nano_Local_AI_Experiments.pptx
+++ b/docs/Jetson_Nano_Local_AI_Experiments.pptx
@@ -2,22 +2,22 @@
 <file path=ppt/presentation.xml><?xml version="1.0" encoding="utf-8"?>
 <p:presentation xmlns:p="http://schemas.openxmlformats.org/presentationml/2006/main">
   <p:sldMasterIdLst>
-    <p:sldMasterId xmlns:r="http://schemas.openxmlformats.org/officeDocument/2006/relationships" id="2147483648" r:id="R63c9e2d4bc2d42ee"/>
+    <p:sldMasterId xmlns:r="http://schemas.openxmlformats.org/officeDocument/2006/relationships" id="2147483648" r:id="R61318e96a7424672"/>
   </p:sldMasterIdLst>
   <p:notesMasterIdLst>
-    <p:notesMasterId xmlns:r="http://schemas.openxmlformats.org/officeDocument/2006/relationships" r:id="R243c1052c57c4d20"/>
+    <p:notesMasterId xmlns:r="http://schemas.openxmlformats.org/officeDocument/2006/relationships" r:id="Rc520d7186cd54fdc"/>
   </p:notesMasterIdLst>
   <p:sldIdLst>
-    <p:sldId xmlns:r="http://schemas.openxmlformats.org/officeDocument/2006/relationships" id="256" r:id="Rd35f6f33c2764035"/>
-    <p:sldId xmlns:r="http://schemas.openxmlformats.org/officeDocument/2006/relationships" id="257" r:id="Rb967bbbd29db421c"/>
-    <p:sldId xmlns:r="http://schemas.openxmlformats.org/officeDocument/2006/relationships" id="258" r:id="Rb5647ad114b34648"/>
-    <p:sldId xmlns:r="http://schemas.openxmlformats.org/officeDocument/2006/relationships" id="259" r:id="R15b1ff74641a4d9b"/>
-    <p:sldId xmlns:r="http://schemas.openxmlformats.org/officeDocument/2006/relationships" id="260" r:id="R528cdc9c1af34cc4"/>
-    <p:sldId xmlns:r="http://schemas.openxmlformats.org/officeDocument/2006/relationships" id="261" r:id="R9258778ac5e146f8"/>
-    <p:sldId xmlns:r="http://schemas.openxmlformats.org/officeDocument/2006/relationships" id="262" r:id="R6fd447b9efe14302"/>
-    <p:sldId xmlns:r="http://schemas.openxmlformats.org/officeDocument/2006/relationships" id="263" r:id="Ree3d3b135f6c4e66"/>
-    <p:sldId xmlns:r="http://schemas.openxmlformats.org/officeDocument/2006/relationships" id="264" r:id="R3aaa7acc11774167"/>
-    <p:sldId xmlns:r="http://schemas.openxmlformats.org/officeDocument/2006/relationships" id="265" r:id="R8bf70701525b47ff"/>
+    <p:sldId xmlns:r="http://schemas.openxmlformats.org/officeDocument/2006/relationships" id="256" r:id="R080aaf2cef074074"/>
+    <p:sldId xmlns:r="http://schemas.openxmlformats.org/officeDocument/2006/relationships" id="257" r:id="R9842083640644bb7"/>
+    <p:sldId xmlns:r="http://schemas.openxmlformats.org/officeDocument/2006/relationships" id="258" r:id="Rf1d9287b809c4093"/>
+    <p:sldId xmlns:r="http://schemas.openxmlformats.org/officeDocument/2006/relationships" id="259" r:id="R4dd05ad61c1f4839"/>
+    <p:sldId xmlns:r="http://schemas.openxmlformats.org/officeDocument/2006/relationships" id="260" r:id="Ra5aea37353e54db0"/>
+    <p:sldId xmlns:r="http://schemas.openxmlformats.org/officeDocument/2006/relationships" id="261" r:id="Rceaa78151687443c"/>
+    <p:sldId xmlns:r="http://schemas.openxmlformats.org/officeDocument/2006/relationships" id="262" r:id="Rb92dbb3a577b4d2c"/>
+    <p:sldId xmlns:r="http://schemas.openxmlformats.org/officeDocument/2006/relationships" id="263" r:id="R59dddf2f9aa84e53"/>
+    <p:sldId xmlns:r="http://schemas.openxmlformats.org/officeDocument/2006/relationships" id="264" r:id="R8518f4595e6a4d0b"/>
+    <p:sldId xmlns:r="http://schemas.openxmlformats.org/officeDocument/2006/relationships" id="265" r:id="R574953dfd6c046df"/>
   </p:sldIdLst>
   <p:sldSz cx="12192000" cy="6858000"/>
   <p:notesSz cx="6858000" cy="9144000"/>
@@ -1204,7 +1204,7 @@
   </p:cSld>
   <p:clrMap bg1="lt1" tx1="dk1" bg2="lt2" tx2="dk2" accent1="accent1" accent2="accent2" accent3="accent3" accent4="accent4" accent5="accent5" accent6="accent6" hlink="hlink" folHlink="folHlink"/>
   <p:sldLayoutIdLst>
-    <p:sldLayoutId xmlns:r="http://schemas.openxmlformats.org/officeDocument/2006/relationships" id="2147483649" r:id="Ra5c741f6d8f742c9"/>
+    <p:sldLayoutId xmlns:r="http://schemas.openxmlformats.org/officeDocument/2006/relationships" id="2147483649" r:id="R5c5f1502f4ad4b8b"/>
   </p:sldLayoutIdLst>
   <p:txStyles>
     <p:titleStyle>
@@ -1752,10 +1752,10 @@
       </p:grpSpPr>
       <p:sp>
         <p:nvSpPr>
-          <p:cNvPr id="8" name="">
+          <p:cNvPr id="4" name="">
             <a:extLst xmlns:a="http://schemas.openxmlformats.org/drawingml/2006/main">
               <a:ext uri="{FF2B5EF4-FFF2-40B4-BE49-F238E27FC236}">
-                <a16:creationId xmlns:a16="http://schemas.microsoft.com/office/drawing/2014/main" id="{652D6817-1018-499B-AE97-27ECF4A92967}"/>
+                <a16:creationId xmlns:a16="http://schemas.microsoft.com/office/drawing/2014/main" id="{1106B75C-3A80-46EF-AA96-1B07B61AFF18}"/>
               </a:ext>
             </a:extLst>
           </p:cNvPr>
@@ -1766,8 +1766,8 @@
         </p:nvSpPr>
         <p:spPr>
           <a:xfrm xmlns:a="http://schemas.openxmlformats.org/drawingml/2006/main">
-            <a:off x="685800" y="647700"/>
-            <a:ext cx="10668000" cy="381000"/>
+            <a:off x="666750" y="1809750"/>
+            <a:ext cx="6191250" cy="1809750"/>
           </a:xfrm>
           <a:prstGeom xmlns:a="http://schemas.openxmlformats.org/drawingml/2006/main" prst="rect">
             <a:avLst/>
@@ -1784,9 +1784,9 @@
           <a:lstStyle xmlns:a="http://schemas.openxmlformats.org/drawingml/2006/main"/>
           <a:p xmlns:a="http://schemas.openxmlformats.org/drawingml/2006/main">
             <a:pPr>
-              <a:defRPr sz="1575" b="1">
-                <a:solidFill>
-                  <a:srgbClr val="397718"/>
+              <a:defRPr sz="4950" b="1">
+                <a:solidFill>
+                  <a:srgbClr val="19332A"/>
                 </a:solidFill>
                 <a:latin typeface="Arial"/>
                 <a:ea typeface="Arial"/>
@@ -1794,54 +1794,20 @@
               </a:defRPr>
             </a:pPr>
             <a:r>
-              <a:rPr sz="1575" b="1">
-                <a:solidFill>
-                  <a:srgbClr val="397718"/>
+              <a:rPr sz="4950" b="1">
+                <a:solidFill>
+                  <a:srgbClr val="19332A"/>
                 </a:solidFill>
                 <a:latin typeface="Arial"/>
                 <a:ea typeface="Arial"/>
                 <a:cs typeface="Arial"/>
               </a:rPr>
-              <a:t>LOCAL AI / CLASSROOM EXPERIMENTS</a:t>
-            </a:r>
-          </a:p>
-        </p:txBody>
-      </p:sp>
-      <p:sp>
-        <p:nvSpPr>
-          <p:cNvPr id="2" name="">
-            <a:extLst xmlns:a="http://schemas.openxmlformats.org/drawingml/2006/main">
-              <a:ext uri="{FF2B5EF4-FFF2-40B4-BE49-F238E27FC236}">
-                <a16:creationId xmlns:a16="http://schemas.microsoft.com/office/drawing/2014/main" id="{AB77F809-9AE7-42B4-B2C8-57DC9D6D7116}"/>
-              </a:ext>
-            </a:extLst>
-          </p:cNvPr>
-          <p:cNvSpPr>
-            <a:spLocks xmlns:a="http://schemas.openxmlformats.org/drawingml/2006/main" noGrp="1"/>
-          </p:cNvSpPr>
-          <p:nvPr/>
-        </p:nvSpPr>
-        <p:spPr>
-          <a:xfrm xmlns:a="http://schemas.openxmlformats.org/drawingml/2006/main">
-            <a:off x="666750" y="1638300"/>
-            <a:ext cx="6000750" cy="1809750"/>
-          </a:xfrm>
-          <a:prstGeom xmlns:a="http://schemas.openxmlformats.org/drawingml/2006/main" prst="rect">
-            <a:avLst/>
-          </a:prstGeom>
-          <a:noFill xmlns:a="http://schemas.openxmlformats.org/drawingml/2006/main"/>
-          <a:ln xmlns:a="http://schemas.openxmlformats.org/drawingml/2006/main" w="0">
-            <a:noFill/>
-          </a:ln>
-        </p:spPr>
-        <p:txBody>
-          <a:bodyPr xmlns:a="http://schemas.openxmlformats.org/drawingml/2006/main">
-            <a:noAutofit/>
-          </a:bodyPr>
-          <a:lstStyle xmlns:a="http://schemas.openxmlformats.org/drawingml/2006/main"/>
+              <a:t>Language Models</a:t>
+            </a:r>
+          </a:p>
           <a:p xmlns:a="http://schemas.openxmlformats.org/drawingml/2006/main">
             <a:pPr>
-              <a:defRPr sz="5700" b="1">
+              <a:defRPr sz="4950" b="1">
                 <a:solidFill>
                   <a:srgbClr val="19332A"/>
                 </a:solidFill>
@@ -1851,7 +1817,7 @@
               </a:defRPr>
             </a:pPr>
             <a:r>
-              <a:rPr sz="5700" b="1">
+              <a:rPr sz="4950" b="1">
                 <a:solidFill>
                   <a:srgbClr val="19332A"/>
                 </a:solidFill>
@@ -1859,261 +1825,21 @@
                 <a:ea typeface="Arial"/>
                 <a:cs typeface="Arial"/>
               </a:rPr>
-              <a:t>Local AI on</a:t>
-            </a:r>
-          </a:p>
-          <a:p xmlns:a="http://schemas.openxmlformats.org/drawingml/2006/main">
-            <a:pPr>
-              <a:defRPr sz="5700" b="1">
-                <a:solidFill>
-                  <a:srgbClr val="19332A"/>
-                </a:solidFill>
-                <a:latin typeface="Arial"/>
-                <a:ea typeface="Arial"/>
-                <a:cs typeface="Arial"/>
-              </a:defRPr>
-            </a:pPr>
-            <a:r>
-              <a:rPr sz="5700" b="1">
-                <a:solidFill>
-                  <a:srgbClr val="19332A"/>
-                </a:solidFill>
-                <a:latin typeface="Arial"/>
-                <a:ea typeface="Arial"/>
-                <a:cs typeface="Arial"/>
-              </a:rPr>
-              <a:t>Jetson Nano</a:t>
-            </a:r>
-          </a:p>
-        </p:txBody>
-      </p:sp>
-      <p:sp>
-        <p:nvSpPr>
-          <p:cNvPr id="3" name="">
-            <a:extLst xmlns:a="http://schemas.openxmlformats.org/drawingml/2006/main">
-              <a:ext uri="{FF2B5EF4-FFF2-40B4-BE49-F238E27FC236}">
-                <a16:creationId xmlns:a16="http://schemas.microsoft.com/office/drawing/2014/main" id="{B6BA6D0A-27ED-4EE6-A6FC-13751BB7F949}"/>
-              </a:ext>
-            </a:extLst>
-          </p:cNvPr>
-          <p:cNvSpPr>
-            <a:spLocks xmlns:a="http://schemas.openxmlformats.org/drawingml/2006/main" noGrp="1"/>
-          </p:cNvSpPr>
-          <p:nvPr/>
-        </p:nvSpPr>
-        <p:spPr>
-          <a:xfrm xmlns:a="http://schemas.openxmlformats.org/drawingml/2006/main">
-            <a:off x="723900" y="3714750"/>
-            <a:ext cx="5429250" cy="895350"/>
-          </a:xfrm>
-          <a:prstGeom xmlns:a="http://schemas.openxmlformats.org/drawingml/2006/main" prst="rect">
-            <a:avLst/>
-          </a:prstGeom>
-          <a:noFill xmlns:a="http://schemas.openxmlformats.org/drawingml/2006/main"/>
-          <a:ln xmlns:a="http://schemas.openxmlformats.org/drawingml/2006/main" w="0">
-            <a:noFill/>
-          </a:ln>
-        </p:spPr>
-        <p:txBody>
-          <a:bodyPr xmlns:a="http://schemas.openxmlformats.org/drawingml/2006/main">
-            <a:noAutofit/>
-          </a:bodyPr>
-          <a:lstStyle xmlns:a="http://schemas.openxmlformats.org/drawingml/2006/main"/>
-          <a:p xmlns:a="http://schemas.openxmlformats.org/drawingml/2006/main">
-            <a:pPr>
-              <a:defRPr sz="2175" b="0">
-                <a:solidFill>
-                  <a:srgbClr val="52635B"/>
-                </a:solidFill>
-                <a:latin typeface="Arial"/>
-                <a:ea typeface="Arial"/>
-                <a:cs typeface="Arial"/>
-              </a:defRPr>
-            </a:pPr>
-            <a:r>
-              <a:rPr sz="2175" b="0">
-                <a:solidFill>
-                  <a:srgbClr val="52635B"/>
-                </a:solidFill>
-                <a:latin typeface="Arial"/>
-                <a:ea typeface="Arial"/>
-                <a:cs typeface="Arial"/>
-              </a:rPr>
-              <a:t>Explore language, memory and vision</a:t>
-            </a:r>
-          </a:p>
-          <a:p xmlns:a="http://schemas.openxmlformats.org/drawingml/2006/main">
-            <a:pPr>
-              <a:defRPr sz="2175" b="0">
-                <a:solidFill>
-                  <a:srgbClr val="52635B"/>
-                </a:solidFill>
-                <a:latin typeface="Arial"/>
-                <a:ea typeface="Arial"/>
-                <a:cs typeface="Arial"/>
-              </a:defRPr>
-            </a:pPr>
-            <a:r>
-              <a:rPr sz="2175" b="0">
-                <a:solidFill>
-                  <a:srgbClr val="52635B"/>
-                </a:solidFill>
-                <a:latin typeface="Arial"/>
-                <a:ea typeface="Arial"/>
-                <a:cs typeface="Arial"/>
-              </a:rPr>
-              <a:t>with local models and a camera.</a:t>
-            </a:r>
-          </a:p>
-        </p:txBody>
-      </p:sp>
-      <p:sp>
-        <p:nvSpPr>
-          <p:cNvPr id="4" name="">
-            <a:extLst xmlns:a="http://schemas.openxmlformats.org/drawingml/2006/main">
-              <a:ext uri="{FF2B5EF4-FFF2-40B4-BE49-F238E27FC236}">
-                <a16:creationId xmlns:a16="http://schemas.microsoft.com/office/drawing/2014/main" id="{B6AB0054-8BC7-4A8B-9D6C-82710923E27E}"/>
-              </a:ext>
-            </a:extLst>
-          </p:cNvPr>
-          <p:cNvSpPr>
-            <a:spLocks xmlns:a="http://schemas.openxmlformats.org/drawingml/2006/main" noGrp="1"/>
-          </p:cNvSpPr>
-          <p:nvPr/>
-        </p:nvSpPr>
-        <p:spPr>
-          <a:xfrm xmlns:a="http://schemas.openxmlformats.org/drawingml/2006/main">
-            <a:off x="685800" y="4972050"/>
-            <a:ext cx="1428750" cy="952500"/>
-          </a:xfrm>
-          <a:prstGeom xmlns:a="http://schemas.openxmlformats.org/drawingml/2006/main" prst="rect">
-            <a:avLst/>
-          </a:prstGeom>
-          <a:noFill xmlns:a="http://schemas.openxmlformats.org/drawingml/2006/main"/>
-          <a:ln xmlns:a="http://schemas.openxmlformats.org/drawingml/2006/main" w="0">
-            <a:noFill/>
-          </a:ln>
-        </p:spPr>
-        <p:txBody>
-          <a:bodyPr xmlns:a="http://schemas.openxmlformats.org/drawingml/2006/main">
-            <a:noAutofit/>
-          </a:bodyPr>
-          <a:lstStyle xmlns:a="http://schemas.openxmlformats.org/drawingml/2006/main"/>
-          <a:p xmlns:a="http://schemas.openxmlformats.org/drawingml/2006/main">
-            <a:pPr>
-              <a:defRPr sz="6000" b="1">
-                <a:solidFill>
-                  <a:srgbClr val="397718"/>
-                </a:solidFill>
-                <a:latin typeface="Arial"/>
-                <a:ea typeface="Arial"/>
-                <a:cs typeface="Arial"/>
-              </a:defRPr>
-            </a:pPr>
-            <a:r>
-              <a:rPr sz="6000" b="1">
-                <a:solidFill>
-                  <a:srgbClr val="397718"/>
-                </a:solidFill>
-                <a:latin typeface="Arial"/>
-                <a:ea typeface="Arial"/>
-                <a:cs typeface="Arial"/>
-              </a:rPr>
-              <a:t>27</a:t>
-            </a:r>
-          </a:p>
-        </p:txBody>
-      </p:sp>
-      <p:sp>
-        <p:nvSpPr>
-          <p:cNvPr id="5" name="">
-            <a:extLst xmlns:a="http://schemas.openxmlformats.org/drawingml/2006/main">
-              <a:ext uri="{FF2B5EF4-FFF2-40B4-BE49-F238E27FC236}">
-                <a16:creationId xmlns:a16="http://schemas.microsoft.com/office/drawing/2014/main" id="{00AD9E32-303F-4F9D-B29E-4536B52A5CE5}"/>
-              </a:ext>
-            </a:extLst>
-          </p:cNvPr>
-          <p:cNvSpPr>
-            <a:spLocks xmlns:a="http://schemas.openxmlformats.org/drawingml/2006/main" noGrp="1"/>
-          </p:cNvSpPr>
-          <p:nvPr/>
-        </p:nvSpPr>
-        <p:spPr>
-          <a:xfrm xmlns:a="http://schemas.openxmlformats.org/drawingml/2006/main">
-            <a:off x="2171700" y="5181600"/>
-            <a:ext cx="3429000" cy="762000"/>
-          </a:xfrm>
-          <a:prstGeom xmlns:a="http://schemas.openxmlformats.org/drawingml/2006/main" prst="rect">
-            <a:avLst/>
-          </a:prstGeom>
-          <a:noFill xmlns:a="http://schemas.openxmlformats.org/drawingml/2006/main"/>
-          <a:ln xmlns:a="http://schemas.openxmlformats.org/drawingml/2006/main" w="0">
-            <a:noFill/>
-          </a:ln>
-        </p:spPr>
-        <p:txBody>
-          <a:bodyPr xmlns:a="http://schemas.openxmlformats.org/drawingml/2006/main">
-            <a:noAutofit/>
-          </a:bodyPr>
-          <a:lstStyle xmlns:a="http://schemas.openxmlformats.org/drawingml/2006/main"/>
-          <a:p xmlns:a="http://schemas.openxmlformats.org/drawingml/2006/main">
-            <a:pPr>
-              <a:defRPr sz="2100" b="0">
-                <a:solidFill>
-                  <a:srgbClr val="19332A"/>
-                </a:solidFill>
-                <a:latin typeface="Arial"/>
-                <a:ea typeface="Arial"/>
-                <a:cs typeface="Arial"/>
-              </a:defRPr>
-            </a:pPr>
-            <a:r>
-              <a:rPr sz="2100" b="0">
-                <a:solidFill>
-                  <a:srgbClr val="19332A"/>
-                </a:solidFill>
-                <a:latin typeface="Arial"/>
-                <a:ea typeface="Arial"/>
-                <a:cs typeface="Arial"/>
-              </a:rPr>
-              <a:t>named experiments</a:t>
-            </a:r>
-          </a:p>
-          <a:p xmlns:a="http://schemas.openxmlformats.org/drawingml/2006/main">
-            <a:pPr>
-              <a:defRPr sz="2100" b="0">
-                <a:solidFill>
-                  <a:srgbClr val="19332A"/>
-                </a:solidFill>
-                <a:latin typeface="Arial"/>
-                <a:ea typeface="Arial"/>
-                <a:cs typeface="Arial"/>
-              </a:defRPr>
-            </a:pPr>
-            <a:r>
-              <a:rPr sz="2100" b="0">
-                <a:solidFill>
-                  <a:srgbClr val="19332A"/>
-                </a:solidFill>
-                <a:latin typeface="Arial"/>
-                <a:ea typeface="Arial"/>
-                <a:cs typeface="Arial"/>
-              </a:rPr>
-              <a:t>one Bash launcher</a:t>
+              <a:t>on Jetson Nano</a:t>
             </a:r>
           </a:p>
         </p:txBody>
       </p:sp>
       <p:pic>
         <p:nvPicPr>
-          <p:cNvPr id="13" name=""/>
+          <p:cNvPr id="5" name=""/>
           <p:cNvPicPr>
             <a:picLocks xmlns:a="http://schemas.openxmlformats.org/drawingml/2006/main" noChangeAspect="1"/>
           </p:cNvPicPr>
           <p:nvPr/>
         </p:nvPicPr>
         <p:blipFill>
-          <a:blip xmlns:r="http://schemas.openxmlformats.org/officeDocument/2006/relationships" xmlns:a="http://schemas.openxmlformats.org/drawingml/2006/main" r:embed="Rc4e22e0fe44447e8"/>
+          <a:blip xmlns:r="http://schemas.openxmlformats.org/officeDocument/2006/relationships" xmlns:a="http://schemas.openxmlformats.org/drawingml/2006/main" r:embed="R49d56913fcad4f70"/>
           <a:stretch xmlns:a="http://schemas.openxmlformats.org/drawingml/2006/main"/>
         </p:blipFill>
         <p:spPr>
@@ -2128,10 +1854,10 @@
       </p:pic>
       <p:sp>
         <p:nvSpPr>
-          <p:cNvPr id="7" name="">
+          <p:cNvPr id="3" name="">
             <a:extLst xmlns:a="http://schemas.openxmlformats.org/drawingml/2006/main">
               <a:ext uri="{FF2B5EF4-FFF2-40B4-BE49-F238E27FC236}">
-                <a16:creationId xmlns:a16="http://schemas.microsoft.com/office/drawing/2014/main" id="{F0BC6F1F-F461-4009-A0E1-F4EF8034499C}"/>
+                <a16:creationId xmlns:a16="http://schemas.microsoft.com/office/drawing/2014/main" id="{15DC085A-C050-42ED-92EA-488CBF23CAAD}"/>
               </a:ext>
             </a:extLst>
           </p:cNvPr>
@@ -2142,8 +1868,8 @@
         </p:nvSpPr>
         <p:spPr>
           <a:xfrm xmlns:a="http://schemas.openxmlformats.org/drawingml/2006/main">
-            <a:off x="714375" y="6286500"/>
-            <a:ext cx="8572500" cy="304800"/>
+            <a:off x="733425" y="4229100"/>
+            <a:ext cx="5048250" cy="1333500"/>
           </a:xfrm>
           <a:prstGeom xmlns:a="http://schemas.openxmlformats.org/drawingml/2006/main" prst="rect">
             <a:avLst/>
@@ -2160,7 +1886,7 @@
           <a:lstStyle xmlns:a="http://schemas.openxmlformats.org/drawingml/2006/main"/>
           <a:p xmlns:a="http://schemas.openxmlformats.org/drawingml/2006/main">
             <a:pPr>
-              <a:defRPr sz="1425" b="0">
+              <a:defRPr sz="1950" b="0">
                 <a:solidFill>
                   <a:srgbClr val="52635B"/>
                 </a:solidFill>
@@ -2170,7 +1896,7 @@
               </a:defRPr>
             </a:pPr>
             <a:r>
-              <a:rPr sz="1425" b="0">
+              <a:rPr sz="1950" b="0">
                 <a:solidFill>
                   <a:srgbClr val="52635B"/>
                 </a:solidFill>
@@ -2178,7 +1904,53 @@
                 <a:ea typeface="Arial"/>
                 <a:cs typeface="Arial"/>
               </a:rPr>
-              <a:t>Original Nano 4GB, JetPack 4, Python 3.6</a:t>
+              <a:t>Jetson Nano 4GB</a:t>
+            </a:r>
+          </a:p>
+          <a:p xmlns:a="http://schemas.openxmlformats.org/drawingml/2006/main">
+            <a:pPr>
+              <a:defRPr sz="1950" b="0">
+                <a:solidFill>
+                  <a:srgbClr val="52635B"/>
+                </a:solidFill>
+                <a:latin typeface="Arial"/>
+                <a:ea typeface="Arial"/>
+                <a:cs typeface="Arial"/>
+              </a:defRPr>
+            </a:pPr>
+            <a:r>
+              <a:rPr sz="1950" b="0">
+                <a:solidFill>
+                  <a:srgbClr val="52635B"/>
+                </a:solidFill>
+                <a:latin typeface="Arial"/>
+                <a:ea typeface="Arial"/>
+                <a:cs typeface="Arial"/>
+              </a:rPr>
+              <a:t>JetPack 4 / Ubuntu 18.04</a:t>
+            </a:r>
+          </a:p>
+          <a:p xmlns:a="http://schemas.openxmlformats.org/drawingml/2006/main">
+            <a:pPr>
+              <a:defRPr sz="1950" b="0">
+                <a:solidFill>
+                  <a:srgbClr val="52635B"/>
+                </a:solidFill>
+                <a:latin typeface="Arial"/>
+                <a:ea typeface="Arial"/>
+                <a:cs typeface="Arial"/>
+              </a:defRPr>
+            </a:pPr>
+            <a:r>
+              <a:rPr sz="1950" b="0">
+                <a:solidFill>
+                  <a:srgbClr val="52635B"/>
+                </a:solidFill>
+                <a:latin typeface="Arial"/>
+                <a:ea typeface="Arial"/>
+                <a:cs typeface="Arial"/>
+              </a:rPr>
+              <a:t>Python 3.6</a:t>
             </a:r>
           </a:p>
         </p:txBody>
@@ -2186,7 +1958,7 @@
     </p:spTree>
     <p:extLst>
       <p:ext uri="{BB962C8B-B14F-4D97-AF65-F5344CB8AC3E}">
-        <p14:creationId xmlns:p14="http://schemas.microsoft.com/office/powerpoint/2010/main" val="1809943120"/>
+        <p14:creationId xmlns:p14="http://schemas.microsoft.com/office/powerpoint/2010/main" val="153984656"/>
       </p:ext>
     </p:extLst>
   </p:cSld>
@@ -2217,7 +1989,7 @@
           <p:cNvPr id="11" name="">
             <a:extLst xmlns:a="http://schemas.openxmlformats.org/drawingml/2006/main">
               <a:ext uri="{FF2B5EF4-FFF2-40B4-BE49-F238E27FC236}">
-                <a16:creationId xmlns:a16="http://schemas.microsoft.com/office/drawing/2014/main" id="{C3952B3D-2EDE-4DF9-A5DD-FEDCD7A65305}"/>
+                <a16:creationId xmlns:a16="http://schemas.microsoft.com/office/drawing/2014/main" id="{194A2950-9D62-4123-A4D0-1EBB216DAEC6}"/>
               </a:ext>
             </a:extLst>
           </p:cNvPr>
@@ -2264,7 +2036,7 @@
                 <a:ea typeface="Arial"/>
                 <a:cs typeface="Arial"/>
               </a:rPr>
-              <a:t>A classroom sequence</a:t>
+              <a:t>Menu Controls</a:t>
             </a:r>
           </a:p>
         </p:txBody>
@@ -2274,121 +2046,7 @@
           <p:cNvPr id="2" name="">
             <a:extLst xmlns:a="http://schemas.openxmlformats.org/drawingml/2006/main">
               <a:ext uri="{FF2B5EF4-FFF2-40B4-BE49-F238E27FC236}">
-                <a16:creationId xmlns:a16="http://schemas.microsoft.com/office/drawing/2014/main" id="{9DF5FB92-DF7E-49B7-A58B-BBA48F3FDD47}"/>
-              </a:ext>
-            </a:extLst>
-          </p:cNvPr>
-          <p:cNvSpPr>
-            <a:spLocks xmlns:a="http://schemas.openxmlformats.org/drawingml/2006/main" noGrp="1"/>
-          </p:cNvSpPr>
-          <p:nvPr/>
-        </p:nvSpPr>
-        <p:spPr>
-          <a:xfrm xmlns:a="http://schemas.openxmlformats.org/drawingml/2006/main">
-            <a:off x="666750" y="1333500"/>
-            <a:ext cx="10858500" cy="619125"/>
-          </a:xfrm>
-          <a:prstGeom xmlns:a="http://schemas.openxmlformats.org/drawingml/2006/main" prst="rect">
-            <a:avLst/>
-          </a:prstGeom>
-          <a:noFill xmlns:a="http://schemas.openxmlformats.org/drawingml/2006/main"/>
-          <a:ln xmlns:a="http://schemas.openxmlformats.org/drawingml/2006/main" w="0">
-            <a:noFill/>
-          </a:ln>
-        </p:spPr>
-        <p:txBody>
-          <a:bodyPr xmlns:a="http://schemas.openxmlformats.org/drawingml/2006/main">
-            <a:noAutofit/>
-          </a:bodyPr>
-          <a:lstStyle xmlns:a="http://schemas.openxmlformats.org/drawingml/2006/main"/>
-          <a:p xmlns:a="http://schemas.openxmlformats.org/drawingml/2006/main">
-            <a:pPr>
-              <a:defRPr sz="1950" b="0">
-                <a:solidFill>
-                  <a:srgbClr val="52635B"/>
-                </a:solidFill>
-                <a:latin typeface="Arial"/>
-                <a:ea typeface="Arial"/>
-                <a:cs typeface="Arial"/>
-              </a:defRPr>
-            </a:pPr>
-            <a:r>
-              <a:rPr sz="1950" b="0">
-                <a:solidFill>
-                  <a:srgbClr val="52635B"/>
-                </a:solidFill>
-                <a:latin typeface="Arial"/>
-                <a:ea typeface="Arial"/>
-                <a:cs typeface="Arial"/>
-              </a:rPr>
-              <a:t>Choose a few experiments and let the audience steer.</a:t>
-            </a:r>
-          </a:p>
-        </p:txBody>
-      </p:sp>
-      <p:sp>
-        <p:nvSpPr>
-          <p:cNvPr id="3" name="">
-            <a:extLst xmlns:a="http://schemas.openxmlformats.org/drawingml/2006/main">
-              <a:ext uri="{FF2B5EF4-FFF2-40B4-BE49-F238E27FC236}">
-                <a16:creationId xmlns:a16="http://schemas.microsoft.com/office/drawing/2014/main" id="{5252BF21-84FC-489F-AFC7-111D58066FAA}"/>
-              </a:ext>
-            </a:extLst>
-          </p:cNvPr>
-          <p:cNvSpPr>
-            <a:spLocks xmlns:a="http://schemas.openxmlformats.org/drawingml/2006/main" noGrp="1"/>
-          </p:cNvSpPr>
-          <p:nvPr/>
-        </p:nvSpPr>
-        <p:spPr>
-          <a:xfrm xmlns:a="http://schemas.openxmlformats.org/drawingml/2006/main">
-            <a:off x="666750" y="6191250"/>
-            <a:ext cx="10287000" cy="419100"/>
-          </a:xfrm>
-          <a:prstGeom xmlns:a="http://schemas.openxmlformats.org/drawingml/2006/main" prst="rect">
-            <a:avLst/>
-          </a:prstGeom>
-          <a:noFill xmlns:a="http://schemas.openxmlformats.org/drawingml/2006/main"/>
-          <a:ln xmlns:a="http://schemas.openxmlformats.org/drawingml/2006/main" w="0">
-            <a:noFill/>
-          </a:ln>
-        </p:spPr>
-        <p:txBody>
-          <a:bodyPr xmlns:a="http://schemas.openxmlformats.org/drawingml/2006/main">
-            <a:noAutofit/>
-          </a:bodyPr>
-          <a:lstStyle xmlns:a="http://schemas.openxmlformats.org/drawingml/2006/main"/>
-          <a:p xmlns:a="http://schemas.openxmlformats.org/drawingml/2006/main">
-            <a:pPr>
-              <a:defRPr sz="1350" b="0">
-                <a:solidFill>
-                  <a:srgbClr val="52635B"/>
-                </a:solidFill>
-                <a:latin typeface="Arial"/>
-                <a:ea typeface="Arial"/>
-                <a:cs typeface="Arial"/>
-              </a:defRPr>
-            </a:pPr>
-            <a:r>
-              <a:rPr sz="1350" b="0">
-                <a:solidFill>
-                  <a:srgbClr val="52635B"/>
-                </a:solidFill>
-                <a:latin typeface="Arial"/>
-                <a:ea typeface="Arial"/>
-                <a:cs typeface="Arial"/>
-              </a:rPr>
-              <a:t>Start with a conversation, invite a plot twist, then bring the camera into the demonstration.</a:t>
-            </a:r>
-          </a:p>
-        </p:txBody>
-      </p:sp>
-      <p:sp>
-        <p:nvSpPr>
-          <p:cNvPr id="4" name="">
-            <a:extLst xmlns:a="http://schemas.openxmlformats.org/drawingml/2006/main">
-              <a:ext uri="{FF2B5EF4-FFF2-40B4-BE49-F238E27FC236}">
-                <a16:creationId xmlns:a16="http://schemas.microsoft.com/office/drawing/2014/main" id="{33A8B963-5181-492D-B70F-032C96C7ECAA}"/>
+                <a16:creationId xmlns:a16="http://schemas.microsoft.com/office/drawing/2014/main" id="{0283958C-2EA1-45A1-88EA-3324D6E9FC44}"/>
               </a:ext>
             </a:extLst>
           </p:cNvPr>
@@ -2442,10 +2100,10 @@
       </p:sp>
       <p:sp>
         <p:nvSpPr>
-          <p:cNvPr id="5" name="">
+          <p:cNvPr id="3" name="">
             <a:extLst xmlns:a="http://schemas.openxmlformats.org/drawingml/2006/main">
               <a:ext uri="{FF2B5EF4-FFF2-40B4-BE49-F238E27FC236}">
-                <a16:creationId xmlns:a16="http://schemas.microsoft.com/office/drawing/2014/main" id="{CBE98558-B21D-48A0-95F9-4E3F561C6AD5}"/>
+                <a16:creationId xmlns:a16="http://schemas.microsoft.com/office/drawing/2014/main" id="{1E710248-A880-459C-B7D8-311EEC2CFC61}"/>
               </a:ext>
             </a:extLst>
           </p:cNvPr>
@@ -2456,8 +2114,8 @@
         </p:nvSpPr>
         <p:spPr>
           <a:xfrm xmlns:a="http://schemas.openxmlformats.org/drawingml/2006/main">
-            <a:off x="714375" y="2181225"/>
-            <a:ext cx="10287000" cy="476250"/>
+            <a:off x="714375" y="2095500"/>
+            <a:ext cx="2667000" cy="476250"/>
           </a:xfrm>
           <a:prstGeom xmlns:a="http://schemas.openxmlformats.org/drawingml/2006/main" prst="rect">
             <a:avLst/>
@@ -2474,7 +2132,7 @@
           <a:lstStyle xmlns:a="http://schemas.openxmlformats.org/drawingml/2006/main"/>
           <a:p xmlns:a="http://schemas.openxmlformats.org/drawingml/2006/main">
             <a:pPr>
-              <a:defRPr sz="2550" b="1">
+              <a:defRPr sz="2400" b="1">
                 <a:solidFill>
                   <a:srgbClr val="19332A"/>
                 </a:solidFill>
@@ -2484,7 +2142,7 @@
               </a:defRPr>
             </a:pPr>
             <a:r>
-              <a:rPr sz="2550" b="1">
+              <a:rPr sz="2400" b="1">
                 <a:solidFill>
                   <a:srgbClr val="19332A"/>
                 </a:solidFill>
@@ -2492,17 +2150,17 @@
                 <a:ea typeface="Arial"/>
                 <a:cs typeface="Arial"/>
               </a:rPr>
-              <a:t>Start with an assistant</a:t>
-            </a:r>
-          </a:p>
-        </p:txBody>
-      </p:sp>
-      <p:sp>
-        <p:nvSpPr>
-          <p:cNvPr id="6" name="">
+              <a:t>Run</a:t>
+            </a:r>
+          </a:p>
+        </p:txBody>
+      </p:sp>
+      <p:sp>
+        <p:nvSpPr>
+          <p:cNvPr id="4" name="">
             <a:extLst xmlns:a="http://schemas.openxmlformats.org/drawingml/2006/main">
               <a:ext uri="{FF2B5EF4-FFF2-40B4-BE49-F238E27FC236}">
-                <a16:creationId xmlns:a16="http://schemas.microsoft.com/office/drawing/2014/main" id="{C3EB005F-47B3-4945-8754-EA440C1DF125}"/>
+                <a16:creationId xmlns:a16="http://schemas.microsoft.com/office/drawing/2014/main" id="{A119ED20-7498-4513-9BFB-F42F2EBF7790}"/>
               </a:ext>
             </a:extLst>
           </p:cNvPr>
@@ -2513,8 +2171,8 @@
         </p:nvSpPr>
         <p:spPr>
           <a:xfrm xmlns:a="http://schemas.openxmlformats.org/drawingml/2006/main">
-            <a:off x="742950" y="2695575"/>
-            <a:ext cx="10668000" cy="476250"/>
+            <a:off x="3429000" y="2114550"/>
+            <a:ext cx="7810500" cy="523875"/>
           </a:xfrm>
           <a:prstGeom xmlns:a="http://schemas.openxmlformats.org/drawingml/2006/main" prst="rect">
             <a:avLst/>
@@ -2531,7 +2189,7 @@
           <a:lstStyle xmlns:a="http://schemas.openxmlformats.org/drawingml/2006/main"/>
           <a:p xmlns:a="http://schemas.openxmlformats.org/drawingml/2006/main">
             <a:pPr>
-              <a:defRPr sz="1950" b="0">
+              <a:defRPr sz="2100" b="0">
                 <a:solidFill>
                   <a:srgbClr val="52635B"/>
                 </a:solidFill>
@@ -2541,7 +2199,7 @@
               </a:defRPr>
             </a:pPr>
             <a:r>
-              <a:rPr sz="1950" b="0">
+              <a:rPr sz="2100" b="0">
                 <a:solidFill>
                   <a:srgbClr val="52635B"/>
                 </a:solidFill>
@@ -2549,17 +2207,17 @@
                 <a:ea typeface="Arial"/>
                 <a:cs typeface="Arial"/>
               </a:rPr>
-              <a:t>15 Mission Control or 17 Story Director gives students a task to direct.</a:t>
-            </a:r>
-          </a:p>
-        </p:txBody>
-      </p:sp>
-      <p:sp>
-        <p:nvSpPr>
-          <p:cNvPr id="7" name="">
+              <a:t>Enter the experiment number.</a:t>
+            </a:r>
+          </a:p>
+        </p:txBody>
+      </p:sp>
+      <p:sp>
+        <p:nvSpPr>
+          <p:cNvPr id="5" name="">
             <a:extLst xmlns:a="http://schemas.openxmlformats.org/drawingml/2006/main">
               <a:ext uri="{FF2B5EF4-FFF2-40B4-BE49-F238E27FC236}">
-                <a16:creationId xmlns:a16="http://schemas.microsoft.com/office/drawing/2014/main" id="{19F3F0B1-2928-46D8-9C61-0C6CB34BB256}"/>
+                <a16:creationId xmlns:a16="http://schemas.microsoft.com/office/drawing/2014/main" id="{F858729D-5EE4-49F9-84A4-499DB83BDC33}"/>
               </a:ext>
             </a:extLst>
           </p:cNvPr>
@@ -2570,8 +2228,8 @@
         </p:nvSpPr>
         <p:spPr>
           <a:xfrm xmlns:a="http://schemas.openxmlformats.org/drawingml/2006/main">
-            <a:off x="714375" y="3457575"/>
-            <a:ext cx="10287000" cy="476250"/>
+            <a:off x="714375" y="3048000"/>
+            <a:ext cx="2667000" cy="476250"/>
           </a:xfrm>
           <a:prstGeom xmlns:a="http://schemas.openxmlformats.org/drawingml/2006/main" prst="rect">
             <a:avLst/>
@@ -2588,7 +2246,7 @@
           <a:lstStyle xmlns:a="http://schemas.openxmlformats.org/drawingml/2006/main"/>
           <a:p xmlns:a="http://schemas.openxmlformats.org/drawingml/2006/main">
             <a:pPr>
-              <a:defRPr sz="2550" b="1">
+              <a:defRPr sz="2400" b="1">
                 <a:solidFill>
                   <a:srgbClr val="19332A"/>
                 </a:solidFill>
@@ -2598,7 +2256,7 @@
               </a:defRPr>
             </a:pPr>
             <a:r>
-              <a:rPr sz="2550" b="1">
+              <a:rPr sz="2400" b="1">
                 <a:solidFill>
                   <a:srgbClr val="19332A"/>
                 </a:solidFill>
@@ -2606,17 +2264,17 @@
                 <a:ea typeface="Arial"/>
                 <a:cs typeface="Arial"/>
               </a:rPr>
-              <a:t>Introduce the camera</a:t>
-            </a:r>
-          </a:p>
-        </p:txBody>
-      </p:sp>
-      <p:sp>
-        <p:nvSpPr>
-          <p:cNvPr id="8" name="">
+              <a:t>Cancel</a:t>
+            </a:r>
+          </a:p>
+        </p:txBody>
+      </p:sp>
+      <p:sp>
+        <p:nvSpPr>
+          <p:cNvPr id="6" name="">
             <a:extLst xmlns:a="http://schemas.openxmlformats.org/drawingml/2006/main">
               <a:ext uri="{FF2B5EF4-FFF2-40B4-BE49-F238E27FC236}">
-                <a16:creationId xmlns:a16="http://schemas.microsoft.com/office/drawing/2014/main" id="{56AA2B63-EDA5-4390-A9E2-188B8DE2A074}"/>
+                <a16:creationId xmlns:a16="http://schemas.microsoft.com/office/drawing/2014/main" id="{4737F967-45C1-4BBD-92B1-56325A80786C}"/>
               </a:ext>
             </a:extLst>
           </p:cNvPr>
@@ -2627,8 +2285,8 @@
         </p:nvSpPr>
         <p:spPr>
           <a:xfrm xmlns:a="http://schemas.openxmlformats.org/drawingml/2006/main">
-            <a:off x="742950" y="3971925"/>
-            <a:ext cx="10668000" cy="476250"/>
+            <a:off x="3429000" y="3067050"/>
+            <a:ext cx="7810500" cy="762000"/>
           </a:xfrm>
           <a:prstGeom xmlns:a="http://schemas.openxmlformats.org/drawingml/2006/main" prst="rect">
             <a:avLst/>
@@ -2645,7 +2303,7 @@
           <a:lstStyle xmlns:a="http://schemas.openxmlformats.org/drawingml/2006/main"/>
           <a:p xmlns:a="http://schemas.openxmlformats.org/drawingml/2006/main">
             <a:pPr>
-              <a:defRPr sz="1950" b="0">
+              <a:defRPr sz="2100" b="0">
                 <a:solidFill>
                   <a:srgbClr val="52635B"/>
                 </a:solidFill>
@@ -2655,7 +2313,7 @@
               </a:defRPr>
             </a:pPr>
             <a:r>
-              <a:rPr sz="1950" b="0">
+              <a:rPr sz="2100" b="0">
                 <a:solidFill>
                   <a:srgbClr val="52635B"/>
                 </a:solidFill>
@@ -2663,17 +2321,17 @@
                 <a:ea typeface="Arial"/>
                 <a:cs typeface="Arial"/>
               </a:rPr>
-              <a:t>18 Scene Memory turns a small change on the desk into evidence to discuss.</a:t>
-            </a:r>
-          </a:p>
-        </p:txBody>
-      </p:sp>
-      <p:sp>
-        <p:nvSpPr>
-          <p:cNvPr id="9" name="">
+              <a:t>Ctrl+C stops the active demo and returns to the menu.</a:t>
+            </a:r>
+          </a:p>
+        </p:txBody>
+      </p:sp>
+      <p:sp>
+        <p:nvSpPr>
+          <p:cNvPr id="7" name="">
             <a:extLst xmlns:a="http://schemas.openxmlformats.org/drawingml/2006/main">
               <a:ext uri="{FF2B5EF4-FFF2-40B4-BE49-F238E27FC236}">
-                <a16:creationId xmlns:a16="http://schemas.microsoft.com/office/drawing/2014/main" id="{2BD6389B-8CBA-4810-B55D-F1D680D06036}"/>
+                <a16:creationId xmlns:a16="http://schemas.microsoft.com/office/drawing/2014/main" id="{08057652-AD49-4ED6-A493-1CCCF21F3D56}"/>
               </a:ext>
             </a:extLst>
           </p:cNvPr>
@@ -2684,8 +2342,8 @@
         </p:nvSpPr>
         <p:spPr>
           <a:xfrm xmlns:a="http://schemas.openxmlformats.org/drawingml/2006/main">
-            <a:off x="714375" y="4733925"/>
-            <a:ext cx="10287000" cy="476250"/>
+            <a:off x="714375" y="4191000"/>
+            <a:ext cx="2667000" cy="476250"/>
           </a:xfrm>
           <a:prstGeom xmlns:a="http://schemas.openxmlformats.org/drawingml/2006/main" prst="rect">
             <a:avLst/>
@@ -2702,7 +2360,7 @@
           <a:lstStyle xmlns:a="http://schemas.openxmlformats.org/drawingml/2006/main"/>
           <a:p xmlns:a="http://schemas.openxmlformats.org/drawingml/2006/main">
             <a:pPr>
-              <a:defRPr sz="2550" b="1">
+              <a:defRPr sz="2400" b="1">
                 <a:solidFill>
                   <a:srgbClr val="19332A"/>
                 </a:solidFill>
@@ -2712,7 +2370,7 @@
               </a:defRPr>
             </a:pPr>
             <a:r>
-              <a:rPr sz="2550" b="1">
+              <a:rPr sz="2400" b="1">
                 <a:solidFill>
                   <a:srgbClr val="19332A"/>
                 </a:solidFill>
@@ -2720,17 +2378,17 @@
                 <a:ea typeface="Arial"/>
                 <a:cs typeface="Arial"/>
               </a:rPr>
-              <a:t>Recover and repeat</a:t>
-            </a:r>
-          </a:p>
-        </p:txBody>
-      </p:sp>
-      <p:sp>
-        <p:nvSpPr>
-          <p:cNvPr id="10" name="">
+              <a:t>Exit</a:t>
+            </a:r>
+          </a:p>
+        </p:txBody>
+      </p:sp>
+      <p:sp>
+        <p:nvSpPr>
+          <p:cNvPr id="8" name="">
             <a:extLst xmlns:a="http://schemas.openxmlformats.org/drawingml/2006/main">
               <a:ext uri="{FF2B5EF4-FFF2-40B4-BE49-F238E27FC236}">
-                <a16:creationId xmlns:a16="http://schemas.microsoft.com/office/drawing/2014/main" id="{C23ED6FD-9E21-4643-A903-79C5821F9CFA}"/>
+                <a16:creationId xmlns:a16="http://schemas.microsoft.com/office/drawing/2014/main" id="{DA73CBB5-5680-4E43-A01B-9B7F20C6A7AA}"/>
               </a:ext>
             </a:extLst>
           </p:cNvPr>
@@ -2741,8 +2399,8 @@
         </p:nvSpPr>
         <p:spPr>
           <a:xfrm xmlns:a="http://schemas.openxmlformats.org/drawingml/2006/main">
-            <a:off x="742950" y="5248275"/>
-            <a:ext cx="10668000" cy="619125"/>
+            <a:off x="3429000" y="4210050"/>
+            <a:ext cx="7810500" cy="523875"/>
           </a:xfrm>
           <a:prstGeom xmlns:a="http://schemas.openxmlformats.org/drawingml/2006/main" prst="rect">
             <a:avLst/>
@@ -2759,7 +2417,7 @@
           <a:lstStyle xmlns:a="http://schemas.openxmlformats.org/drawingml/2006/main"/>
           <a:p xmlns:a="http://schemas.openxmlformats.org/drawingml/2006/main">
             <a:pPr>
-              <a:defRPr sz="1875" b="0">
+              <a:defRPr sz="2100" b="0">
                 <a:solidFill>
                   <a:srgbClr val="52635B"/>
                 </a:solidFill>
@@ -2769,7 +2427,7 @@
               </a:defRPr>
             </a:pPr>
             <a:r>
-              <a:rPr sz="1875" b="0">
+              <a:rPr sz="2100" b="0">
                 <a:solidFill>
                   <a:srgbClr val="52635B"/>
                 </a:solidFill>
@@ -2777,7 +2435,121 @@
                 <a:ea typeface="Arial"/>
                 <a:cs typeface="Arial"/>
               </a:rPr>
-              <a:t>Ctrl+C returns to the menu. 0 exits. 21 runs the prepared demonstration sequence.</a:t>
+              <a:t>Enter 0.</a:t>
+            </a:r>
+          </a:p>
+        </p:txBody>
+      </p:sp>
+      <p:sp>
+        <p:nvSpPr>
+          <p:cNvPr id="9" name="">
+            <a:extLst xmlns:a="http://schemas.openxmlformats.org/drawingml/2006/main">
+              <a:ext uri="{FF2B5EF4-FFF2-40B4-BE49-F238E27FC236}">
+                <a16:creationId xmlns:a16="http://schemas.microsoft.com/office/drawing/2014/main" id="{6E6DAB77-5ED2-47E5-85FF-281BEB12D136}"/>
+              </a:ext>
+            </a:extLst>
+          </p:cNvPr>
+          <p:cNvSpPr>
+            <a:spLocks xmlns:a="http://schemas.openxmlformats.org/drawingml/2006/main" noGrp="1"/>
+          </p:cNvSpPr>
+          <p:nvPr/>
+        </p:nvSpPr>
+        <p:spPr>
+          <a:xfrm xmlns:a="http://schemas.openxmlformats.org/drawingml/2006/main">
+            <a:off x="714375" y="5143500"/>
+            <a:ext cx="2667000" cy="476250"/>
+          </a:xfrm>
+          <a:prstGeom xmlns:a="http://schemas.openxmlformats.org/drawingml/2006/main" prst="rect">
+            <a:avLst/>
+          </a:prstGeom>
+          <a:noFill xmlns:a="http://schemas.openxmlformats.org/drawingml/2006/main"/>
+          <a:ln xmlns:a="http://schemas.openxmlformats.org/drawingml/2006/main" w="0">
+            <a:noFill/>
+          </a:ln>
+        </p:spPr>
+        <p:txBody>
+          <a:bodyPr xmlns:a="http://schemas.openxmlformats.org/drawingml/2006/main">
+            <a:noAutofit/>
+          </a:bodyPr>
+          <a:lstStyle xmlns:a="http://schemas.openxmlformats.org/drawingml/2006/main"/>
+          <a:p xmlns:a="http://schemas.openxmlformats.org/drawingml/2006/main">
+            <a:pPr>
+              <a:defRPr sz="2400" b="1">
+                <a:solidFill>
+                  <a:srgbClr val="19332A"/>
+                </a:solidFill>
+                <a:latin typeface="Arial"/>
+                <a:ea typeface="Arial"/>
+                <a:cs typeface="Arial"/>
+              </a:defRPr>
+            </a:pPr>
+            <a:r>
+              <a:rPr sz="2400" b="1">
+                <a:solidFill>
+                  <a:srgbClr val="19332A"/>
+                </a:solidFill>
+                <a:latin typeface="Arial"/>
+                <a:ea typeface="Arial"/>
+                <a:cs typeface="Arial"/>
+              </a:rPr>
+              <a:t>Sequence</a:t>
+            </a:r>
+          </a:p>
+        </p:txBody>
+      </p:sp>
+      <p:sp>
+        <p:nvSpPr>
+          <p:cNvPr id="10" name="">
+            <a:extLst xmlns:a="http://schemas.openxmlformats.org/drawingml/2006/main">
+              <a:ext uri="{FF2B5EF4-FFF2-40B4-BE49-F238E27FC236}">
+                <a16:creationId xmlns:a16="http://schemas.microsoft.com/office/drawing/2014/main" id="{ADB496BF-27A7-4FA3-A499-A40F905DFB7E}"/>
+              </a:ext>
+            </a:extLst>
+          </p:cNvPr>
+          <p:cNvSpPr>
+            <a:spLocks xmlns:a="http://schemas.openxmlformats.org/drawingml/2006/main" noGrp="1"/>
+          </p:cNvSpPr>
+          <p:nvPr/>
+        </p:nvSpPr>
+        <p:spPr>
+          <a:xfrm xmlns:a="http://schemas.openxmlformats.org/drawingml/2006/main">
+            <a:off x="3429000" y="5162550"/>
+            <a:ext cx="7810500" cy="762000"/>
+          </a:xfrm>
+          <a:prstGeom xmlns:a="http://schemas.openxmlformats.org/drawingml/2006/main" prst="rect">
+            <a:avLst/>
+          </a:prstGeom>
+          <a:noFill xmlns:a="http://schemas.openxmlformats.org/drawingml/2006/main"/>
+          <a:ln xmlns:a="http://schemas.openxmlformats.org/drawingml/2006/main" w="0">
+            <a:noFill/>
+          </a:ln>
+        </p:spPr>
+        <p:txBody>
+          <a:bodyPr xmlns:a="http://schemas.openxmlformats.org/drawingml/2006/main">
+            <a:noAutofit/>
+          </a:bodyPr>
+          <a:lstStyle xmlns:a="http://schemas.openxmlformats.org/drawingml/2006/main"/>
+          <a:p xmlns:a="http://schemas.openxmlformats.org/drawingml/2006/main">
+            <a:pPr>
+              <a:defRPr sz="2100" b="0">
+                <a:solidFill>
+                  <a:srgbClr val="52635B"/>
+                </a:solidFill>
+                <a:latin typeface="Arial"/>
+                <a:ea typeface="Arial"/>
+                <a:cs typeface="Arial"/>
+              </a:defRPr>
+            </a:pPr>
+            <a:r>
+              <a:rPr sz="2100" b="0">
+                <a:solidFill>
+                  <a:srgbClr val="52635B"/>
+                </a:solidFill>
+                <a:latin typeface="Arial"/>
+                <a:ea typeface="Arial"/>
+                <a:cs typeface="Arial"/>
+              </a:rPr>
+              <a:t>Enter 21 to run the prepared demonstrations.</a:t>
             </a:r>
           </a:p>
         </p:txBody>
@@ -2785,7 +2557,7 @@
     </p:spTree>
     <p:extLst>
       <p:ext uri="{BB962C8B-B14F-4D97-AF65-F5344CB8AC3E}">
-        <p14:creationId xmlns:p14="http://schemas.microsoft.com/office/powerpoint/2010/main" val="624355846"/>
+        <p14:creationId xmlns:p14="http://schemas.microsoft.com/office/powerpoint/2010/main" val="751267710"/>
       </p:ext>
     </p:extLst>
   </p:cSld>
@@ -2813,10 +2585,10 @@
       </p:grpSpPr>
       <p:sp>
         <p:nvSpPr>
-          <p:cNvPr id="14" name="">
+          <p:cNvPr id="9" name="">
             <a:extLst xmlns:a="http://schemas.openxmlformats.org/drawingml/2006/main">
               <a:ext uri="{FF2B5EF4-FFF2-40B4-BE49-F238E27FC236}">
-                <a16:creationId xmlns:a16="http://schemas.microsoft.com/office/drawing/2014/main" id="{E249BB3B-3496-4B0F-81C3-033DD8A6921B}"/>
+                <a16:creationId xmlns:a16="http://schemas.microsoft.com/office/drawing/2014/main" id="{1458723E-47F9-4C51-B72D-1C713527F837}"/>
               </a:ext>
             </a:extLst>
           </p:cNvPr>
@@ -2863,7 +2635,7 @@
                 <a:ea typeface="Arial"/>
                 <a:cs typeface="Arial"/>
               </a:rPr>
-              <a:t>Setup and the experiment menu</a:t>
+              <a:t>Setup</a:t>
             </a:r>
           </a:p>
         </p:txBody>
@@ -2873,7 +2645,7 @@
           <p:cNvPr id="2" name="">
             <a:extLst xmlns:a="http://schemas.openxmlformats.org/drawingml/2006/main">
               <a:ext uri="{FF2B5EF4-FFF2-40B4-BE49-F238E27FC236}">
-                <a16:creationId xmlns:a16="http://schemas.microsoft.com/office/drawing/2014/main" id="{7A60ECE8-7FDD-473B-AACA-5C11AB29F4BA}"/>
+                <a16:creationId xmlns:a16="http://schemas.microsoft.com/office/drawing/2014/main" id="{9DEFAD9B-EA9C-49E2-835B-6C8AF6207800}"/>
               </a:ext>
             </a:extLst>
           </p:cNvPr>
@@ -2920,7 +2692,7 @@
                 <a:ea typeface="Arial"/>
                 <a:cs typeface="Arial"/>
               </a:rPr>
-              <a:t>Run these commands in a terminal on the Nano.</a:t>
+              <a:t>Run in a terminal on the Nano.</a:t>
             </a:r>
           </a:p>
         </p:txBody>
@@ -2930,64 +2702,7 @@
           <p:cNvPr id="3" name="">
             <a:extLst xmlns:a="http://schemas.openxmlformats.org/drawingml/2006/main">
               <a:ext uri="{FF2B5EF4-FFF2-40B4-BE49-F238E27FC236}">
-                <a16:creationId xmlns:a16="http://schemas.microsoft.com/office/drawing/2014/main" id="{E1B0C650-546B-4D1D-BE08-6B38301F309C}"/>
-              </a:ext>
-            </a:extLst>
-          </p:cNvPr>
-          <p:cNvSpPr>
-            <a:spLocks xmlns:a="http://schemas.openxmlformats.org/drawingml/2006/main" noGrp="1"/>
-          </p:cNvSpPr>
-          <p:nvPr/>
-        </p:nvSpPr>
-        <p:spPr>
-          <a:xfrm xmlns:a="http://schemas.openxmlformats.org/drawingml/2006/main">
-            <a:off x="666750" y="6191250"/>
-            <a:ext cx="10287000" cy="419100"/>
-          </a:xfrm>
-          <a:prstGeom xmlns:a="http://schemas.openxmlformats.org/drawingml/2006/main" prst="rect">
-            <a:avLst/>
-          </a:prstGeom>
-          <a:noFill xmlns:a="http://schemas.openxmlformats.org/drawingml/2006/main"/>
-          <a:ln xmlns:a="http://schemas.openxmlformats.org/drawingml/2006/main" w="0">
-            <a:noFill/>
-          </a:ln>
-        </p:spPr>
-        <p:txBody>
-          <a:bodyPr xmlns:a="http://schemas.openxmlformats.org/drawingml/2006/main">
-            <a:noAutofit/>
-          </a:bodyPr>
-          <a:lstStyle xmlns:a="http://schemas.openxmlformats.org/drawingml/2006/main"/>
-          <a:p xmlns:a="http://schemas.openxmlformats.org/drawingml/2006/main">
-            <a:pPr>
-              <a:defRPr sz="1350" b="0">
-                <a:solidFill>
-                  <a:srgbClr val="52635B"/>
-                </a:solidFill>
-                <a:latin typeface="Arial"/>
-                <a:ea typeface="Arial"/>
-                <a:cs typeface="Arial"/>
-              </a:defRPr>
-            </a:pPr>
-            <a:r>
-              <a:rPr sz="1350" b="0">
-                <a:solidFill>
-                  <a:srgbClr val="52635B"/>
-                </a:solidFill>
-                <a:latin typeface="Arial"/>
-                <a:ea typeface="Arial"/>
-                <a:cs typeface="Arial"/>
-              </a:rPr>
-              <a:t>Prepare once, then choose a local AI experiment by its menu number.</a:t>
-            </a:r>
-          </a:p>
-        </p:txBody>
-      </p:sp>
-      <p:sp>
-        <p:nvSpPr>
-          <p:cNvPr id="4" name="">
-            <a:extLst xmlns:a="http://schemas.openxmlformats.org/drawingml/2006/main">
-              <a:ext uri="{FF2B5EF4-FFF2-40B4-BE49-F238E27FC236}">
-                <a16:creationId xmlns:a16="http://schemas.microsoft.com/office/drawing/2014/main" id="{C884B7E3-C81E-4A04-A6E7-0C5452ABD5EB}"/>
+                <a16:creationId xmlns:a16="http://schemas.microsoft.com/office/drawing/2014/main" id="{543A3E33-311F-446A-8A07-D593FCD4D5B5}"/>
               </a:ext>
             </a:extLst>
           </p:cNvPr>
@@ -3041,10 +2756,10 @@
       </p:sp>
       <p:sp>
         <p:nvSpPr>
-          <p:cNvPr id="5" name="">
+          <p:cNvPr id="4" name="">
             <a:extLst xmlns:a="http://schemas.openxmlformats.org/drawingml/2006/main">
               <a:ext uri="{FF2B5EF4-FFF2-40B4-BE49-F238E27FC236}">
-                <a16:creationId xmlns:a16="http://schemas.microsoft.com/office/drawing/2014/main" id="{5912FAA5-619F-4479-BF73-44A2DA90D71F}"/>
+                <a16:creationId xmlns:a16="http://schemas.microsoft.com/office/drawing/2014/main" id="{CB735A41-3B9B-4339-B915-BFA2D5364F30}"/>
               </a:ext>
             </a:extLst>
           </p:cNvPr>
@@ -3098,10 +2813,10 @@
       </p:sp>
       <p:sp>
         <p:nvSpPr>
-          <p:cNvPr id="6" name="">
+          <p:cNvPr id="5" name="">
             <a:extLst xmlns:a="http://schemas.openxmlformats.org/drawingml/2006/main">
               <a:ext uri="{FF2B5EF4-FFF2-40B4-BE49-F238E27FC236}">
-                <a16:creationId xmlns:a16="http://schemas.microsoft.com/office/drawing/2014/main" id="{4DC9035A-760C-440B-BB84-4A63280DF73A}"/>
+                <a16:creationId xmlns:a16="http://schemas.microsoft.com/office/drawing/2014/main" id="{F80427A5-033C-4953-9974-A8BDEE4D9D32}"/>
               </a:ext>
             </a:extLst>
           </p:cNvPr>
@@ -3155,10 +2870,10 @@
       </p:sp>
       <p:sp>
         <p:nvSpPr>
-          <p:cNvPr id="7" name="">
+          <p:cNvPr id="6" name="">
             <a:extLst xmlns:a="http://schemas.openxmlformats.org/drawingml/2006/main">
               <a:ext uri="{FF2B5EF4-FFF2-40B4-BE49-F238E27FC236}">
-                <a16:creationId xmlns:a16="http://schemas.microsoft.com/office/drawing/2014/main" id="{BC72FDE0-176F-4EEE-9B6A-926169FE43A2}"/>
+                <a16:creationId xmlns:a16="http://schemas.microsoft.com/office/drawing/2014/main" id="{AC6588DC-384C-42A4-90FF-CDAA751CBC96}"/>
               </a:ext>
             </a:extLst>
           </p:cNvPr>
@@ -3212,10 +2927,10 @@
       </p:sp>
       <p:sp>
         <p:nvSpPr>
-          <p:cNvPr id="8" name="">
+          <p:cNvPr id="7" name="">
             <a:extLst xmlns:a="http://schemas.openxmlformats.org/drawingml/2006/main">
               <a:ext uri="{FF2B5EF4-FFF2-40B4-BE49-F238E27FC236}">
-                <a16:creationId xmlns:a16="http://schemas.microsoft.com/office/drawing/2014/main" id="{602850A4-3540-42D2-A4DE-0053D8690FA1}"/>
+                <a16:creationId xmlns:a16="http://schemas.microsoft.com/office/drawing/2014/main" id="{155AB4B2-33C6-431B-A985-B3B213A08E52}"/>
               </a:ext>
             </a:extLst>
           </p:cNvPr>
@@ -3227,7 +2942,7 @@
         <p:spPr>
           <a:xfrm xmlns:a="http://schemas.openxmlformats.org/drawingml/2006/main">
             <a:off x="742950" y="4762500"/>
-            <a:ext cx="2571750" cy="476250"/>
+            <a:ext cx="10477500" cy="476250"/>
           </a:xfrm>
           <a:prstGeom xmlns:a="http://schemas.openxmlformats.org/drawingml/2006/main" prst="rect">
             <a:avLst/>
@@ -3244,7 +2959,7 @@
           <a:lstStyle xmlns:a="http://schemas.openxmlformats.org/drawingml/2006/main"/>
           <a:p xmlns:a="http://schemas.openxmlformats.org/drawingml/2006/main">
             <a:pPr>
-              <a:defRPr sz="2175" b="1">
+              <a:defRPr sz="2025" b="0">
                 <a:solidFill>
                   <a:srgbClr val="19332A"/>
                 </a:solidFill>
@@ -3254,7 +2969,7 @@
               </a:defRPr>
             </a:pPr>
             <a:r>
-              <a:rPr sz="2175" b="1">
+              <a:rPr sz="2025" b="0">
                 <a:solidFill>
                   <a:srgbClr val="19332A"/>
                 </a:solidFill>
@@ -3262,17 +2977,17 @@
                 <a:ea typeface="Arial"/>
                 <a:cs typeface="Arial"/>
               </a:rPr>
-              <a:t>Prepare</a:t>
-            </a:r>
-          </a:p>
-        </p:txBody>
-      </p:sp>
-      <p:sp>
-        <p:nvSpPr>
-          <p:cNvPr id="9" name="">
+              <a:t>1  Install dependencies and models</a:t>
+            </a:r>
+          </a:p>
+        </p:txBody>
+      </p:sp>
+      <p:sp>
+        <p:nvSpPr>
+          <p:cNvPr id="8" name="">
             <a:extLst xmlns:a="http://schemas.openxmlformats.org/drawingml/2006/main">
               <a:ext uri="{FF2B5EF4-FFF2-40B4-BE49-F238E27FC236}">
-                <a16:creationId xmlns:a16="http://schemas.microsoft.com/office/drawing/2014/main" id="{04DC4B2D-9A69-44D8-B0B8-3F56FFB532DF}"/>
+                <a16:creationId xmlns:a16="http://schemas.microsoft.com/office/drawing/2014/main" id="{00347B2B-E400-49CE-8450-BB1614A664F7}"/>
               </a:ext>
             </a:extLst>
           </p:cNvPr>
@@ -3283,8 +2998,8 @@
         </p:nvSpPr>
         <p:spPr>
           <a:xfrm xmlns:a="http://schemas.openxmlformats.org/drawingml/2006/main">
-            <a:off x="742950" y="5248275"/>
-            <a:ext cx="2857500" cy="514350"/>
+            <a:off x="742950" y="5286375"/>
+            <a:ext cx="10477500" cy="476250"/>
           </a:xfrm>
           <a:prstGeom xmlns:a="http://schemas.openxmlformats.org/drawingml/2006/main" prst="rect">
             <a:avLst/>
@@ -3301,9 +3016,9 @@
           <a:lstStyle xmlns:a="http://schemas.openxmlformats.org/drawingml/2006/main"/>
           <a:p xmlns:a="http://schemas.openxmlformats.org/drawingml/2006/main">
             <a:pPr>
-              <a:defRPr sz="1800" b="0">
-                <a:solidFill>
-                  <a:srgbClr val="52635B"/>
+              <a:defRPr sz="2025" b="0">
+                <a:solidFill>
+                  <a:srgbClr val="19332A"/>
                 </a:solidFill>
                 <a:latin typeface="Arial"/>
                 <a:ea typeface="Arial"/>
@@ -3311,243 +3026,15 @@
               </a:defRPr>
             </a:pPr>
             <a:r>
-              <a:rPr sz="1800" b="0">
-                <a:solidFill>
-                  <a:srgbClr val="52635B"/>
+              <a:rPr sz="2025" b="0">
+                <a:solidFill>
+                  <a:srgbClr val="19332A"/>
                 </a:solidFill>
                 <a:latin typeface="Arial"/>
                 <a:ea typeface="Arial"/>
                 <a:cs typeface="Arial"/>
               </a:rPr>
-              <a:t>Choose 1 before class.</a:t>
-            </a:r>
-          </a:p>
-        </p:txBody>
-      </p:sp>
-      <p:sp>
-        <p:nvSpPr>
-          <p:cNvPr id="10" name="">
-            <a:extLst xmlns:a="http://schemas.openxmlformats.org/drawingml/2006/main">
-              <a:ext uri="{FF2B5EF4-FFF2-40B4-BE49-F238E27FC236}">
-                <a16:creationId xmlns:a16="http://schemas.microsoft.com/office/drawing/2014/main" id="{C2D2093F-4752-4CF0-815C-EB24FDB90871}"/>
-              </a:ext>
-            </a:extLst>
-          </p:cNvPr>
-          <p:cNvSpPr>
-            <a:spLocks xmlns:a="http://schemas.openxmlformats.org/drawingml/2006/main" noGrp="1"/>
-          </p:cNvSpPr>
-          <p:nvPr/>
-        </p:nvSpPr>
-        <p:spPr>
-          <a:xfrm xmlns:a="http://schemas.openxmlformats.org/drawingml/2006/main">
-            <a:off x="4314825" y="4762500"/>
-            <a:ext cx="2571750" cy="476250"/>
-          </a:xfrm>
-          <a:prstGeom xmlns:a="http://schemas.openxmlformats.org/drawingml/2006/main" prst="rect">
-            <a:avLst/>
-          </a:prstGeom>
-          <a:noFill xmlns:a="http://schemas.openxmlformats.org/drawingml/2006/main"/>
-          <a:ln xmlns:a="http://schemas.openxmlformats.org/drawingml/2006/main" w="0">
-            <a:noFill/>
-          </a:ln>
-        </p:spPr>
-        <p:txBody>
-          <a:bodyPr xmlns:a="http://schemas.openxmlformats.org/drawingml/2006/main">
-            <a:noAutofit/>
-          </a:bodyPr>
-          <a:lstStyle xmlns:a="http://schemas.openxmlformats.org/drawingml/2006/main"/>
-          <a:p xmlns:a="http://schemas.openxmlformats.org/drawingml/2006/main">
-            <a:pPr>
-              <a:defRPr sz="2175" b="1">
-                <a:solidFill>
-                  <a:srgbClr val="19332A"/>
-                </a:solidFill>
-                <a:latin typeface="Arial"/>
-                <a:ea typeface="Arial"/>
-                <a:cs typeface="Arial"/>
-              </a:defRPr>
-            </a:pPr>
-            <a:r>
-              <a:rPr sz="2175" b="1">
-                <a:solidFill>
-                  <a:srgbClr val="19332A"/>
-                </a:solidFill>
-                <a:latin typeface="Arial"/>
-                <a:ea typeface="Arial"/>
-                <a:cs typeface="Arial"/>
-              </a:rPr>
-              <a:t>Check</a:t>
-            </a:r>
-          </a:p>
-        </p:txBody>
-      </p:sp>
-      <p:sp>
-        <p:nvSpPr>
-          <p:cNvPr id="11" name="">
-            <a:extLst xmlns:a="http://schemas.openxmlformats.org/drawingml/2006/main">
-              <a:ext uri="{FF2B5EF4-FFF2-40B4-BE49-F238E27FC236}">
-                <a16:creationId xmlns:a16="http://schemas.microsoft.com/office/drawing/2014/main" id="{7668139E-4F1C-4FDB-ACC2-6D2F707743FF}"/>
-              </a:ext>
-            </a:extLst>
-          </p:cNvPr>
-          <p:cNvSpPr>
-            <a:spLocks xmlns:a="http://schemas.openxmlformats.org/drawingml/2006/main" noGrp="1"/>
-          </p:cNvSpPr>
-          <p:nvPr/>
-        </p:nvSpPr>
-        <p:spPr>
-          <a:xfrm xmlns:a="http://schemas.openxmlformats.org/drawingml/2006/main">
-            <a:off x="4314825" y="5248275"/>
-            <a:ext cx="3048000" cy="514350"/>
-          </a:xfrm>
-          <a:prstGeom xmlns:a="http://schemas.openxmlformats.org/drawingml/2006/main" prst="rect">
-            <a:avLst/>
-          </a:prstGeom>
-          <a:noFill xmlns:a="http://schemas.openxmlformats.org/drawingml/2006/main"/>
-          <a:ln xmlns:a="http://schemas.openxmlformats.org/drawingml/2006/main" w="0">
-            <a:noFill/>
-          </a:ln>
-        </p:spPr>
-        <p:txBody>
-          <a:bodyPr xmlns:a="http://schemas.openxmlformats.org/drawingml/2006/main">
-            <a:noAutofit/>
-          </a:bodyPr>
-          <a:lstStyle xmlns:a="http://schemas.openxmlformats.org/drawingml/2006/main"/>
-          <a:p xmlns:a="http://schemas.openxmlformats.org/drawingml/2006/main">
-            <a:pPr>
-              <a:defRPr sz="1800" b="0">
-                <a:solidFill>
-                  <a:srgbClr val="52635B"/>
-                </a:solidFill>
-                <a:latin typeface="Arial"/>
-                <a:ea typeface="Arial"/>
-                <a:cs typeface="Arial"/>
-              </a:defRPr>
-            </a:pPr>
-            <a:r>
-              <a:rPr sz="1800" b="0">
-                <a:solidFill>
-                  <a:srgbClr val="52635B"/>
-                </a:solidFill>
-                <a:latin typeface="Arial"/>
-                <a:ea typeface="Arial"/>
-                <a:cs typeface="Arial"/>
-              </a:rPr>
-              <a:t>Choose 2 for board status.</a:t>
-            </a:r>
-          </a:p>
-        </p:txBody>
-      </p:sp>
-      <p:sp>
-        <p:nvSpPr>
-          <p:cNvPr id="12" name="">
-            <a:extLst xmlns:a="http://schemas.openxmlformats.org/drawingml/2006/main">
-              <a:ext uri="{FF2B5EF4-FFF2-40B4-BE49-F238E27FC236}">
-                <a16:creationId xmlns:a16="http://schemas.microsoft.com/office/drawing/2014/main" id="{EA006D79-F7E9-4330-ADF8-EFA14E2A90F5}"/>
-              </a:ext>
-            </a:extLst>
-          </p:cNvPr>
-          <p:cNvSpPr>
-            <a:spLocks xmlns:a="http://schemas.openxmlformats.org/drawingml/2006/main" noGrp="1"/>
-          </p:cNvSpPr>
-          <p:nvPr/>
-        </p:nvSpPr>
-        <p:spPr>
-          <a:xfrm xmlns:a="http://schemas.openxmlformats.org/drawingml/2006/main">
-            <a:off x="8039100" y="4762500"/>
-            <a:ext cx="3143250" cy="476250"/>
-          </a:xfrm>
-          <a:prstGeom xmlns:a="http://schemas.openxmlformats.org/drawingml/2006/main" prst="rect">
-            <a:avLst/>
-          </a:prstGeom>
-          <a:noFill xmlns:a="http://schemas.openxmlformats.org/drawingml/2006/main"/>
-          <a:ln xmlns:a="http://schemas.openxmlformats.org/drawingml/2006/main" w="0">
-            <a:noFill/>
-          </a:ln>
-        </p:spPr>
-        <p:txBody>
-          <a:bodyPr xmlns:a="http://schemas.openxmlformats.org/drawingml/2006/main">
-            <a:noAutofit/>
-          </a:bodyPr>
-          <a:lstStyle xmlns:a="http://schemas.openxmlformats.org/drawingml/2006/main"/>
-          <a:p xmlns:a="http://schemas.openxmlformats.org/drawingml/2006/main">
-            <a:pPr>
-              <a:defRPr sz="2175" b="1">
-                <a:solidFill>
-                  <a:srgbClr val="19332A"/>
-                </a:solidFill>
-                <a:latin typeface="Arial"/>
-                <a:ea typeface="Arial"/>
-                <a:cs typeface="Arial"/>
-              </a:defRPr>
-            </a:pPr>
-            <a:r>
-              <a:rPr sz="2175" b="1">
-                <a:solidFill>
-                  <a:srgbClr val="19332A"/>
-                </a:solidFill>
-                <a:latin typeface="Arial"/>
-                <a:ea typeface="Arial"/>
-                <a:cs typeface="Arial"/>
-              </a:rPr>
-              <a:t>Explore</a:t>
-            </a:r>
-          </a:p>
-        </p:txBody>
-      </p:sp>
-      <p:sp>
-        <p:nvSpPr>
-          <p:cNvPr id="13" name="">
-            <a:extLst xmlns:a="http://schemas.openxmlformats.org/drawingml/2006/main">
-              <a:ext uri="{FF2B5EF4-FFF2-40B4-BE49-F238E27FC236}">
-                <a16:creationId xmlns:a16="http://schemas.microsoft.com/office/drawing/2014/main" id="{5CD72529-7107-455A-A1DC-6269ABD027E5}"/>
-              </a:ext>
-            </a:extLst>
-          </p:cNvPr>
-          <p:cNvSpPr>
-            <a:spLocks xmlns:a="http://schemas.openxmlformats.org/drawingml/2006/main" noGrp="1"/>
-          </p:cNvSpPr>
-          <p:nvPr/>
-        </p:nvSpPr>
-        <p:spPr>
-          <a:xfrm xmlns:a="http://schemas.openxmlformats.org/drawingml/2006/main">
-            <a:off x="8039100" y="5248275"/>
-            <a:ext cx="3333750" cy="619125"/>
-          </a:xfrm>
-          <a:prstGeom xmlns:a="http://schemas.openxmlformats.org/drawingml/2006/main" prst="rect">
-            <a:avLst/>
-          </a:prstGeom>
-          <a:noFill xmlns:a="http://schemas.openxmlformats.org/drawingml/2006/main"/>
-          <a:ln xmlns:a="http://schemas.openxmlformats.org/drawingml/2006/main" w="0">
-            <a:noFill/>
-          </a:ln>
-        </p:spPr>
-        <p:txBody>
-          <a:bodyPr xmlns:a="http://schemas.openxmlformats.org/drawingml/2006/main">
-            <a:noAutofit/>
-          </a:bodyPr>
-          <a:lstStyle xmlns:a="http://schemas.openxmlformats.org/drawingml/2006/main"/>
-          <a:p xmlns:a="http://schemas.openxmlformats.org/drawingml/2006/main">
-            <a:pPr>
-              <a:defRPr sz="1800" b="0">
-                <a:solidFill>
-                  <a:srgbClr val="52635B"/>
-                </a:solidFill>
-                <a:latin typeface="Arial"/>
-                <a:ea typeface="Arial"/>
-                <a:cs typeface="Arial"/>
-              </a:defRPr>
-            </a:pPr>
-            <a:r>
-              <a:rPr sz="1800" b="0">
-                <a:solidFill>
-                  <a:srgbClr val="52635B"/>
-                </a:solidFill>
-                <a:latin typeface="Arial"/>
-                <a:ea typeface="Arial"/>
-                <a:cs typeface="Arial"/>
-              </a:rPr>
-              <a:t>Select any experiment number.</a:t>
+              <a:t>2  Check board status</a:t>
             </a:r>
           </a:p>
         </p:txBody>
@@ -3555,7 +3042,7 @@
     </p:spTree>
     <p:extLst>
       <p:ext uri="{BB962C8B-B14F-4D97-AF65-F5344CB8AC3E}">
-        <p14:creationId xmlns:p14="http://schemas.microsoft.com/office/powerpoint/2010/main" val="801142662"/>
+        <p14:creationId xmlns:p14="http://schemas.microsoft.com/office/powerpoint/2010/main" val="2007947025"/>
       </p:ext>
     </p:extLst>
   </p:cSld>
@@ -3583,10 +3070,10 @@
       </p:grpSpPr>
       <p:sp>
         <p:nvSpPr>
-          <p:cNvPr id="13" name="">
+          <p:cNvPr id="11" name="">
             <a:extLst xmlns:a="http://schemas.openxmlformats.org/drawingml/2006/main">
               <a:ext uri="{FF2B5EF4-FFF2-40B4-BE49-F238E27FC236}">
-                <a16:creationId xmlns:a16="http://schemas.microsoft.com/office/drawing/2014/main" id="{250E9F42-3427-4566-BB27-DA649C0919D7}"/>
+                <a16:creationId xmlns:a16="http://schemas.microsoft.com/office/drawing/2014/main" id="{4AC87039-7F5B-48EC-9B63-57BCF45BEFBB}"/>
               </a:ext>
             </a:extLst>
           </p:cNvPr>
@@ -3633,7 +3120,7 @@
                 <a:ea typeface="Arial"/>
                 <a:cs typeface="Arial"/>
               </a:rPr>
-              <a:t>Conversations that involve the class</a:t>
+              <a:t>Text Conversations</a:t>
             </a:r>
           </a:p>
         </p:txBody>
@@ -3643,121 +3130,7 @@
           <p:cNvPr id="2" name="">
             <a:extLst xmlns:a="http://schemas.openxmlformats.org/drawingml/2006/main">
               <a:ext uri="{FF2B5EF4-FFF2-40B4-BE49-F238E27FC236}">
-                <a16:creationId xmlns:a16="http://schemas.microsoft.com/office/drawing/2014/main" id="{2D4EA3AB-3FD3-415A-A1CB-102F550EC9A8}"/>
-              </a:ext>
-            </a:extLst>
-          </p:cNvPr>
-          <p:cNvSpPr>
-            <a:spLocks xmlns:a="http://schemas.openxmlformats.org/drawingml/2006/main" noGrp="1"/>
-          </p:cNvSpPr>
-          <p:nvPr/>
-        </p:nvSpPr>
-        <p:spPr>
-          <a:xfrm xmlns:a="http://schemas.openxmlformats.org/drawingml/2006/main">
-            <a:off x="666750" y="1333500"/>
-            <a:ext cx="10858500" cy="619125"/>
-          </a:xfrm>
-          <a:prstGeom xmlns:a="http://schemas.openxmlformats.org/drawingml/2006/main" prst="rect">
-            <a:avLst/>
-          </a:prstGeom>
-          <a:noFill xmlns:a="http://schemas.openxmlformats.org/drawingml/2006/main"/>
-          <a:ln xmlns:a="http://schemas.openxmlformats.org/drawingml/2006/main" w="0">
-            <a:noFill/>
-          </a:ln>
-        </p:spPr>
-        <p:txBody>
-          <a:bodyPr xmlns:a="http://schemas.openxmlformats.org/drawingml/2006/main">
-            <a:noAutofit/>
-          </a:bodyPr>
-          <a:lstStyle xmlns:a="http://schemas.openxmlformats.org/drawingml/2006/main"/>
-          <a:p xmlns:a="http://schemas.openxmlformats.org/drawingml/2006/main">
-            <a:pPr>
-              <a:defRPr sz="1950" b="0">
-                <a:solidFill>
-                  <a:srgbClr val="52635B"/>
-                </a:solidFill>
-                <a:latin typeface="Arial"/>
-                <a:ea typeface="Arial"/>
-                <a:cs typeface="Arial"/>
-              </a:defRPr>
-            </a:pPr>
-            <a:r>
-              <a:rPr sz="1950" b="0">
-                <a:solidFill>
-                  <a:srgbClr val="52635B"/>
-                </a:solidFill>
-                <a:latin typeface="Arial"/>
-                <a:ea typeface="Arial"/>
-                <a:cs typeface="Arial"/>
-              </a:rPr>
-              <a:t>Students take the next turn and shape what happens.</a:t>
-            </a:r>
-          </a:p>
-        </p:txBody>
-      </p:sp>
-      <p:sp>
-        <p:nvSpPr>
-          <p:cNvPr id="3" name="">
-            <a:extLst xmlns:a="http://schemas.openxmlformats.org/drawingml/2006/main">
-              <a:ext uri="{FF2B5EF4-FFF2-40B4-BE49-F238E27FC236}">
-                <a16:creationId xmlns:a16="http://schemas.microsoft.com/office/drawing/2014/main" id="{0D195F22-FDBC-4B14-AD10-B623A09107B5}"/>
-              </a:ext>
-            </a:extLst>
-          </p:cNvPr>
-          <p:cNvSpPr>
-            <a:spLocks xmlns:a="http://schemas.openxmlformats.org/drawingml/2006/main" noGrp="1"/>
-          </p:cNvSpPr>
-          <p:nvPr/>
-        </p:nvSpPr>
-        <p:spPr>
-          <a:xfrm xmlns:a="http://schemas.openxmlformats.org/drawingml/2006/main">
-            <a:off x="666750" y="6191250"/>
-            <a:ext cx="10287000" cy="419100"/>
-          </a:xfrm>
-          <a:prstGeom xmlns:a="http://schemas.openxmlformats.org/drawingml/2006/main" prst="rect">
-            <a:avLst/>
-          </a:prstGeom>
-          <a:noFill xmlns:a="http://schemas.openxmlformats.org/drawingml/2006/main"/>
-          <a:ln xmlns:a="http://schemas.openxmlformats.org/drawingml/2006/main" w="0">
-            <a:noFill/>
-          </a:ln>
-        </p:spPr>
-        <p:txBody>
-          <a:bodyPr xmlns:a="http://schemas.openxmlformats.org/drawingml/2006/main">
-            <a:noAutofit/>
-          </a:bodyPr>
-          <a:lstStyle xmlns:a="http://schemas.openxmlformats.org/drawingml/2006/main"/>
-          <a:p xmlns:a="http://schemas.openxmlformats.org/drawingml/2006/main">
-            <a:pPr>
-              <a:defRPr sz="1350" b="0">
-                <a:solidFill>
-                  <a:srgbClr val="52635B"/>
-                </a:solidFill>
-                <a:latin typeface="Arial"/>
-                <a:ea typeface="Arial"/>
-                <a:cs typeface="Arial"/>
-              </a:defRPr>
-            </a:pPr>
-            <a:r>
-              <a:rPr sz="1350" b="0">
-                <a:solidFill>
-                  <a:srgbClr val="52635B"/>
-                </a:solidFill>
-                <a:latin typeface="Arial"/>
-                <a:ea typeface="Arial"/>
-                <a:cs typeface="Arial"/>
-              </a:rPr>
-              <a:t>Type /quit to return to the menu. Each conversation uses the earlier turns.</a:t>
-            </a:r>
-          </a:p>
-        </p:txBody>
-      </p:sp>
-      <p:sp>
-        <p:nvSpPr>
-          <p:cNvPr id="4" name="">
-            <a:extLst xmlns:a="http://schemas.openxmlformats.org/drawingml/2006/main">
-              <a:ext uri="{FF2B5EF4-FFF2-40B4-BE49-F238E27FC236}">
-                <a16:creationId xmlns:a16="http://schemas.microsoft.com/office/drawing/2014/main" id="{D951B7C6-896E-445F-883B-194538FD62BD}"/>
+                <a16:creationId xmlns:a16="http://schemas.microsoft.com/office/drawing/2014/main" id="{03901629-1E3B-464A-91E5-3B0E2ADCD24F}"/>
               </a:ext>
             </a:extLst>
           </p:cNvPr>
@@ -3811,10 +3184,10 @@
       </p:sp>
       <p:sp>
         <p:nvSpPr>
-          <p:cNvPr id="5" name="">
+          <p:cNvPr id="3" name="">
             <a:extLst xmlns:a="http://schemas.openxmlformats.org/drawingml/2006/main">
               <a:ext uri="{FF2B5EF4-FFF2-40B4-BE49-F238E27FC236}">
-                <a16:creationId xmlns:a16="http://schemas.microsoft.com/office/drawing/2014/main" id="{457974C2-9E85-4C7E-B2F1-6294349D8F0C}"/>
+                <a16:creationId xmlns:a16="http://schemas.microsoft.com/office/drawing/2014/main" id="{6B936980-4351-484B-9DED-4303BE82EDA9}"/>
               </a:ext>
             </a:extLst>
           </p:cNvPr>
@@ -3861,17 +3234,17 @@
                 <a:ea typeface="Arial"/>
                 <a:cs typeface="Arial"/>
               </a:rPr>
-              <a:t>Experiment 29</a:t>
-            </a:r>
-          </a:p>
-        </p:txBody>
-      </p:sp>
-      <p:sp>
-        <p:nvSpPr>
-          <p:cNvPr id="6" name="">
+              <a:t>Menu 29</a:t>
+            </a:r>
+          </a:p>
+        </p:txBody>
+      </p:sp>
+      <p:sp>
+        <p:nvSpPr>
+          <p:cNvPr id="4" name="">
             <a:extLst xmlns:a="http://schemas.openxmlformats.org/drawingml/2006/main">
               <a:ext uri="{FF2B5EF4-FFF2-40B4-BE49-F238E27FC236}">
-                <a16:creationId xmlns:a16="http://schemas.microsoft.com/office/drawing/2014/main" id="{BAC11B37-8E08-4BDC-981F-A44250A289D1}"/>
+                <a16:creationId xmlns:a16="http://schemas.microsoft.com/office/drawing/2014/main" id="{4E06C31A-0732-47E2-AB49-72A490D3D9AB}"/>
               </a:ext>
             </a:extLst>
           </p:cNvPr>
@@ -3925,10 +3298,10 @@
       </p:sp>
       <p:sp>
         <p:nvSpPr>
-          <p:cNvPr id="7" name="">
+          <p:cNvPr id="5" name="">
             <a:extLst xmlns:a="http://schemas.openxmlformats.org/drawingml/2006/main">
               <a:ext uri="{FF2B5EF4-FFF2-40B4-BE49-F238E27FC236}">
-                <a16:creationId xmlns:a16="http://schemas.microsoft.com/office/drawing/2014/main" id="{C380692F-1154-4B3C-A589-3D70670AD934}"/>
+                <a16:creationId xmlns:a16="http://schemas.microsoft.com/office/drawing/2014/main" id="{2C542239-7195-47F7-9ED4-F9634068C055}"/>
               </a:ext>
             </a:extLst>
           </p:cNvPr>
@@ -3975,7 +3348,7 @@
                 <a:ea typeface="Arial"/>
                 <a:cs typeface="Arial"/>
               </a:rPr>
-              <a:t>Choose a topic. Answer one guiding</a:t>
+              <a:t>Discuss a topic through successive</a:t>
             </a:r>
           </a:p>
           <a:p xmlns:a="http://schemas.openxmlformats.org/drawingml/2006/main">
@@ -3998,7 +3371,7 @@
                 <a:ea typeface="Arial"/>
                 <a:cs typeface="Arial"/>
               </a:rPr>
-              <a:t>question at a time and explain</a:t>
+              <a:t>questions. Each reply uses the</a:t>
             </a:r>
           </a:p>
           <a:p xmlns:a="http://schemas.openxmlformats.org/drawingml/2006/main">
@@ -4021,17 +3394,17 @@
                 <a:ea typeface="Arial"/>
                 <a:cs typeface="Arial"/>
               </a:rPr>
-              <a:t>your reasoning.</a:t>
-            </a:r>
-          </a:p>
-        </p:txBody>
-      </p:sp>
-      <p:sp>
-        <p:nvSpPr>
-          <p:cNvPr id="8" name="">
+              <a:t>previous conversation.</a:t>
+            </a:r>
+          </a:p>
+        </p:txBody>
+      </p:sp>
+      <p:sp>
+        <p:nvSpPr>
+          <p:cNvPr id="6" name="">
             <a:extLst xmlns:a="http://schemas.openxmlformats.org/drawingml/2006/main">
               <a:ext uri="{FF2B5EF4-FFF2-40B4-BE49-F238E27FC236}">
-                <a16:creationId xmlns:a16="http://schemas.microsoft.com/office/drawing/2014/main" id="{304F5F94-9507-4599-A6F8-BA11F7F51092}"/>
+                <a16:creationId xmlns:a16="http://schemas.microsoft.com/office/drawing/2014/main" id="{ED401F0E-CF45-413D-A70A-9BF389C8CE3B}"/>
               </a:ext>
             </a:extLst>
           </p:cNvPr>
@@ -4078,17 +3451,17 @@
                 <a:ea typeface="Arial"/>
                 <a:cs typeface="Arial"/>
               </a:rPr>
-              <a:t>Try: Why do objects float?</a:t>
-            </a:r>
-          </a:p>
-        </p:txBody>
-      </p:sp>
-      <p:sp>
-        <p:nvSpPr>
-          <p:cNvPr id="9" name="">
+              <a:t>Example topic: Why do objects float?</a:t>
+            </a:r>
+          </a:p>
+        </p:txBody>
+      </p:sp>
+      <p:sp>
+        <p:nvSpPr>
+          <p:cNvPr id="7" name="">
             <a:extLst xmlns:a="http://schemas.openxmlformats.org/drawingml/2006/main">
               <a:ext uri="{FF2B5EF4-FFF2-40B4-BE49-F238E27FC236}">
-                <a16:creationId xmlns:a16="http://schemas.microsoft.com/office/drawing/2014/main" id="{123D050F-184F-4014-895D-4A5E890F68C9}"/>
+                <a16:creationId xmlns:a16="http://schemas.microsoft.com/office/drawing/2014/main" id="{57D8FDF0-DD92-4EC0-A255-BA1D0129088E}"/>
               </a:ext>
             </a:extLst>
           </p:cNvPr>
@@ -4135,17 +3508,17 @@
                 <a:ea typeface="Arial"/>
                 <a:cs typeface="Arial"/>
               </a:rPr>
-              <a:t>Experiment 30</a:t>
-            </a:r>
-          </a:p>
-        </p:txBody>
-      </p:sp>
-      <p:sp>
-        <p:nvSpPr>
-          <p:cNvPr id="10" name="">
+              <a:t>Menu 30</a:t>
+            </a:r>
+          </a:p>
+        </p:txBody>
+      </p:sp>
+      <p:sp>
+        <p:nvSpPr>
+          <p:cNvPr id="8" name="">
             <a:extLst xmlns:a="http://schemas.openxmlformats.org/drawingml/2006/main">
               <a:ext uri="{FF2B5EF4-FFF2-40B4-BE49-F238E27FC236}">
-                <a16:creationId xmlns:a16="http://schemas.microsoft.com/office/drawing/2014/main" id="{AC41D485-7B2D-4A2C-B4D9-D0AD381F3642}"/>
+                <a16:creationId xmlns:a16="http://schemas.microsoft.com/office/drawing/2014/main" id="{A6C12A4C-6DAF-45CB-9B52-BF958DFF65BC}"/>
               </a:ext>
             </a:extLst>
           </p:cNvPr>
@@ -4222,10 +3595,10 @@
       </p:sp>
       <p:sp>
         <p:nvSpPr>
-          <p:cNvPr id="11" name="">
+          <p:cNvPr id="9" name="">
             <a:extLst xmlns:a="http://schemas.openxmlformats.org/drawingml/2006/main">
               <a:ext uri="{FF2B5EF4-FFF2-40B4-BE49-F238E27FC236}">
-                <a16:creationId xmlns:a16="http://schemas.microsoft.com/office/drawing/2014/main" id="{F0862BC0-C5D8-4535-822C-534EF85EC51C}"/>
+                <a16:creationId xmlns:a16="http://schemas.microsoft.com/office/drawing/2014/main" id="{FAE7DF16-2C10-4EAB-89DC-E4630584C3EC}"/>
               </a:ext>
             </a:extLst>
           </p:cNvPr>
@@ -4272,7 +3645,7 @@
                 <a:ea typeface="Arial"/>
                 <a:cs typeface="Arial"/>
               </a:rPr>
-              <a:t>Interview a fictional character.</a:t>
+              <a:t>Ask a fictional character questions</a:t>
             </a:r>
           </a:p>
           <a:p xmlns:a="http://schemas.openxmlformats.org/drawingml/2006/main">
@@ -4295,7 +3668,7 @@
                 <a:ea typeface="Arial"/>
                 <a:cs typeface="Arial"/>
               </a:rPr>
-              <a:t>Collect clues, then guess</a:t>
+              <a:t>and use the answers to identify</a:t>
             </a:r>
           </a:p>
           <a:p xmlns:a="http://schemas.openxmlformats.org/drawingml/2006/main">
@@ -4325,10 +3698,10 @@
       </p:sp>
       <p:sp>
         <p:nvSpPr>
-          <p:cNvPr id="12" name="">
+          <p:cNvPr id="10" name="">
             <a:extLst xmlns:a="http://schemas.openxmlformats.org/drawingml/2006/main">
               <a:ext uri="{FF2B5EF4-FFF2-40B4-BE49-F238E27FC236}">
-                <a16:creationId xmlns:a16="http://schemas.microsoft.com/office/drawing/2014/main" id="{52C5A8BD-BFA7-4E3D-90D8-6C0B0FBDF60E}"/>
+                <a16:creationId xmlns:a16="http://schemas.microsoft.com/office/drawing/2014/main" id="{B88BFAB4-04E5-4039-8DF7-32CF2FA641D2}"/>
               </a:ext>
             </a:extLst>
           </p:cNvPr>
@@ -4383,7 +3756,7 @@
     </p:spTree>
     <p:extLst>
       <p:ext uri="{BB962C8B-B14F-4D97-AF65-F5344CB8AC3E}">
-        <p14:creationId xmlns:p14="http://schemas.microsoft.com/office/powerpoint/2010/main" val="1879518823"/>
+        <p14:creationId xmlns:p14="http://schemas.microsoft.com/office/powerpoint/2010/main" val="261506530"/>
       </p:ext>
     </p:extLst>
   </p:cSld>
@@ -4411,10 +3784,10 @@
       </p:grpSpPr>
       <p:sp>
         <p:nvSpPr>
-          <p:cNvPr id="6" name="">
+          <p:cNvPr id="4" name="">
             <a:extLst xmlns:a="http://schemas.openxmlformats.org/drawingml/2006/main">
               <a:ext uri="{FF2B5EF4-FFF2-40B4-BE49-F238E27FC236}">
-                <a16:creationId xmlns:a16="http://schemas.microsoft.com/office/drawing/2014/main" id="{876B20AC-5C7D-4C7F-92F9-18CFC195FDD2}"/>
+                <a16:creationId xmlns:a16="http://schemas.microsoft.com/office/drawing/2014/main" id="{53BF914D-8325-482A-896F-AC665794C31C}"/>
               </a:ext>
             </a:extLst>
           </p:cNvPr>
@@ -4461,7 +3834,7 @@
                 <a:ea typeface="Arial"/>
                 <a:cs typeface="Arial"/>
               </a:rPr>
-              <a:t>Assistants with visible evidence</a:t>
+              <a:t>Tools and Document Retrieval</a:t>
             </a:r>
           </a:p>
         </p:txBody>
@@ -4471,121 +3844,7 @@
           <p:cNvPr id="2" name="">
             <a:extLst xmlns:a="http://schemas.openxmlformats.org/drawingml/2006/main">
               <a:ext uri="{FF2B5EF4-FFF2-40B4-BE49-F238E27FC236}">
-                <a16:creationId xmlns:a16="http://schemas.microsoft.com/office/drawing/2014/main" id="{7FCA11F6-C36A-447C-8D79-E1F7CFF49C50}"/>
-              </a:ext>
-            </a:extLst>
-          </p:cNvPr>
-          <p:cNvSpPr>
-            <a:spLocks xmlns:a="http://schemas.openxmlformats.org/drawingml/2006/main" noGrp="1"/>
-          </p:cNvSpPr>
-          <p:nvPr/>
-        </p:nvSpPr>
-        <p:spPr>
-          <a:xfrm xmlns:a="http://schemas.openxmlformats.org/drawingml/2006/main">
-            <a:off x="666750" y="1333500"/>
-            <a:ext cx="10858500" cy="619125"/>
-          </a:xfrm>
-          <a:prstGeom xmlns:a="http://schemas.openxmlformats.org/drawingml/2006/main" prst="rect">
-            <a:avLst/>
-          </a:prstGeom>
-          <a:noFill xmlns:a="http://schemas.openxmlformats.org/drawingml/2006/main"/>
-          <a:ln xmlns:a="http://schemas.openxmlformats.org/drawingml/2006/main" w="0">
-            <a:noFill/>
-          </a:ln>
-        </p:spPr>
-        <p:txBody>
-          <a:bodyPr xmlns:a="http://schemas.openxmlformats.org/drawingml/2006/main">
-            <a:noAutofit/>
-          </a:bodyPr>
-          <a:lstStyle xmlns:a="http://schemas.openxmlformats.org/drawingml/2006/main"/>
-          <a:p xmlns:a="http://schemas.openxmlformats.org/drawingml/2006/main">
-            <a:pPr>
-              <a:defRPr sz="1950" b="0">
-                <a:solidFill>
-                  <a:srgbClr val="52635B"/>
-                </a:solidFill>
-                <a:latin typeface="Arial"/>
-                <a:ea typeface="Arial"/>
-                <a:cs typeface="Arial"/>
-              </a:defRPr>
-            </a:pPr>
-            <a:r>
-              <a:rPr sz="1950" b="0">
-                <a:solidFill>
-                  <a:srgbClr val="52635B"/>
-                </a:solidFill>
-                <a:latin typeface="Arial"/>
-                <a:ea typeface="Arial"/>
-                <a:cs typeface="Arial"/>
-              </a:rPr>
-              <a:t>Inspect what the model knows, retrieves and calls.</a:t>
-            </a:r>
-          </a:p>
-        </p:txBody>
-      </p:sp>
-      <p:sp>
-        <p:nvSpPr>
-          <p:cNvPr id="3" name="">
-            <a:extLst xmlns:a="http://schemas.openxmlformats.org/drawingml/2006/main">
-              <a:ext uri="{FF2B5EF4-FFF2-40B4-BE49-F238E27FC236}">
-                <a16:creationId xmlns:a16="http://schemas.microsoft.com/office/drawing/2014/main" id="{7FD4D6CD-BCCF-4117-86AA-F5841D2DB4EB}"/>
-              </a:ext>
-            </a:extLst>
-          </p:cNvPr>
-          <p:cNvSpPr>
-            <a:spLocks xmlns:a="http://schemas.openxmlformats.org/drawingml/2006/main" noGrp="1"/>
-          </p:cNvSpPr>
-          <p:nvPr/>
-        </p:nvSpPr>
-        <p:spPr>
-          <a:xfrm xmlns:a="http://schemas.openxmlformats.org/drawingml/2006/main">
-            <a:off x="666750" y="6191250"/>
-            <a:ext cx="10287000" cy="419100"/>
-          </a:xfrm>
-          <a:prstGeom xmlns:a="http://schemas.openxmlformats.org/drawingml/2006/main" prst="rect">
-            <a:avLst/>
-          </a:prstGeom>
-          <a:noFill xmlns:a="http://schemas.openxmlformats.org/drawingml/2006/main"/>
-          <a:ln xmlns:a="http://schemas.openxmlformats.org/drawingml/2006/main" w="0">
-            <a:noFill/>
-          </a:ln>
-        </p:spPr>
-        <p:txBody>
-          <a:bodyPr xmlns:a="http://schemas.openxmlformats.org/drawingml/2006/main">
-            <a:noAutofit/>
-          </a:bodyPr>
-          <a:lstStyle xmlns:a="http://schemas.openxmlformats.org/drawingml/2006/main"/>
-          <a:p xmlns:a="http://schemas.openxmlformats.org/drawingml/2006/main">
-            <a:pPr>
-              <a:defRPr sz="1350" b="0">
-                <a:solidFill>
-                  <a:srgbClr val="52635B"/>
-                </a:solidFill>
-                <a:latin typeface="Arial"/>
-                <a:ea typeface="Arial"/>
-                <a:cs typeface="Arial"/>
-              </a:defRPr>
-            </a:pPr>
-            <a:r>
-              <a:rPr sz="1350" b="0">
-                <a:solidFill>
-                  <a:srgbClr val="52635B"/>
-                </a:solidFill>
-                <a:latin typeface="Arial"/>
-                <a:ea typeface="Arial"/>
-                <a:cs typeface="Arial"/>
-              </a:rPr>
-              <a:t>Read-only tools. Explicit local memory. BM25 retrieval over your own documents.</a:t>
-            </a:r>
-          </a:p>
-        </p:txBody>
-      </p:sp>
-      <p:sp>
-        <p:nvSpPr>
-          <p:cNvPr id="4" name="">
-            <a:extLst xmlns:a="http://schemas.openxmlformats.org/drawingml/2006/main">
-              <a:ext uri="{FF2B5EF4-FFF2-40B4-BE49-F238E27FC236}">
-                <a16:creationId xmlns:a16="http://schemas.microsoft.com/office/drawing/2014/main" id="{431F1BC3-6AD8-48B9-B4AC-CAF1DB19ACF0}"/>
+                <a16:creationId xmlns:a16="http://schemas.microsoft.com/office/drawing/2014/main" id="{6B286F56-7B2C-44A9-BC3E-031452F8BAE2}"/>
               </a:ext>
             </a:extLst>
           </p:cNvPr>
@@ -4639,7 +3898,7 @@
       </p:sp>
       <p:graphicFrame>
         <p:nvGraphicFramePr>
-          <p:cNvPr id="10" name=""/>
+          <p:cNvPr id="6" name=""/>
           <p:cNvGraphicFramePr/>
           <p:nvPr/>
         </p:nvGraphicFramePr>
@@ -4725,7 +3984,7 @@
                           <a:ea typeface="Arial"/>
                           <a:cs typeface="Arial"/>
                         </a:rPr>
-                        <a:t>WHAT STUDENTS DO</a:t>
+                        <a:t>FUNCTION</a:t>
                       </a:r>
                     </a:p>
                   </a:txBody>
@@ -4805,7 +4064,7 @@
                           <a:ea typeface="Arial"/>
                           <a:cs typeface="Arial"/>
                         </a:rPr>
-                        <a:t>Give a mission, inspect its tool plan, then check the evidence.</a:t>
+                        <a:t>Select read-only tools and summarize the returned data.</a:t>
                       </a:r>
                     </a:p>
                   </a:txBody>
@@ -4885,7 +4144,7 @@
                           <a:ea typeface="Arial"/>
                           <a:cs typeface="Arial"/>
                         </a:rPr>
-                        <a:t>Ask the exhibit brief a question and inspect source passages.</a:t>
+                        <a:t>Answer questions from retrieved exhibit passages.</a:t>
                       </a:r>
                     </a:p>
                   </a:txBody>
@@ -4965,7 +4224,7 @@
                           <a:ea typeface="Arial"/>
                           <a:cs typeface="Arial"/>
                         </a:rPr>
-                        <a:t>Store a fictional preference and reuse it in a later session.</a:t>
+                        <a:t>Save explicit facts and retrieve them in later sessions.</a:t>
                       </a:r>
                     </a:p>
                   </a:txBody>
@@ -5045,7 +4304,7 @@
                           <a:ea typeface="Arial"/>
                           <a:cs typeface="Arial"/>
                         </a:rPr>
-                        <a:t>Index notes, retrieve passages and question the answer.</a:t>
+                        <a:t>Index text documents and generate answers from retrieved passages.</a:t>
                       </a:r>
                     </a:p>
                   </a:txBody>
@@ -5125,7 +4384,7 @@
                           <a:ea typeface="Arial"/>
                           <a:cs typeface="Arial"/>
                         </a:rPr>
-                        <a:t>Hold a short local conversation and inspect its memory.</a:t>
+                        <a:t>Generate responses using the preceding conversation.</a:t>
                       </a:r>
                     </a:p>
                   </a:txBody>
@@ -5143,7 +4402,7 @@
     </p:spTree>
     <p:extLst>
       <p:ext uri="{BB962C8B-B14F-4D97-AF65-F5344CB8AC3E}">
-        <p14:creationId xmlns:p14="http://schemas.microsoft.com/office/powerpoint/2010/main" val="854286553"/>
+        <p14:creationId xmlns:p14="http://schemas.microsoft.com/office/powerpoint/2010/main" val="701202595"/>
       </p:ext>
     </p:extLst>
   </p:cSld>
@@ -5171,10 +4430,10 @@
       </p:grpSpPr>
       <p:sp>
         <p:nvSpPr>
-          <p:cNvPr id="6" name="">
+          <p:cNvPr id="4" name="">
             <a:extLst xmlns:a="http://schemas.openxmlformats.org/drawingml/2006/main">
               <a:ext uri="{FF2B5EF4-FFF2-40B4-BE49-F238E27FC236}">
-                <a16:creationId xmlns:a16="http://schemas.microsoft.com/office/drawing/2014/main" id="{6052940C-26EA-4A18-BD62-3107ECA14A20}"/>
+                <a16:creationId xmlns:a16="http://schemas.microsoft.com/office/drawing/2014/main" id="{2C3B22B7-B805-4ADA-83C5-51E019022A13}"/>
               </a:ext>
             </a:extLst>
           </p:cNvPr>
@@ -5221,7 +4480,7 @@
                 <a:ea typeface="Arial"/>
                 <a:cs typeface="Arial"/>
               </a:rPr>
-              <a:t>Language under the microscope</a:t>
+              <a:t>Tokenization and Generation</a:t>
             </a:r>
           </a:p>
         </p:txBody>
@@ -5231,121 +4490,7 @@
           <p:cNvPr id="2" name="">
             <a:extLst xmlns:a="http://schemas.openxmlformats.org/drawingml/2006/main">
               <a:ext uri="{FF2B5EF4-FFF2-40B4-BE49-F238E27FC236}">
-                <a16:creationId xmlns:a16="http://schemas.microsoft.com/office/drawing/2014/main" id="{2A128034-1918-4072-92C7-3CE823D95D79}"/>
-              </a:ext>
-            </a:extLst>
-          </p:cNvPr>
-          <p:cNvSpPr>
-            <a:spLocks xmlns:a="http://schemas.openxmlformats.org/drawingml/2006/main" noGrp="1"/>
-          </p:cNvSpPr>
-          <p:nvPr/>
-        </p:nvSpPr>
-        <p:spPr>
-          <a:xfrm xmlns:a="http://schemas.openxmlformats.org/drawingml/2006/main">
-            <a:off x="666750" y="1333500"/>
-            <a:ext cx="10858500" cy="619125"/>
-          </a:xfrm>
-          <a:prstGeom xmlns:a="http://schemas.openxmlformats.org/drawingml/2006/main" prst="rect">
-            <a:avLst/>
-          </a:prstGeom>
-          <a:noFill xmlns:a="http://schemas.openxmlformats.org/drawingml/2006/main"/>
-          <a:ln xmlns:a="http://schemas.openxmlformats.org/drawingml/2006/main" w="0">
-            <a:noFill/>
-          </a:ln>
-        </p:spPr>
-        <p:txBody>
-          <a:bodyPr xmlns:a="http://schemas.openxmlformats.org/drawingml/2006/main">
-            <a:noAutofit/>
-          </a:bodyPr>
-          <a:lstStyle xmlns:a="http://schemas.openxmlformats.org/drawingml/2006/main"/>
-          <a:p xmlns:a="http://schemas.openxmlformats.org/drawingml/2006/main">
-            <a:pPr>
-              <a:defRPr sz="1950" b="0">
-                <a:solidFill>
-                  <a:srgbClr val="52635B"/>
-                </a:solidFill>
-                <a:latin typeface="Arial"/>
-                <a:ea typeface="Arial"/>
-                <a:cs typeface="Arial"/>
-              </a:defRPr>
-            </a:pPr>
-            <a:r>
-              <a:rPr sz="1950" b="0">
-                <a:solidFill>
-                  <a:srgbClr val="52635B"/>
-                </a:solidFill>
-                <a:latin typeface="Arial"/>
-                <a:ea typeface="Arial"/>
-                <a:cs typeface="Arial"/>
-              </a:rPr>
-              <a:t>Change the input or decoding settings and compare the response.</a:t>
-            </a:r>
-          </a:p>
-        </p:txBody>
-      </p:sp>
-      <p:sp>
-        <p:nvSpPr>
-          <p:cNvPr id="3" name="">
-            <a:extLst xmlns:a="http://schemas.openxmlformats.org/drawingml/2006/main">
-              <a:ext uri="{FF2B5EF4-FFF2-40B4-BE49-F238E27FC236}">
-                <a16:creationId xmlns:a16="http://schemas.microsoft.com/office/drawing/2014/main" id="{DC00DC30-E760-4F3A-BD5A-A88F6F597602}"/>
-              </a:ext>
-            </a:extLst>
-          </p:cNvPr>
-          <p:cNvSpPr>
-            <a:spLocks xmlns:a="http://schemas.openxmlformats.org/drawingml/2006/main" noGrp="1"/>
-          </p:cNvSpPr>
-          <p:nvPr/>
-        </p:nvSpPr>
-        <p:spPr>
-          <a:xfrm xmlns:a="http://schemas.openxmlformats.org/drawingml/2006/main">
-            <a:off x="666750" y="6191250"/>
-            <a:ext cx="10287000" cy="419100"/>
-          </a:xfrm>
-          <a:prstGeom xmlns:a="http://schemas.openxmlformats.org/drawingml/2006/main" prst="rect">
-            <a:avLst/>
-          </a:prstGeom>
-          <a:noFill xmlns:a="http://schemas.openxmlformats.org/drawingml/2006/main"/>
-          <a:ln xmlns:a="http://schemas.openxmlformats.org/drawingml/2006/main" w="0">
-            <a:noFill/>
-          </a:ln>
-        </p:spPr>
-        <p:txBody>
-          <a:bodyPr xmlns:a="http://schemas.openxmlformats.org/drawingml/2006/main">
-            <a:noAutofit/>
-          </a:bodyPr>
-          <a:lstStyle xmlns:a="http://schemas.openxmlformats.org/drawingml/2006/main"/>
-          <a:p xmlns:a="http://schemas.openxmlformats.org/drawingml/2006/main">
-            <a:pPr>
-              <a:defRPr sz="1350" b="0">
-                <a:solidFill>
-                  <a:srgbClr val="52635B"/>
-                </a:solidFill>
-                <a:latin typeface="Arial"/>
-                <a:ea typeface="Arial"/>
-                <a:cs typeface="Arial"/>
-              </a:defRPr>
-            </a:pPr>
-            <a:r>
-              <a:rPr sz="1350" b="0">
-                <a:solidFill>
-                  <a:srgbClr val="52635B"/>
-                </a:solidFill>
-                <a:latin typeface="Arial"/>
-                <a:ea typeface="Arial"/>
-                <a:cs typeface="Arial"/>
-              </a:rPr>
-              <a:t>Ask the class to predict how each change will affect the answer.</a:t>
-            </a:r>
-          </a:p>
-        </p:txBody>
-      </p:sp>
-      <p:sp>
-        <p:nvSpPr>
-          <p:cNvPr id="4" name="">
-            <a:extLst xmlns:a="http://schemas.openxmlformats.org/drawingml/2006/main">
-              <a:ext uri="{FF2B5EF4-FFF2-40B4-BE49-F238E27FC236}">
-                <a16:creationId xmlns:a16="http://schemas.microsoft.com/office/drawing/2014/main" id="{512D35F5-0B15-486C-AD63-C23DAA1F968D}"/>
+                <a16:creationId xmlns:a16="http://schemas.microsoft.com/office/drawing/2014/main" id="{66D60612-F7EC-4B17-8395-FCC44F17CB72}"/>
               </a:ext>
             </a:extLst>
           </p:cNvPr>
@@ -5399,7 +4544,7 @@
       </p:sp>
       <p:graphicFrame>
         <p:nvGraphicFramePr>
-          <p:cNvPr id="10" name=""/>
+          <p:cNvPr id="6" name=""/>
           <p:cNvGraphicFramePr/>
           <p:nvPr/>
         </p:nvGraphicFramePr>
@@ -5485,7 +4630,7 @@
                           <a:ea typeface="Arial"/>
                           <a:cs typeface="Arial"/>
                         </a:rPr>
-                        <a:t>WHAT STUDENTS DO</a:t>
+                        <a:t>FUNCTION</a:t>
                       </a:r>
                     </a:p>
                   </a:txBody>
@@ -5565,7 +4710,7 @@
                           <a:ea typeface="Arial"/>
                           <a:cs typeface="Arial"/>
                         </a:rPr>
-                        <a:t>Test a short question with the configured small model.</a:t>
+                        <a:t>Generate a response to a single prompt.</a:t>
                       </a:r>
                     </a:p>
                   </a:txBody>
@@ -5645,7 +4790,7 @@
                           <a:ea typeface="Arial"/>
                           <a:cs typeface="Arial"/>
                         </a:rPr>
-                        <a:t>Compare how words, code and symbols split into tokens.</a:t>
+                        <a:t>Inspect token IDs for text, code and symbols.</a:t>
                       </a:r>
                     </a:p>
                   </a:txBody>
@@ -5983,7 +5128,7 @@
     </p:spTree>
     <p:extLst>
       <p:ext uri="{BB962C8B-B14F-4D97-AF65-F5344CB8AC3E}">
-        <p14:creationId xmlns:p14="http://schemas.microsoft.com/office/powerpoint/2010/main" val="264836762"/>
+        <p14:creationId xmlns:p14="http://schemas.microsoft.com/office/powerpoint/2010/main" val="201638484"/>
       </p:ext>
     </p:extLst>
   </p:cSld>
@@ -6011,10 +5156,10 @@
       </p:grpSpPr>
       <p:sp>
         <p:nvSpPr>
-          <p:cNvPr id="6" name="">
+          <p:cNvPr id="4" name="">
             <a:extLst xmlns:a="http://schemas.openxmlformats.org/drawingml/2006/main">
               <a:ext uri="{FF2B5EF4-FFF2-40B4-BE49-F238E27FC236}">
-                <a16:creationId xmlns:a16="http://schemas.microsoft.com/office/drawing/2014/main" id="{C4A515BD-39B8-44A1-8641-8D94B5DF303B}"/>
+                <a16:creationId xmlns:a16="http://schemas.microsoft.com/office/drawing/2014/main" id="{E609E92C-4A08-4F2A-B836-56706266AE52}"/>
               </a:ext>
             </a:extLst>
           </p:cNvPr>
@@ -6061,7 +5206,7 @@
                 <a:ea typeface="Arial"/>
                 <a:cs typeface="Arial"/>
               </a:rPr>
-              <a:t>Creativity and practical text tasks</a:t>
+              <a:t>Text Generation and Processing</a:t>
             </a:r>
           </a:p>
         </p:txBody>
@@ -6071,121 +5216,7 @@
           <p:cNvPr id="2" name="">
             <a:extLst xmlns:a="http://schemas.openxmlformats.org/drawingml/2006/main">
               <a:ext uri="{FF2B5EF4-FFF2-40B4-BE49-F238E27FC236}">
-                <a16:creationId xmlns:a16="http://schemas.microsoft.com/office/drawing/2014/main" id="{DA383EA6-2759-4F79-BA73-1381A7BE2E4C}"/>
-              </a:ext>
-            </a:extLst>
-          </p:cNvPr>
-          <p:cNvSpPr>
-            <a:spLocks xmlns:a="http://schemas.openxmlformats.org/drawingml/2006/main" noGrp="1"/>
-          </p:cNvSpPr>
-          <p:nvPr/>
-        </p:nvSpPr>
-        <p:spPr>
-          <a:xfrm xmlns:a="http://schemas.openxmlformats.org/drawingml/2006/main">
-            <a:off x="666750" y="1333500"/>
-            <a:ext cx="10858500" cy="619125"/>
-          </a:xfrm>
-          <a:prstGeom xmlns:a="http://schemas.openxmlformats.org/drawingml/2006/main" prst="rect">
-            <a:avLst/>
-          </a:prstGeom>
-          <a:noFill xmlns:a="http://schemas.openxmlformats.org/drawingml/2006/main"/>
-          <a:ln xmlns:a="http://schemas.openxmlformats.org/drawingml/2006/main" w="0">
-            <a:noFill/>
-          </a:ln>
-        </p:spPr>
-        <p:txBody>
-          <a:bodyPr xmlns:a="http://schemas.openxmlformats.org/drawingml/2006/main">
-            <a:noAutofit/>
-          </a:bodyPr>
-          <a:lstStyle xmlns:a="http://schemas.openxmlformats.org/drawingml/2006/main"/>
-          <a:p xmlns:a="http://schemas.openxmlformats.org/drawingml/2006/main">
-            <a:pPr>
-              <a:defRPr sz="1950" b="0">
-                <a:solidFill>
-                  <a:srgbClr val="52635B"/>
-                </a:solidFill>
-                <a:latin typeface="Arial"/>
-                <a:ea typeface="Arial"/>
-                <a:cs typeface="Arial"/>
-              </a:defRPr>
-            </a:pPr>
-            <a:r>
-              <a:rPr sz="1950" b="0">
-                <a:solidFill>
-                  <a:srgbClr val="52635B"/>
-                </a:solidFill>
-                <a:latin typeface="Arial"/>
-                <a:ea typeface="Arial"/>
-                <a:cs typeface="Arial"/>
-              </a:rPr>
-              <a:t>Let students supply a twist, a message or a passage.</a:t>
-            </a:r>
-          </a:p>
-        </p:txBody>
-      </p:sp>
-      <p:sp>
-        <p:nvSpPr>
-          <p:cNvPr id="3" name="">
-            <a:extLst xmlns:a="http://schemas.openxmlformats.org/drawingml/2006/main">
-              <a:ext uri="{FF2B5EF4-FFF2-40B4-BE49-F238E27FC236}">
-                <a16:creationId xmlns:a16="http://schemas.microsoft.com/office/drawing/2014/main" id="{AF8ED5C8-C3FA-4354-B52C-35EDBE6B0206}"/>
-              </a:ext>
-            </a:extLst>
-          </p:cNvPr>
-          <p:cNvSpPr>
-            <a:spLocks xmlns:a="http://schemas.openxmlformats.org/drawingml/2006/main" noGrp="1"/>
-          </p:cNvSpPr>
-          <p:nvPr/>
-        </p:nvSpPr>
-        <p:spPr>
-          <a:xfrm xmlns:a="http://schemas.openxmlformats.org/drawingml/2006/main">
-            <a:off x="666750" y="6191250"/>
-            <a:ext cx="10287000" cy="419100"/>
-          </a:xfrm>
-          <a:prstGeom xmlns:a="http://schemas.openxmlformats.org/drawingml/2006/main" prst="rect">
-            <a:avLst/>
-          </a:prstGeom>
-          <a:noFill xmlns:a="http://schemas.openxmlformats.org/drawingml/2006/main"/>
-          <a:ln xmlns:a="http://schemas.openxmlformats.org/drawingml/2006/main" w="0">
-            <a:noFill/>
-          </a:ln>
-        </p:spPr>
-        <p:txBody>
-          <a:bodyPr xmlns:a="http://schemas.openxmlformats.org/drawingml/2006/main">
-            <a:noAutofit/>
-          </a:bodyPr>
-          <a:lstStyle xmlns:a="http://schemas.openxmlformats.org/drawingml/2006/main"/>
-          <a:p xmlns:a="http://schemas.openxmlformats.org/drawingml/2006/main">
-            <a:pPr>
-              <a:defRPr sz="1350" b="0">
-                <a:solidFill>
-                  <a:srgbClr val="52635B"/>
-                </a:solidFill>
-                <a:latin typeface="Arial"/>
-                <a:ea typeface="Arial"/>
-                <a:cs typeface="Arial"/>
-              </a:defRPr>
-            </a:pPr>
-            <a:r>
-              <a:rPr sz="1350" b="0">
-                <a:solidFill>
-                  <a:srgbClr val="52635B"/>
-                </a:solidFill>
-                <a:latin typeface="Arial"/>
-                <a:ea typeface="Arial"/>
-                <a:cs typeface="Arial"/>
-              </a:rPr>
-              <a:t>Invite students to bring a story twist, a classroom message or a short passage.</a:t>
-            </a:r>
-          </a:p>
-        </p:txBody>
-      </p:sp>
-      <p:sp>
-        <p:nvSpPr>
-          <p:cNvPr id="4" name="">
-            <a:extLst xmlns:a="http://schemas.openxmlformats.org/drawingml/2006/main">
-              <a:ext uri="{FF2B5EF4-FFF2-40B4-BE49-F238E27FC236}">
-                <a16:creationId xmlns:a16="http://schemas.microsoft.com/office/drawing/2014/main" id="{04B1D60E-820B-4C93-BBC9-4E36F9BF9211}"/>
+                <a16:creationId xmlns:a16="http://schemas.microsoft.com/office/drawing/2014/main" id="{232030A5-1109-4ECA-8FD4-5F3505EA50CF}"/>
               </a:ext>
             </a:extLst>
           </p:cNvPr>
@@ -6239,7 +5270,7 @@
       </p:sp>
       <p:graphicFrame>
         <p:nvGraphicFramePr>
-          <p:cNvPr id="10" name=""/>
+          <p:cNvPr id="6" name=""/>
           <p:cNvGraphicFramePr/>
           <p:nvPr/>
         </p:nvGraphicFramePr>
@@ -6325,7 +5356,7 @@
                           <a:ea typeface="Arial"/>
                           <a:cs typeface="Arial"/>
                         </a:rPr>
-                        <a:t>WHAT STUDENTS DO</a:t>
+                        <a:t>FUNCTION</a:t>
                       </a:r>
                     </a:p>
                   </a:txBody>
@@ -6405,7 +5436,7 @@
                           <a:ea typeface="Arial"/>
                           <a:cs typeface="Arial"/>
                         </a:rPr>
-                        <a:t>Choose a setting, then change the generated story with a twist.</a:t>
+                        <a:t>Generate a story and continue it using a supplied plot change.</a:t>
                       </a:r>
                     </a:p>
                   </a:txBody>
@@ -6485,7 +5516,7 @@
                           <a:ea typeface="Arial"/>
                           <a:cs typeface="Arial"/>
                         </a:rPr>
-                        <a:t>Continue a story with a small dedicated language model.</a:t>
+                        <a:t>Generate text with the TinyStories model.</a:t>
                       </a:r>
                     </a:p>
                   </a:txBody>
@@ -6645,7 +5676,7 @@
                           <a:ea typeface="Arial"/>
                           <a:cs typeface="Arial"/>
                         </a:rPr>
-                        <a:t>Read the source, summary and separate model critique.</a:t>
+                        <a:t>Summarize a passage and compare it with a second model critique.</a:t>
                       </a:r>
                     </a:p>
                   </a:txBody>
@@ -6725,7 +5756,7 @@
                           <a:ea typeface="Arial"/>
                           <a:cs typeface="Arial"/>
                         </a:rPr>
-                        <a:t>Inspect how a tool performs arithmetic for a language model.</a:t>
+                        <a:t>Evaluate a validated arithmetic expression using a calculator tool.</a:t>
                       </a:r>
                     </a:p>
                   </a:txBody>
@@ -6743,7 +5774,7 @@
     </p:spTree>
     <p:extLst>
       <p:ext uri="{BB962C8B-B14F-4D97-AF65-F5344CB8AC3E}">
-        <p14:creationId xmlns:p14="http://schemas.microsoft.com/office/powerpoint/2010/main" val="726683948"/>
+        <p14:creationId xmlns:p14="http://schemas.microsoft.com/office/powerpoint/2010/main" val="1214969562"/>
       </p:ext>
     </p:extLst>
   </p:cSld>
@@ -6771,10 +5802,10 @@
       </p:grpSpPr>
       <p:sp>
         <p:nvSpPr>
-          <p:cNvPr id="13" name="">
+          <p:cNvPr id="11" name="">
             <a:extLst xmlns:a="http://schemas.openxmlformats.org/drawingml/2006/main">
               <a:ext uri="{FF2B5EF4-FFF2-40B4-BE49-F238E27FC236}">
-                <a16:creationId xmlns:a16="http://schemas.microsoft.com/office/drawing/2014/main" id="{1ED31DCA-7B77-4825-9E1D-AE42344DB9AB}"/>
+                <a16:creationId xmlns:a16="http://schemas.microsoft.com/office/drawing/2014/main" id="{70A89D95-701D-4948-824F-A8BCB336A2BA}"/>
               </a:ext>
             </a:extLst>
           </p:cNvPr>
@@ -6821,7 +5852,7 @@
                 <a:ea typeface="Arial"/>
                 <a:cs typeface="Arial"/>
               </a:rPr>
-              <a:t>Memory, uncertainty and trust</a:t>
+              <a:t>Prompt Injection and Context</a:t>
             </a:r>
           </a:p>
         </p:txBody>
@@ -6831,121 +5862,7 @@
           <p:cNvPr id="2" name="">
             <a:extLst xmlns:a="http://schemas.openxmlformats.org/drawingml/2006/main">
               <a:ext uri="{FF2B5EF4-FFF2-40B4-BE49-F238E27FC236}">
-                <a16:creationId xmlns:a16="http://schemas.microsoft.com/office/drawing/2014/main" id="{2F895C9B-E7DB-497D-BB53-C018B77DC6A6}"/>
-              </a:ext>
-            </a:extLst>
-          </p:cNvPr>
-          <p:cNvSpPr>
-            <a:spLocks xmlns:a="http://schemas.openxmlformats.org/drawingml/2006/main" noGrp="1"/>
-          </p:cNvSpPr>
-          <p:nvPr/>
-        </p:nvSpPr>
-        <p:spPr>
-          <a:xfrm xmlns:a="http://schemas.openxmlformats.org/drawingml/2006/main">
-            <a:off x="666750" y="1333500"/>
-            <a:ext cx="10858500" cy="619125"/>
-          </a:xfrm>
-          <a:prstGeom xmlns:a="http://schemas.openxmlformats.org/drawingml/2006/main" prst="rect">
-            <a:avLst/>
-          </a:prstGeom>
-          <a:noFill xmlns:a="http://schemas.openxmlformats.org/drawingml/2006/main"/>
-          <a:ln xmlns:a="http://schemas.openxmlformats.org/drawingml/2006/main" w="0">
-            <a:noFill/>
-          </a:ln>
-        </p:spPr>
-        <p:txBody>
-          <a:bodyPr xmlns:a="http://schemas.openxmlformats.org/drawingml/2006/main">
-            <a:noAutofit/>
-          </a:bodyPr>
-          <a:lstStyle xmlns:a="http://schemas.openxmlformats.org/drawingml/2006/main"/>
-          <a:p xmlns:a="http://schemas.openxmlformats.org/drawingml/2006/main">
-            <a:pPr>
-              <a:defRPr sz="1950" b="0">
-                <a:solidFill>
-                  <a:srgbClr val="52635B"/>
-                </a:solidFill>
-                <a:latin typeface="Arial"/>
-                <a:ea typeface="Arial"/>
-                <a:cs typeface="Arial"/>
-              </a:defRPr>
-            </a:pPr>
-            <a:r>
-              <a:rPr sz="1950" b="0">
-                <a:solidFill>
-                  <a:srgbClr val="52635B"/>
-                </a:solidFill>
-                <a:latin typeface="Arial"/>
-                <a:ea typeface="Arial"/>
-                <a:cs typeface="Arial"/>
-              </a:rPr>
-              <a:t>Explore how an assistant handles instructions, missing facts and memory.</a:t>
-            </a:r>
-          </a:p>
-        </p:txBody>
-      </p:sp>
-      <p:sp>
-        <p:nvSpPr>
-          <p:cNvPr id="3" name="">
-            <a:extLst xmlns:a="http://schemas.openxmlformats.org/drawingml/2006/main">
-              <a:ext uri="{FF2B5EF4-FFF2-40B4-BE49-F238E27FC236}">
-                <a16:creationId xmlns:a16="http://schemas.microsoft.com/office/drawing/2014/main" id="{C7F8F860-EBC3-4E4D-B814-86B521E27433}"/>
-              </a:ext>
-            </a:extLst>
-          </p:cNvPr>
-          <p:cNvSpPr>
-            <a:spLocks xmlns:a="http://schemas.openxmlformats.org/drawingml/2006/main" noGrp="1"/>
-          </p:cNvSpPr>
-          <p:nvPr/>
-        </p:nvSpPr>
-        <p:spPr>
-          <a:xfrm xmlns:a="http://schemas.openxmlformats.org/drawingml/2006/main">
-            <a:off x="666750" y="6191250"/>
-            <a:ext cx="10287000" cy="419100"/>
-          </a:xfrm>
-          <a:prstGeom xmlns:a="http://schemas.openxmlformats.org/drawingml/2006/main" prst="rect">
-            <a:avLst/>
-          </a:prstGeom>
-          <a:noFill xmlns:a="http://schemas.openxmlformats.org/drawingml/2006/main"/>
-          <a:ln xmlns:a="http://schemas.openxmlformats.org/drawingml/2006/main" w="0">
-            <a:noFill/>
-          </a:ln>
-        </p:spPr>
-        <p:txBody>
-          <a:bodyPr xmlns:a="http://schemas.openxmlformats.org/drawingml/2006/main">
-            <a:noAutofit/>
-          </a:bodyPr>
-          <a:lstStyle xmlns:a="http://schemas.openxmlformats.org/drawingml/2006/main"/>
-          <a:p xmlns:a="http://schemas.openxmlformats.org/drawingml/2006/main">
-            <a:pPr>
-              <a:defRPr sz="1350" b="0">
-                <a:solidFill>
-                  <a:srgbClr val="52635B"/>
-                </a:solidFill>
-                <a:latin typeface="Arial"/>
-                <a:ea typeface="Arial"/>
-                <a:cs typeface="Arial"/>
-              </a:defRPr>
-            </a:pPr>
-            <a:r>
-              <a:rPr sz="1350" b="0">
-                <a:solidFill>
-                  <a:srgbClr val="52635B"/>
-                </a:solidFill>
-                <a:latin typeface="Arial"/>
-                <a:ea typeface="Arial"/>
-                <a:cs typeface="Arial"/>
-              </a:rPr>
-              <a:t>Challenge the assistant, inspect its answer, and compare it with the source facts.</a:t>
-            </a:r>
-          </a:p>
-        </p:txBody>
-      </p:sp>
-      <p:sp>
-        <p:nvSpPr>
-          <p:cNvPr id="4" name="">
-            <a:extLst xmlns:a="http://schemas.openxmlformats.org/drawingml/2006/main">
-              <a:ext uri="{FF2B5EF4-FFF2-40B4-BE49-F238E27FC236}">
-                <a16:creationId xmlns:a16="http://schemas.microsoft.com/office/drawing/2014/main" id="{C90618C9-7B1C-4471-BB85-3FDF9BAC3FA6}"/>
+                <a16:creationId xmlns:a16="http://schemas.microsoft.com/office/drawing/2014/main" id="{7270A4AC-2C52-41D1-B44D-23204D18E34A}"/>
               </a:ext>
             </a:extLst>
           </p:cNvPr>
@@ -6999,10 +5916,10 @@
       </p:sp>
       <p:sp>
         <p:nvSpPr>
-          <p:cNvPr id="5" name="">
+          <p:cNvPr id="3" name="">
             <a:extLst xmlns:a="http://schemas.openxmlformats.org/drawingml/2006/main">
               <a:ext uri="{FF2B5EF4-FFF2-40B4-BE49-F238E27FC236}">
-                <a16:creationId xmlns:a16="http://schemas.microsoft.com/office/drawing/2014/main" id="{726D0ED5-DED1-419A-8A1A-4FB4811F6603}"/>
+                <a16:creationId xmlns:a16="http://schemas.microsoft.com/office/drawing/2014/main" id="{285F08BB-E527-49E0-814F-1D4D95F04ACA}"/>
               </a:ext>
             </a:extLst>
           </p:cNvPr>
@@ -7049,17 +5966,17 @@
                 <a:ea typeface="Arial"/>
                 <a:cs typeface="Arial"/>
               </a:rPr>
-              <a:t>Experiment 26</a:t>
-            </a:r>
-          </a:p>
-        </p:txBody>
-      </p:sp>
-      <p:sp>
-        <p:nvSpPr>
-          <p:cNvPr id="6" name="">
+              <a:t>Menu 26</a:t>
+            </a:r>
+          </a:p>
+        </p:txBody>
+      </p:sp>
+      <p:sp>
+        <p:nvSpPr>
+          <p:cNvPr id="4" name="">
             <a:extLst xmlns:a="http://schemas.openxmlformats.org/drawingml/2006/main">
               <a:ext uri="{FF2B5EF4-FFF2-40B4-BE49-F238E27FC236}">
-                <a16:creationId xmlns:a16="http://schemas.microsoft.com/office/drawing/2014/main" id="{29F17C53-8140-40A4-9E48-911159DCEF2E}"/>
+                <a16:creationId xmlns:a16="http://schemas.microsoft.com/office/drawing/2014/main" id="{14652289-B854-43E8-B9B5-6476167009FC}"/>
               </a:ext>
             </a:extLst>
           </p:cNvPr>
@@ -7113,10 +6030,10 @@
       </p:sp>
       <p:sp>
         <p:nvSpPr>
-          <p:cNvPr id="7" name="">
+          <p:cNvPr id="5" name="">
             <a:extLst xmlns:a="http://schemas.openxmlformats.org/drawingml/2006/main">
               <a:ext uri="{FF2B5EF4-FFF2-40B4-BE49-F238E27FC236}">
-                <a16:creationId xmlns:a16="http://schemas.microsoft.com/office/drawing/2014/main" id="{1641CA58-E882-47C6-ADFC-6E417F941C55}"/>
+                <a16:creationId xmlns:a16="http://schemas.microsoft.com/office/drawing/2014/main" id="{C61E6A3C-1B91-473C-89EF-FCAF8FB48589}"/>
               </a:ext>
             </a:extLst>
           </p:cNvPr>
@@ -7170,10 +6087,10 @@
       </p:sp>
       <p:sp>
         <p:nvSpPr>
-          <p:cNvPr id="8" name="">
+          <p:cNvPr id="6" name="">
             <a:extLst xmlns:a="http://schemas.openxmlformats.org/drawingml/2006/main">
               <a:ext uri="{FF2B5EF4-FFF2-40B4-BE49-F238E27FC236}">
-                <a16:creationId xmlns:a16="http://schemas.microsoft.com/office/drawing/2014/main" id="{816BB589-333A-4134-B91D-2DD85B53AB8C}"/>
+                <a16:creationId xmlns:a16="http://schemas.microsoft.com/office/drawing/2014/main" id="{44344DAE-B22E-48AC-AF45-2F2E4939B0DD}"/>
               </a:ext>
             </a:extLst>
           </p:cNvPr>
@@ -7220,17 +6137,17 @@
                 <a:ea typeface="Arial"/>
                 <a:cs typeface="Arial"/>
               </a:rPr>
-              <a:t>Experiment 27</a:t>
-            </a:r>
-          </a:p>
-        </p:txBody>
-      </p:sp>
-      <p:sp>
-        <p:nvSpPr>
-          <p:cNvPr id="9" name="">
+              <a:t>Menu 27</a:t>
+            </a:r>
+          </a:p>
+        </p:txBody>
+      </p:sp>
+      <p:sp>
+        <p:nvSpPr>
+          <p:cNvPr id="7" name="">
             <a:extLst xmlns:a="http://schemas.openxmlformats.org/drawingml/2006/main">
               <a:ext uri="{FF2B5EF4-FFF2-40B4-BE49-F238E27FC236}">
-                <a16:creationId xmlns:a16="http://schemas.microsoft.com/office/drawing/2014/main" id="{B8FF8D72-B20B-4049-9B2C-BA505BBDAC07}"/>
+                <a16:creationId xmlns:a16="http://schemas.microsoft.com/office/drawing/2014/main" id="{F4493DF7-DCBE-49AD-B690-AB17439F744E}"/>
               </a:ext>
             </a:extLst>
           </p:cNvPr>
@@ -7284,10 +6201,10 @@
       </p:sp>
       <p:sp>
         <p:nvSpPr>
-          <p:cNvPr id="10" name="">
+          <p:cNvPr id="8" name="">
             <a:extLst xmlns:a="http://schemas.openxmlformats.org/drawingml/2006/main">
               <a:ext uri="{FF2B5EF4-FFF2-40B4-BE49-F238E27FC236}">
-                <a16:creationId xmlns:a16="http://schemas.microsoft.com/office/drawing/2014/main" id="{F660FA5B-DDCF-429D-8A5F-F42901D36035}"/>
+                <a16:creationId xmlns:a16="http://schemas.microsoft.com/office/drawing/2014/main" id="{615E354F-CA01-449C-9A29-7A692578BEBA}"/>
               </a:ext>
             </a:extLst>
           </p:cNvPr>
@@ -7341,10 +6258,10 @@
       </p:sp>
       <p:sp>
         <p:nvSpPr>
-          <p:cNvPr id="11" name="">
+          <p:cNvPr id="9" name="">
             <a:extLst xmlns:a="http://schemas.openxmlformats.org/drawingml/2006/main">
               <a:ext uri="{FF2B5EF4-FFF2-40B4-BE49-F238E27FC236}">
-                <a16:creationId xmlns:a16="http://schemas.microsoft.com/office/drawing/2014/main" id="{E9693CC6-F79E-4E52-B2C6-BE5CDD345D36}"/>
+                <a16:creationId xmlns:a16="http://schemas.microsoft.com/office/drawing/2014/main" id="{EB7A3841-FF8C-4E7B-B2D4-15B03607D213}"/>
               </a:ext>
             </a:extLst>
           </p:cNvPr>
@@ -7391,17 +6308,17 @@
                 <a:ea typeface="Arial"/>
                 <a:cs typeface="Arial"/>
               </a:rPr>
-              <a:t>Experiment 28: Context Memory Challenge</a:t>
-            </a:r>
-          </a:p>
-        </p:txBody>
-      </p:sp>
-      <p:sp>
-        <p:nvSpPr>
-          <p:cNvPr id="12" name="">
+              <a:t>Menu 28: Context Memory Challenge</a:t>
+            </a:r>
+          </a:p>
+        </p:txBody>
+      </p:sp>
+      <p:sp>
+        <p:nvSpPr>
+          <p:cNvPr id="10" name="">
             <a:extLst xmlns:a="http://schemas.openxmlformats.org/drawingml/2006/main">
               <a:ext uri="{FF2B5EF4-FFF2-40B4-BE49-F238E27FC236}">
-                <a16:creationId xmlns:a16="http://schemas.microsoft.com/office/drawing/2014/main" id="{9AB07230-0B47-43BB-9BBE-DEED6BAD8E58}"/>
+                <a16:creationId xmlns:a16="http://schemas.microsoft.com/office/drawing/2014/main" id="{48F46CC2-CA05-40AD-A18B-32FA627682FA}"/>
               </a:ext>
             </a:extLst>
           </p:cNvPr>
@@ -7456,7 +6373,7 @@
     </p:spTree>
     <p:extLst>
       <p:ext uri="{BB962C8B-B14F-4D97-AF65-F5344CB8AC3E}">
-        <p14:creationId xmlns:p14="http://schemas.microsoft.com/office/powerpoint/2010/main" val="37995341"/>
+        <p14:creationId xmlns:p14="http://schemas.microsoft.com/office/powerpoint/2010/main" val="1561833522"/>
       </p:ext>
     </p:extLst>
   </p:cSld>
@@ -7484,10 +6401,10 @@
       </p:grpSpPr>
       <p:sp>
         <p:nvSpPr>
-          <p:cNvPr id="7" name="">
+          <p:cNvPr id="6" name="">
             <a:extLst xmlns:a="http://schemas.openxmlformats.org/drawingml/2006/main">
               <a:ext uri="{FF2B5EF4-FFF2-40B4-BE49-F238E27FC236}">
-                <a16:creationId xmlns:a16="http://schemas.microsoft.com/office/drawing/2014/main" id="{843E3006-0661-4D69-AF3C-EAB1C8E49FF4}"/>
+                <a16:creationId xmlns:a16="http://schemas.microsoft.com/office/drawing/2014/main" id="{FD14484D-AF43-4B7F-963C-B19C2C969AAD}"/>
               </a:ext>
             </a:extLst>
           </p:cNvPr>
@@ -7534,7 +6451,7 @@
                 <a:ea typeface="Arial"/>
                 <a:cs typeface="Arial"/>
               </a:rPr>
-              <a:t>Camera projects beyond detection</a:t>
+              <a:t>Camera Applications</a:t>
             </a:r>
           </a:p>
         </p:txBody>
@@ -7544,7 +6461,7 @@
           <p:cNvPr id="2" name="">
             <a:extLst xmlns:a="http://schemas.openxmlformats.org/drawingml/2006/main">
               <a:ext uri="{FF2B5EF4-FFF2-40B4-BE49-F238E27FC236}">
-                <a16:creationId xmlns:a16="http://schemas.microsoft.com/office/drawing/2014/main" id="{3FB96AED-A273-40D8-8882-1FCB199807ED}"/>
+                <a16:creationId xmlns:a16="http://schemas.microsoft.com/office/drawing/2014/main" id="{6F3640AD-7C70-4E05-8B3E-83E6A1F1432F}"/>
               </a:ext>
             </a:extLst>
           </p:cNvPr>
@@ -7591,7 +6508,7 @@
                 <a:ea typeface="Arial"/>
                 <a:cs typeface="Arial"/>
               </a:rPr>
-              <a:t>Keep the camera fixed. Move ordinary objects in the scene.</a:t>
+              <a:t>Keep the camera fixed between observations.</a:t>
             </a:r>
           </a:p>
         </p:txBody>
@@ -7601,64 +6518,7 @@
           <p:cNvPr id="3" name="">
             <a:extLst xmlns:a="http://schemas.openxmlformats.org/drawingml/2006/main">
               <a:ext uri="{FF2B5EF4-FFF2-40B4-BE49-F238E27FC236}">
-                <a16:creationId xmlns:a16="http://schemas.microsoft.com/office/drawing/2014/main" id="{EFCB9428-03D2-4401-9CEB-C144681BF218}"/>
-              </a:ext>
-            </a:extLst>
-          </p:cNvPr>
-          <p:cNvSpPr>
-            <a:spLocks xmlns:a="http://schemas.openxmlformats.org/drawingml/2006/main" noGrp="1"/>
-          </p:cNvSpPr>
-          <p:nvPr/>
-        </p:nvSpPr>
-        <p:spPr>
-          <a:xfrm xmlns:a="http://schemas.openxmlformats.org/drawingml/2006/main">
-            <a:off x="666750" y="6191250"/>
-            <a:ext cx="10287000" cy="419100"/>
-          </a:xfrm>
-          <a:prstGeom xmlns:a="http://schemas.openxmlformats.org/drawingml/2006/main" prst="rect">
-            <a:avLst/>
-          </a:prstGeom>
-          <a:noFill xmlns:a="http://schemas.openxmlformats.org/drawingml/2006/main"/>
-          <a:ln xmlns:a="http://schemas.openxmlformats.org/drawingml/2006/main" w="0">
-            <a:noFill/>
-          </a:ln>
-        </p:spPr>
-        <p:txBody>
-          <a:bodyPr xmlns:a="http://schemas.openxmlformats.org/drawingml/2006/main">
-            <a:noAutofit/>
-          </a:bodyPr>
-          <a:lstStyle xmlns:a="http://schemas.openxmlformats.org/drawingml/2006/main"/>
-          <a:p xmlns:a="http://schemas.openxmlformats.org/drawingml/2006/main">
-            <a:pPr>
-              <a:defRPr sz="1350" b="0">
-                <a:solidFill>
-                  <a:srgbClr val="52635B"/>
-                </a:solidFill>
-                <a:latin typeface="Arial"/>
-                <a:ea typeface="Arial"/>
-                <a:cs typeface="Arial"/>
-              </a:defRPr>
-            </a:pPr>
-            <a:r>
-              <a:rPr sz="1350" b="0">
-                <a:solidFill>
-                  <a:srgbClr val="52635B"/>
-                </a:solidFill>
-                <a:latin typeface="Arial"/>
-                <a:ea typeface="Arial"/>
-                <a:cs typeface="Arial"/>
-              </a:rPr>
-              <a:t>Run 13 → install and rehearse detection first. Vision and the language model run sequentially.</a:t>
-            </a:r>
-          </a:p>
-        </p:txBody>
-      </p:sp>
-      <p:sp>
-        <p:nvSpPr>
-          <p:cNvPr id="4" name="">
-            <a:extLst xmlns:a="http://schemas.openxmlformats.org/drawingml/2006/main">
-              <a:ext uri="{FF2B5EF4-FFF2-40B4-BE49-F238E27FC236}">
-                <a16:creationId xmlns:a16="http://schemas.microsoft.com/office/drawing/2014/main" id="{9405CB78-00D6-4411-8237-50AFDDE894FC}"/>
+                <a16:creationId xmlns:a16="http://schemas.microsoft.com/office/drawing/2014/main" id="{D4758701-5A20-4D58-B494-1D742201667E}"/>
               </a:ext>
             </a:extLst>
           </p:cNvPr>
@@ -7712,7 +6572,7 @@
       </p:sp>
       <p:graphicFrame>
         <p:nvGraphicFramePr>
-          <p:cNvPr id="11" name=""/>
+          <p:cNvPr id="9" name=""/>
           <p:cNvGraphicFramePr/>
           <p:nvPr/>
         </p:nvGraphicFramePr>
@@ -7798,7 +6658,7 @@
                           <a:ea typeface="Arial"/>
                           <a:cs typeface="Arial"/>
                         </a:rPr>
-                        <a:t>WHAT STUDENTS DO</a:t>
+                        <a:t>FUNCTION</a:t>
                       </a:r>
                     </a:p>
                   </a:txBody>
@@ -7878,7 +6738,7 @@
                           <a:ea typeface="Arial"/>
                           <a:cs typeface="Arial"/>
                         </a:rPr>
-                        <a:t>Observe the desk, change something, then explain the measured difference.</a:t>
+                        <a:t>Compare object classes, counts and positions across two observations.</a:t>
                       </a:r>
                     </a:p>
                   </a:txBody>
@@ -7958,7 +6818,7 @@
                           <a:ea typeface="Arial"/>
                           <a:cs typeface="Arial"/>
                         </a:rPr>
-                        <a:t>Arrange objects for an AI-generated quest; detector evidence determines the score.</a:t>
+                        <a:t>Generate an object-finding task and score detections against its targets.</a:t>
                       </a:r>
                     </a:p>
                   </a:txBody>
@@ -8038,7 +6898,7 @@
                           <a:ea typeface="Arial"/>
                           <a:cs typeface="Arial"/>
                         </a:rPr>
-                        <a:t>Capture three observations and summarize the recorded changes.</a:t>
+                        <a:t>Record three observations and summarize the detected changes.</a:t>
                       </a:r>
                     </a:p>
                   </a:txBody>
@@ -8118,7 +6978,7 @@
                           <a:ea typeface="Arial"/>
                           <a:cs typeface="Arial"/>
                         </a:rPr>
-                        <a:t>Explore detection, classification, pose or segmentation.</a:t>
+                        <a:t>Run detection, classification, pose estimation or segmentation.</a:t>
                       </a:r>
                     </a:p>
                   </a:txBody>
@@ -8135,10 +6995,10 @@
       </p:graphicFrame>
       <p:sp>
         <p:nvSpPr>
-          <p:cNvPr id="6" name="">
+          <p:cNvPr id="5" name="">
             <a:extLst xmlns:a="http://schemas.openxmlformats.org/drawingml/2006/main">
               <a:ext uri="{FF2B5EF4-FFF2-40B4-BE49-F238E27FC236}">
-                <a16:creationId xmlns:a16="http://schemas.microsoft.com/office/drawing/2014/main" id="{9BF8FC52-3999-4277-9CDF-D3F54FE2ECD4}"/>
+                <a16:creationId xmlns:a16="http://schemas.microsoft.com/office/drawing/2014/main" id="{EBDE1D2B-5CD7-4206-9EB1-DF9CC34B74D8}"/>
               </a:ext>
             </a:extLst>
           </p:cNvPr>
@@ -8149,7 +7009,7 @@
         </p:nvSpPr>
         <p:spPr>
           <a:xfrm xmlns:a="http://schemas.openxmlformats.org/drawingml/2006/main">
-            <a:off x="723900" y="5591175"/>
+            <a:off x="723900" y="5657850"/>
             <a:ext cx="10382250" cy="457200"/>
           </a:xfrm>
           <a:prstGeom xmlns:a="http://schemas.openxmlformats.org/drawingml/2006/main" prst="rect">
@@ -8167,9 +7027,9 @@
           <a:lstStyle xmlns:a="http://schemas.openxmlformats.org/drawingml/2006/main"/>
           <a:p xmlns:a="http://schemas.openxmlformats.org/drawingml/2006/main">
             <a:pPr>
-              <a:defRPr sz="2250" b="1">
-                <a:solidFill>
-                  <a:srgbClr val="397718"/>
+              <a:defRPr sz="1875" b="0">
+                <a:solidFill>
+                  <a:srgbClr val="52635B"/>
                 </a:solidFill>
                 <a:latin typeface="Arial"/>
                 <a:ea typeface="Arial"/>
@@ -8177,15 +7037,15 @@
               </a:defRPr>
             </a:pPr>
             <a:r>
-              <a:rPr sz="2250" b="1">
-                <a:solidFill>
-                  <a:srgbClr val="397718"/>
+              <a:rPr sz="1875" b="0">
+                <a:solidFill>
+                  <a:srgbClr val="52635B"/>
                 </a:solidFill>
                 <a:latin typeface="Arial"/>
                 <a:ea typeface="Arial"/>
                 <a:cs typeface="Arial"/>
               </a:rPr>
-              <a:t>Try it with a cup, a book or a bottle.</a:t>
+              <a:t>Camera setup: menu 13, then install.</a:t>
             </a:r>
           </a:p>
         </p:txBody>
@@ -8193,7 +7053,7 @@
     </p:spTree>
     <p:extLst>
       <p:ext uri="{BB962C8B-B14F-4D97-AF65-F5344CB8AC3E}">
-        <p14:creationId xmlns:p14="http://schemas.microsoft.com/office/powerpoint/2010/main" val="1211632577"/>
+        <p14:creationId xmlns:p14="http://schemas.microsoft.com/office/powerpoint/2010/main" val="357624320"/>
       </p:ext>
     </p:extLst>
   </p:cSld>
@@ -8221,10 +7081,10 @@
       </p:grpSpPr>
       <p:sp>
         <p:nvSpPr>
-          <p:cNvPr id="11" name="">
+          <p:cNvPr id="9" name="">
             <a:extLst xmlns:a="http://schemas.openxmlformats.org/drawingml/2006/main">
               <a:ext uri="{FF2B5EF4-FFF2-40B4-BE49-F238E27FC236}">
-                <a16:creationId xmlns:a16="http://schemas.microsoft.com/office/drawing/2014/main" id="{04B9A307-1337-42F5-A365-DD34E580A834}"/>
+                <a16:creationId xmlns:a16="http://schemas.microsoft.com/office/drawing/2014/main" id="{DE847DF4-805F-490F-940D-69D9BB4220CE}"/>
               </a:ext>
             </a:extLst>
           </p:cNvPr>
@@ -8271,7 +7131,7 @@
                 <a:ea typeface="Arial"/>
                 <a:cs typeface="Arial"/>
               </a:rPr>
-              <a:t>Model performance and evaluation</a:t>
+              <a:t>Performance and Evaluation</a:t>
             </a:r>
           </a:p>
         </p:txBody>
@@ -8281,121 +7141,7 @@
           <p:cNvPr id="2" name="">
             <a:extLst xmlns:a="http://schemas.openxmlformats.org/drawingml/2006/main">
               <a:ext uri="{FF2B5EF4-FFF2-40B4-BE49-F238E27FC236}">
-                <a16:creationId xmlns:a16="http://schemas.microsoft.com/office/drawing/2014/main" id="{31D1AC7E-64C6-4ADD-AAF5-BFDBF1F2A22E}"/>
-              </a:ext>
-            </a:extLst>
-          </p:cNvPr>
-          <p:cNvSpPr>
-            <a:spLocks xmlns:a="http://schemas.openxmlformats.org/drawingml/2006/main" noGrp="1"/>
-          </p:cNvSpPr>
-          <p:nvPr/>
-        </p:nvSpPr>
-        <p:spPr>
-          <a:xfrm xmlns:a="http://schemas.openxmlformats.org/drawingml/2006/main">
-            <a:off x="666750" y="1333500"/>
-            <a:ext cx="10858500" cy="619125"/>
-          </a:xfrm>
-          <a:prstGeom xmlns:a="http://schemas.openxmlformats.org/drawingml/2006/main" prst="rect">
-            <a:avLst/>
-          </a:prstGeom>
-          <a:noFill xmlns:a="http://schemas.openxmlformats.org/drawingml/2006/main"/>
-          <a:ln xmlns:a="http://schemas.openxmlformats.org/drawingml/2006/main" w="0">
-            <a:noFill/>
-          </a:ln>
-        </p:spPr>
-        <p:txBody>
-          <a:bodyPr xmlns:a="http://schemas.openxmlformats.org/drawingml/2006/main">
-            <a:noAutofit/>
-          </a:bodyPr>
-          <a:lstStyle xmlns:a="http://schemas.openxmlformats.org/drawingml/2006/main"/>
-          <a:p xmlns:a="http://schemas.openxmlformats.org/drawingml/2006/main">
-            <a:pPr>
-              <a:defRPr sz="1950" b="0">
-                <a:solidFill>
-                  <a:srgbClr val="52635B"/>
-                </a:solidFill>
-                <a:latin typeface="Arial"/>
-                <a:ea typeface="Arial"/>
-                <a:cs typeface="Arial"/>
-              </a:defRPr>
-            </a:pPr>
-            <a:r>
-              <a:rPr sz="1950" b="0">
-                <a:solidFill>
-                  <a:srgbClr val="52635B"/>
-                </a:solidFill>
-                <a:latin typeface="Arial"/>
-                <a:ea typeface="Arial"/>
-                <a:cs typeface="Arial"/>
-              </a:rPr>
-              <a:t>Inspect model responses and measure runtime.</a:t>
-            </a:r>
-          </a:p>
-        </p:txBody>
-      </p:sp>
-      <p:sp>
-        <p:nvSpPr>
-          <p:cNvPr id="3" name="">
-            <a:extLst xmlns:a="http://schemas.openxmlformats.org/drawingml/2006/main">
-              <a:ext uri="{FF2B5EF4-FFF2-40B4-BE49-F238E27FC236}">
-                <a16:creationId xmlns:a16="http://schemas.microsoft.com/office/drawing/2014/main" id="{339E4887-0413-4C00-8B76-96765999C083}"/>
-              </a:ext>
-            </a:extLst>
-          </p:cNvPr>
-          <p:cNvSpPr>
-            <a:spLocks xmlns:a="http://schemas.openxmlformats.org/drawingml/2006/main" noGrp="1"/>
-          </p:cNvSpPr>
-          <p:nvPr/>
-        </p:nvSpPr>
-        <p:spPr>
-          <a:xfrm xmlns:a="http://schemas.openxmlformats.org/drawingml/2006/main">
-            <a:off x="666750" y="6191250"/>
-            <a:ext cx="10287000" cy="419100"/>
-          </a:xfrm>
-          <a:prstGeom xmlns:a="http://schemas.openxmlformats.org/drawingml/2006/main" prst="rect">
-            <a:avLst/>
-          </a:prstGeom>
-          <a:noFill xmlns:a="http://schemas.openxmlformats.org/drawingml/2006/main"/>
-          <a:ln xmlns:a="http://schemas.openxmlformats.org/drawingml/2006/main" w="0">
-            <a:noFill/>
-          </a:ln>
-        </p:spPr>
-        <p:txBody>
-          <a:bodyPr xmlns:a="http://schemas.openxmlformats.org/drawingml/2006/main">
-            <a:noAutofit/>
-          </a:bodyPr>
-          <a:lstStyle xmlns:a="http://schemas.openxmlformats.org/drawingml/2006/main"/>
-          <a:p xmlns:a="http://schemas.openxmlformats.org/drawingml/2006/main">
-            <a:pPr>
-              <a:defRPr sz="1350" b="0">
-                <a:solidFill>
-                  <a:srgbClr val="52635B"/>
-                </a:solidFill>
-                <a:latin typeface="Arial"/>
-                <a:ea typeface="Arial"/>
-                <a:cs typeface="Arial"/>
-              </a:defRPr>
-            </a:pPr>
-            <a:r>
-              <a:rPr sz="1350" b="0">
-                <a:solidFill>
-                  <a:srgbClr val="52635B"/>
-                </a:solidFill>
-                <a:latin typeface="Arial"/>
-                <a:ea typeface="Arial"/>
-                <a:cs typeface="Arial"/>
-              </a:rPr>
-              <a:t>Compare the saved outputs and timings from your chosen workload.</a:t>
-            </a:r>
-          </a:p>
-        </p:txBody>
-      </p:sp>
-      <p:sp>
-        <p:nvSpPr>
-          <p:cNvPr id="4" name="">
-            <a:extLst xmlns:a="http://schemas.openxmlformats.org/drawingml/2006/main">
-              <a:ext uri="{FF2B5EF4-FFF2-40B4-BE49-F238E27FC236}">
-                <a16:creationId xmlns:a16="http://schemas.microsoft.com/office/drawing/2014/main" id="{64DA0A4E-9FB7-412C-8E78-DD5B5E930959}"/>
+                <a16:creationId xmlns:a16="http://schemas.microsoft.com/office/drawing/2014/main" id="{140CB928-978F-4D89-9BD3-1B354BD703D9}"/>
               </a:ext>
             </a:extLst>
           </p:cNvPr>
@@ -8449,10 +7195,10 @@
       </p:sp>
       <p:sp>
         <p:nvSpPr>
-          <p:cNvPr id="5" name="">
+          <p:cNvPr id="3" name="">
             <a:extLst xmlns:a="http://schemas.openxmlformats.org/drawingml/2006/main">
               <a:ext uri="{FF2B5EF4-FFF2-40B4-BE49-F238E27FC236}">
-                <a16:creationId xmlns:a16="http://schemas.microsoft.com/office/drawing/2014/main" id="{B1F58E43-C718-4831-9023-A1C37FD3DB98}"/>
+                <a16:creationId xmlns:a16="http://schemas.microsoft.com/office/drawing/2014/main" id="{550F984B-ECE6-474C-9294-685F937C5C13}"/>
               </a:ext>
             </a:extLst>
           </p:cNvPr>
@@ -8499,17 +7245,17 @@
                 <a:ea typeface="Arial"/>
                 <a:cs typeface="Arial"/>
               </a:rPr>
-              <a:t>Experiment 11</a:t>
-            </a:r>
-          </a:p>
-        </p:txBody>
-      </p:sp>
-      <p:sp>
-        <p:nvSpPr>
-          <p:cNvPr id="6" name="">
+              <a:t>Menu 11</a:t>
+            </a:r>
+          </a:p>
+        </p:txBody>
+      </p:sp>
+      <p:sp>
+        <p:nvSpPr>
+          <p:cNvPr id="4" name="">
             <a:extLst xmlns:a="http://schemas.openxmlformats.org/drawingml/2006/main">
               <a:ext uri="{FF2B5EF4-FFF2-40B4-BE49-F238E27FC236}">
-                <a16:creationId xmlns:a16="http://schemas.microsoft.com/office/drawing/2014/main" id="{993F2EA9-FD58-496A-AE58-8858A5F0B2B9}"/>
+                <a16:creationId xmlns:a16="http://schemas.microsoft.com/office/drawing/2014/main" id="{E62E4DED-969C-4F26-B420-E6E6EA6C9C1E}"/>
               </a:ext>
             </a:extLst>
           </p:cNvPr>
@@ -8586,10 +7332,10 @@
       </p:sp>
       <p:sp>
         <p:nvSpPr>
-          <p:cNvPr id="7" name="">
+          <p:cNvPr id="5" name="">
             <a:extLst xmlns:a="http://schemas.openxmlformats.org/drawingml/2006/main">
               <a:ext uri="{FF2B5EF4-FFF2-40B4-BE49-F238E27FC236}">
-                <a16:creationId xmlns:a16="http://schemas.microsoft.com/office/drawing/2014/main" id="{594E3212-F208-4853-9E2A-FBF32107D80A}"/>
+                <a16:creationId xmlns:a16="http://schemas.microsoft.com/office/drawing/2014/main" id="{F005D8A6-9A4E-4801-A651-A6F8F7F4347E}"/>
               </a:ext>
             </a:extLst>
           </p:cNvPr>
@@ -8666,10 +7412,10 @@
       </p:sp>
       <p:sp>
         <p:nvSpPr>
-          <p:cNvPr id="8" name="">
+          <p:cNvPr id="6" name="">
             <a:extLst xmlns:a="http://schemas.openxmlformats.org/drawingml/2006/main">
               <a:ext uri="{FF2B5EF4-FFF2-40B4-BE49-F238E27FC236}">
-                <a16:creationId xmlns:a16="http://schemas.microsoft.com/office/drawing/2014/main" id="{5F482AFA-9BA7-4C71-B211-EA2A60C3B0A3}"/>
+                <a16:creationId xmlns:a16="http://schemas.microsoft.com/office/drawing/2014/main" id="{1DDED668-2D72-4A57-A388-09DB00350FE9}"/>
               </a:ext>
             </a:extLst>
           </p:cNvPr>
@@ -8716,17 +7462,17 @@
                 <a:ea typeface="Arial"/>
                 <a:cs typeface="Arial"/>
               </a:rPr>
-              <a:t>Experiment 12</a:t>
-            </a:r>
-          </a:p>
-        </p:txBody>
-      </p:sp>
-      <p:sp>
-        <p:nvSpPr>
-          <p:cNvPr id="9" name="">
+              <a:t>Menu 12</a:t>
+            </a:r>
+          </a:p>
+        </p:txBody>
+      </p:sp>
+      <p:sp>
+        <p:nvSpPr>
+          <p:cNvPr id="7" name="">
             <a:extLst xmlns:a="http://schemas.openxmlformats.org/drawingml/2006/main">
               <a:ext uri="{FF2B5EF4-FFF2-40B4-BE49-F238E27FC236}">
-                <a16:creationId xmlns:a16="http://schemas.microsoft.com/office/drawing/2014/main" id="{1355499E-AEF7-42A5-8D38-1C6222DBD1C0}"/>
+                <a16:creationId xmlns:a16="http://schemas.microsoft.com/office/drawing/2014/main" id="{C02DF85B-CCD4-45AF-931F-575882218103}"/>
               </a:ext>
             </a:extLst>
           </p:cNvPr>
@@ -8803,10 +7549,10 @@
       </p:sp>
       <p:sp>
         <p:nvSpPr>
-          <p:cNvPr id="10" name="">
+          <p:cNvPr id="8" name="">
             <a:extLst xmlns:a="http://schemas.openxmlformats.org/drawingml/2006/main">
               <a:ext uri="{FF2B5EF4-FFF2-40B4-BE49-F238E27FC236}">
-                <a16:creationId xmlns:a16="http://schemas.microsoft.com/office/drawing/2014/main" id="{82C63AC1-1523-4EBB-B3ED-876F489F3169}"/>
+                <a16:creationId xmlns:a16="http://schemas.microsoft.com/office/drawing/2014/main" id="{4B519EAD-9509-4F4E-B0A2-822B64F3B501}"/>
               </a:ext>
             </a:extLst>
           </p:cNvPr>
@@ -8907,7 +7653,7 @@
     </p:spTree>
     <p:extLst>
       <p:ext uri="{BB962C8B-B14F-4D97-AF65-F5344CB8AC3E}">
-        <p14:creationId xmlns:p14="http://schemas.microsoft.com/office/powerpoint/2010/main" val="1855397704"/>
+        <p14:creationId xmlns:p14="http://schemas.microsoft.com/office/powerpoint/2010/main" val="101238428"/>
       </p:ext>
     </p:extLst>
   </p:cSld>

</xml_diff>

<commit_message>
Support ZIP updates, repeatable setup checklist and illustrated demo slides
</commit_message>
<xml_diff>
--- a/docs/Jetson_Nano_Local_AI_Experiments.pptx
+++ b/docs/Jetson_Nano_Local_AI_Experiments.pptx
@@ -2,19 +2,19 @@
 <file path=ppt/presentation.xml><?xml version="1.0" encoding="utf-8"?>
 <p:presentation xmlns:p="http://schemas.openxmlformats.org/presentationml/2006/main">
   <p:sldMasterIdLst>
-    <p:sldMasterId xmlns:r="http://schemas.openxmlformats.org/officeDocument/2006/relationships" id="2147483648" r:id="R8f1f77419b1441ae"/>
+    <p:sldMasterId xmlns:r="http://schemas.openxmlformats.org/officeDocument/2006/relationships" id="2147483648" r:id="R34fb2aa7261d4c4b"/>
   </p:sldMasterIdLst>
   <p:notesMasterIdLst>
-    <p:notesMasterId xmlns:r="http://schemas.openxmlformats.org/officeDocument/2006/relationships" r:id="R9cfc5cabd4ff48b5"/>
+    <p:notesMasterId xmlns:r="http://schemas.openxmlformats.org/officeDocument/2006/relationships" r:id="R00e48b11a0ed4e0e"/>
   </p:notesMasterIdLst>
   <p:sldIdLst>
-    <p:sldId xmlns:r="http://schemas.openxmlformats.org/officeDocument/2006/relationships" id="256" r:id="Ree27db097d734db5"/>
-    <p:sldId xmlns:r="http://schemas.openxmlformats.org/officeDocument/2006/relationships" id="257" r:id="R78959b4779f94b07"/>
-    <p:sldId xmlns:r="http://schemas.openxmlformats.org/officeDocument/2006/relationships" id="258" r:id="Rde7f496ac0c14395"/>
-    <p:sldId xmlns:r="http://schemas.openxmlformats.org/officeDocument/2006/relationships" id="259" r:id="R54e774a68c004e14"/>
-    <p:sldId xmlns:r="http://schemas.openxmlformats.org/officeDocument/2006/relationships" id="260" r:id="Rb5a2d6d9a33b421d"/>
-    <p:sldId xmlns:r="http://schemas.openxmlformats.org/officeDocument/2006/relationships" id="261" r:id="Rac6980f06c374dcd"/>
-    <p:sldId xmlns:r="http://schemas.openxmlformats.org/officeDocument/2006/relationships" id="262" r:id="R86c90283679c44a7"/>
+    <p:sldId xmlns:r="http://schemas.openxmlformats.org/officeDocument/2006/relationships" id="256" r:id="R7a16c796209f4805"/>
+    <p:sldId xmlns:r="http://schemas.openxmlformats.org/officeDocument/2006/relationships" id="257" r:id="Rca4c68bceb9e42f8"/>
+    <p:sldId xmlns:r="http://schemas.openxmlformats.org/officeDocument/2006/relationships" id="258" r:id="R0cb36b49d0954811"/>
+    <p:sldId xmlns:r="http://schemas.openxmlformats.org/officeDocument/2006/relationships" id="259" r:id="Rf1c163d1d6114913"/>
+    <p:sldId xmlns:r="http://schemas.openxmlformats.org/officeDocument/2006/relationships" id="260" r:id="R99cdb1abe69e47ed"/>
+    <p:sldId xmlns:r="http://schemas.openxmlformats.org/officeDocument/2006/relationships" id="261" r:id="Rdcbbe0b040984d5f"/>
+    <p:sldId xmlns:r="http://schemas.openxmlformats.org/officeDocument/2006/relationships" id="262" r:id="R75dcefaa57424e8e"/>
   </p:sldIdLst>
   <p:sldSz cx="12192000" cy="6858000"/>
   <p:notesSz cx="6858000" cy="9144000"/>
@@ -668,12 +668,7 @@
           <a:lstStyle xmlns:a="http://schemas.openxmlformats.org/drawingml/2006/main"/>
           <a:p xmlns:a="http://schemas.openxmlformats.org/drawingml/2006/main">
             <a:r>
-              <a:t>Code and menu: https://github.com/nileshsarkar-ai/JetsonNano-Demo/tree/master</a:t>
-            </a:r>
-          </a:p>
-          <a:p xmlns:a="http://schemas.openxmlformats.org/drawingml/2006/main">
-            <a:r>
-              <a:t>Scope and names: docs/EXPERIMENTS.md. Presenter notes: Physical Nano execution unverified. Software tests use mocks. Models may hallucinate; prompt separation and self-critique are not security or accuracy guarantees. Check against visible source facts. Camera projects use object detections plus text generation, not a vision-language model. Default setup does not need audio or external training. Rehearse power, cooling, camera capture, latency and answer quality on the actual board. This is the current local programme, not the historical 72-topic idea catalogue.</a:t>
+              <a:t>AI-generated illustrative scene, not a camera capture or measured detection result. Detection labels and bounding boxes come from labs/vision.py during live execution. Ask students which objects remain detectable after rotation or partial occlusion; no accuracy outcome is predetermined.</a:t>
             </a:r>
           </a:p>
         </p:txBody>
@@ -961,7 +956,7 @@
   </p:cSld>
   <p:clrMap bg1="lt1" tx1="dk1" bg2="lt2" tx2="dk2" accent1="accent1" accent2="accent2" accent3="accent3" accent4="accent4" accent5="accent5" accent6="accent6" hlink="hlink" folHlink="folHlink"/>
   <p:sldLayoutIdLst>
-    <p:sldLayoutId xmlns:r="http://schemas.openxmlformats.org/officeDocument/2006/relationships" id="2147483649" r:id="Ra66acb3724bb4bff"/>
+    <p:sldLayoutId xmlns:r="http://schemas.openxmlformats.org/officeDocument/2006/relationships" id="2147483649" r:id="R5c99be58d48f4117"/>
   </p:sldLayoutIdLst>
   <p:txStyles>
     <p:titleStyle>
@@ -1512,7 +1507,7 @@
           <p:cNvPr id="4" name="">
             <a:extLst xmlns:a="http://schemas.openxmlformats.org/drawingml/2006/main">
               <a:ext uri="{FF2B5EF4-FFF2-40B4-BE49-F238E27FC236}">
-                <a16:creationId xmlns:a16="http://schemas.microsoft.com/office/drawing/2014/main" id="{18BF824D-D129-4837-A225-703C0C1E866B}"/>
+                <a16:creationId xmlns:a16="http://schemas.microsoft.com/office/drawing/2014/main" id="{6B8204A1-FE74-4696-878B-B0C090E04798}"/>
               </a:ext>
             </a:extLst>
           </p:cNvPr>
@@ -1596,7 +1591,7 @@
           <p:nvPr/>
         </p:nvPicPr>
         <p:blipFill>
-          <a:blip xmlns:r="http://schemas.openxmlformats.org/officeDocument/2006/relationships" xmlns:a="http://schemas.openxmlformats.org/drawingml/2006/main" r:embed="Rd1399ac78ee44f44"/>
+          <a:blip xmlns:r="http://schemas.openxmlformats.org/officeDocument/2006/relationships" xmlns:a="http://schemas.openxmlformats.org/drawingml/2006/main" r:embed="R53b2c0b5b09f42ed"/>
           <a:stretch xmlns:a="http://schemas.openxmlformats.org/drawingml/2006/main"/>
         </p:blipFill>
         <p:spPr>
@@ -1614,7 +1609,7 @@
           <p:cNvPr id="3" name="">
             <a:extLst xmlns:a="http://schemas.openxmlformats.org/drawingml/2006/main">
               <a:ext uri="{FF2B5EF4-FFF2-40B4-BE49-F238E27FC236}">
-                <a16:creationId xmlns:a16="http://schemas.microsoft.com/office/drawing/2014/main" id="{4185CD49-713D-4B66-81E5-47B3D35AE1A5}"/>
+                <a16:creationId xmlns:a16="http://schemas.microsoft.com/office/drawing/2014/main" id="{6888DF4B-7B71-4D75-9BA0-421AAC5913E8}"/>
               </a:ext>
             </a:extLst>
           </p:cNvPr>
@@ -1715,7 +1710,7 @@
     </p:spTree>
     <p:extLst>
       <p:ext uri="{BB962C8B-B14F-4D97-AF65-F5344CB8AC3E}">
-        <p14:creationId xmlns:p14="http://schemas.microsoft.com/office/powerpoint/2010/main" val="1942301839"/>
+        <p14:creationId xmlns:p14="http://schemas.microsoft.com/office/powerpoint/2010/main" val="1976310032"/>
       </p:ext>
     </p:extLst>
   </p:cSld>
@@ -1746,7 +1741,7 @@
           <p:cNvPr id="10" name="">
             <a:extLst xmlns:a="http://schemas.openxmlformats.org/drawingml/2006/main">
               <a:ext uri="{FF2B5EF4-FFF2-40B4-BE49-F238E27FC236}">
-                <a16:creationId xmlns:a16="http://schemas.microsoft.com/office/drawing/2014/main" id="{0290E4CF-B054-4C26-90C5-C7F87839298E}"/>
+                <a16:creationId xmlns:a16="http://schemas.microsoft.com/office/drawing/2014/main" id="{2526F82A-9CF2-479B-9D20-9767254A04A6}"/>
               </a:ext>
             </a:extLst>
           </p:cNvPr>
@@ -1803,7 +1798,7 @@
           <p:cNvPr id="2" name="">
             <a:extLst xmlns:a="http://schemas.openxmlformats.org/drawingml/2006/main">
               <a:ext uri="{FF2B5EF4-FFF2-40B4-BE49-F238E27FC236}">
-                <a16:creationId xmlns:a16="http://schemas.microsoft.com/office/drawing/2014/main" id="{33540E8E-52C4-4CAC-86B6-798734FB0EB3}"/>
+                <a16:creationId xmlns:a16="http://schemas.microsoft.com/office/drawing/2014/main" id="{4C6967D6-C26D-4298-9996-865850F76995}"/>
               </a:ext>
             </a:extLst>
           </p:cNvPr>
@@ -1860,7 +1855,7 @@
           <p:cNvPr id="3" name="">
             <a:extLst xmlns:a="http://schemas.openxmlformats.org/drawingml/2006/main">
               <a:ext uri="{FF2B5EF4-FFF2-40B4-BE49-F238E27FC236}">
-                <a16:creationId xmlns:a16="http://schemas.microsoft.com/office/drawing/2014/main" id="{8420DD6D-7180-41FE-A06B-67E84EAB81AE}"/>
+                <a16:creationId xmlns:a16="http://schemas.microsoft.com/office/drawing/2014/main" id="{F0490142-68B9-46FC-95DB-D31EF10791B8}"/>
               </a:ext>
             </a:extLst>
           </p:cNvPr>
@@ -1917,7 +1912,7 @@
           <p:cNvPr id="4" name="">
             <a:extLst xmlns:a="http://schemas.openxmlformats.org/drawingml/2006/main">
               <a:ext uri="{FF2B5EF4-FFF2-40B4-BE49-F238E27FC236}">
-                <a16:creationId xmlns:a16="http://schemas.microsoft.com/office/drawing/2014/main" id="{8DE78796-6B11-4B33-83FA-988354D87B72}"/>
+                <a16:creationId xmlns:a16="http://schemas.microsoft.com/office/drawing/2014/main" id="{2C02CAB8-1338-46F7-8684-0337FBEACADE}"/>
               </a:ext>
             </a:extLst>
           </p:cNvPr>
@@ -1974,7 +1969,7 @@
           <p:cNvPr id="5" name="">
             <a:extLst xmlns:a="http://schemas.openxmlformats.org/drawingml/2006/main">
               <a:ext uri="{FF2B5EF4-FFF2-40B4-BE49-F238E27FC236}">
-                <a16:creationId xmlns:a16="http://schemas.microsoft.com/office/drawing/2014/main" id="{9F769CE5-4228-4546-BF36-0553B0980724}"/>
+                <a16:creationId xmlns:a16="http://schemas.microsoft.com/office/drawing/2014/main" id="{FF9FEEEB-27A6-4C01-9C93-A87649A5FC45}"/>
               </a:ext>
             </a:extLst>
           </p:cNvPr>
@@ -2031,7 +2026,7 @@
           <p:cNvPr id="6" name="">
             <a:extLst xmlns:a="http://schemas.openxmlformats.org/drawingml/2006/main">
               <a:ext uri="{FF2B5EF4-FFF2-40B4-BE49-F238E27FC236}">
-                <a16:creationId xmlns:a16="http://schemas.microsoft.com/office/drawing/2014/main" id="{2CB2DA93-EF69-4479-983B-AAD3559B8328}"/>
+                <a16:creationId xmlns:a16="http://schemas.microsoft.com/office/drawing/2014/main" id="{5B1AB6CA-DCD4-4BCD-8219-0B0B72EC5F9A}"/>
               </a:ext>
             </a:extLst>
           </p:cNvPr>
@@ -2088,7 +2083,7 @@
           <p:cNvPr id="7" name="">
             <a:extLst xmlns:a="http://schemas.openxmlformats.org/drawingml/2006/main">
               <a:ext uri="{FF2B5EF4-FFF2-40B4-BE49-F238E27FC236}">
-                <a16:creationId xmlns:a16="http://schemas.microsoft.com/office/drawing/2014/main" id="{E5352B48-38E6-4DBF-9F9B-C11AC9E90182}"/>
+                <a16:creationId xmlns:a16="http://schemas.microsoft.com/office/drawing/2014/main" id="{55087962-96EB-4253-90AF-2D1F83235EAA}"/>
               </a:ext>
             </a:extLst>
           </p:cNvPr>
@@ -2145,7 +2140,7 @@
           <p:cNvPr id="8" name="">
             <a:extLst xmlns:a="http://schemas.openxmlformats.org/drawingml/2006/main">
               <a:ext uri="{FF2B5EF4-FFF2-40B4-BE49-F238E27FC236}">
-                <a16:creationId xmlns:a16="http://schemas.microsoft.com/office/drawing/2014/main" id="{F9EECA27-115F-4C80-9571-DD103EA15692}"/>
+                <a16:creationId xmlns:a16="http://schemas.microsoft.com/office/drawing/2014/main" id="{D25A62AD-8526-42D2-B249-A30A278A6E29}"/>
               </a:ext>
             </a:extLst>
           </p:cNvPr>
@@ -2202,7 +2197,7 @@
           <p:cNvPr id="9" name="">
             <a:extLst xmlns:a="http://schemas.openxmlformats.org/drawingml/2006/main">
               <a:ext uri="{FF2B5EF4-FFF2-40B4-BE49-F238E27FC236}">
-                <a16:creationId xmlns:a16="http://schemas.microsoft.com/office/drawing/2014/main" id="{9826A751-2C5D-484A-BA17-BDE438D54107}"/>
+                <a16:creationId xmlns:a16="http://schemas.microsoft.com/office/drawing/2014/main" id="{2CEB3730-2229-4721-AF29-6BD9C4139975}"/>
               </a:ext>
             </a:extLst>
           </p:cNvPr>
@@ -2257,7 +2252,7 @@
     </p:spTree>
     <p:extLst>
       <p:ext uri="{BB962C8B-B14F-4D97-AF65-F5344CB8AC3E}">
-        <p14:creationId xmlns:p14="http://schemas.microsoft.com/office/powerpoint/2010/main" val="1604606088"/>
+        <p14:creationId xmlns:p14="http://schemas.microsoft.com/office/powerpoint/2010/main" val="675713208"/>
       </p:ext>
     </p:extLst>
   </p:cSld>
@@ -2288,7 +2283,7 @@
           <p:cNvPr id="9" name="">
             <a:extLst xmlns:a="http://schemas.openxmlformats.org/drawingml/2006/main">
               <a:ext uri="{FF2B5EF4-FFF2-40B4-BE49-F238E27FC236}">
-                <a16:creationId xmlns:a16="http://schemas.microsoft.com/office/drawing/2014/main" id="{808EDBB0-AF2B-40DD-9E64-7D3BB76A9DAA}"/>
+                <a16:creationId xmlns:a16="http://schemas.microsoft.com/office/drawing/2014/main" id="{E55109A8-B186-4379-91EB-0DCCE5A00047}"/>
               </a:ext>
             </a:extLst>
           </p:cNvPr>
@@ -2345,7 +2340,7 @@
           <p:cNvPr id="2" name="">
             <a:extLst xmlns:a="http://schemas.openxmlformats.org/drawingml/2006/main">
               <a:ext uri="{FF2B5EF4-FFF2-40B4-BE49-F238E27FC236}">
-                <a16:creationId xmlns:a16="http://schemas.microsoft.com/office/drawing/2014/main" id="{0AA390A1-1D67-476A-91B1-4263E55B0BB7}"/>
+                <a16:creationId xmlns:a16="http://schemas.microsoft.com/office/drawing/2014/main" id="{4C0AB812-B979-4C3F-BE82-D6BE3284D54D}"/>
               </a:ext>
             </a:extLst>
           </p:cNvPr>
@@ -2402,7 +2397,7 @@
           <p:cNvPr id="3" name="">
             <a:extLst xmlns:a="http://schemas.openxmlformats.org/drawingml/2006/main">
               <a:ext uri="{FF2B5EF4-FFF2-40B4-BE49-F238E27FC236}">
-                <a16:creationId xmlns:a16="http://schemas.microsoft.com/office/drawing/2014/main" id="{627C089E-D2E5-4164-A58C-1E21C3A1CAC0}"/>
+                <a16:creationId xmlns:a16="http://schemas.microsoft.com/office/drawing/2014/main" id="{5BCC955D-43D2-43A3-A612-9CB63F1E9290}"/>
               </a:ext>
             </a:extLst>
           </p:cNvPr>
@@ -2459,7 +2454,7 @@
           <p:cNvPr id="4" name="">
             <a:extLst xmlns:a="http://schemas.openxmlformats.org/drawingml/2006/main">
               <a:ext uri="{FF2B5EF4-FFF2-40B4-BE49-F238E27FC236}">
-                <a16:creationId xmlns:a16="http://schemas.microsoft.com/office/drawing/2014/main" id="{D32C9A22-874B-4A78-83EE-DB0B29915751}"/>
+                <a16:creationId xmlns:a16="http://schemas.microsoft.com/office/drawing/2014/main" id="{A63E9FEB-50BA-4756-9596-F1BD1644D5D2}"/>
               </a:ext>
             </a:extLst>
           </p:cNvPr>
@@ -2470,8 +2465,8 @@
         </p:nvSpPr>
         <p:spPr>
           <a:xfrm xmlns:a="http://schemas.openxmlformats.org/drawingml/2006/main">
-            <a:off x="714375" y="2238375"/>
-            <a:ext cx="10477500" cy="619125"/>
+            <a:off x="742950" y="2143125"/>
+            <a:ext cx="10572750" cy="952500"/>
           </a:xfrm>
           <a:prstGeom xmlns:a="http://schemas.openxmlformats.org/drawingml/2006/main" prst="rect">
             <a:avLst/>
@@ -2488,25 +2483,25 @@
           <a:lstStyle xmlns:a="http://schemas.openxmlformats.org/drawingml/2006/main"/>
           <a:p xmlns:a="http://schemas.openxmlformats.org/drawingml/2006/main">
             <a:pPr>
-              <a:defRPr sz="2850" b="1">
-                <a:solidFill>
-                  <a:srgbClr val="19332A"/>
-                </a:solidFill>
-                <a:latin typeface="Arial"/>
-                <a:ea typeface="Arial"/>
-                <a:cs typeface="Arial"/>
-              </a:defRPr>
-            </a:pPr>
-            <a:r>
-              <a:rPr sz="2850" b="1">
-                <a:solidFill>
-                  <a:srgbClr val="19332A"/>
-                </a:solidFill>
-                <a:latin typeface="Arial"/>
-                <a:ea typeface="Arial"/>
-                <a:cs typeface="Arial"/>
-              </a:rPr>
-              <a:t>SmolLM2-360M Instruct</a:t>
+              <a:defRPr sz="3675" b="1">
+                <a:solidFill>
+                  <a:srgbClr val="19332A"/>
+                </a:solidFill>
+                <a:latin typeface="Arial"/>
+                <a:ea typeface="Arial"/>
+                <a:cs typeface="Arial"/>
+              </a:defRPr>
+            </a:pPr>
+            <a:r>
+              <a:rPr sz="3675" b="1">
+                <a:solidFill>
+                  <a:srgbClr val="19332A"/>
+                </a:solidFill>
+                <a:latin typeface="Arial"/>
+                <a:ea typeface="Arial"/>
+                <a:cs typeface="Arial"/>
+              </a:rPr>
+              <a:t>“Why does a steel ship float?”</a:t>
             </a:r>
           </a:p>
         </p:txBody>
@@ -2516,7 +2511,7 @@
           <p:cNvPr id="5" name="">
             <a:extLst xmlns:a="http://schemas.openxmlformats.org/drawingml/2006/main">
               <a:ext uri="{FF2B5EF4-FFF2-40B4-BE49-F238E27FC236}">
-                <a16:creationId xmlns:a16="http://schemas.microsoft.com/office/drawing/2014/main" id="{C7414B40-7067-4328-8149-AD35412CEDE6}"/>
+                <a16:creationId xmlns:a16="http://schemas.microsoft.com/office/drawing/2014/main" id="{3D5F2A43-0956-4263-ABA0-AF7551D7041D}"/>
               </a:ext>
             </a:extLst>
           </p:cNvPr>
@@ -2527,8 +2522,8 @@
         </p:nvSpPr>
         <p:spPr>
           <a:xfrm xmlns:a="http://schemas.openxmlformats.org/drawingml/2006/main">
-            <a:off x="742950" y="3105150"/>
-            <a:ext cx="10334625" cy="857250"/>
+            <a:off x="762000" y="3524250"/>
+            <a:ext cx="10096500" cy="428625"/>
           </a:xfrm>
           <a:prstGeom xmlns:a="http://schemas.openxmlformats.org/drawingml/2006/main" prst="rect">
             <a:avLst/>
@@ -2545,25 +2540,25 @@
           <a:lstStyle xmlns:a="http://schemas.openxmlformats.org/drawingml/2006/main"/>
           <a:p xmlns:a="http://schemas.openxmlformats.org/drawingml/2006/main">
             <a:pPr>
-              <a:defRPr sz="2325" b="0">
-                <a:solidFill>
-                  <a:srgbClr val="52635B"/>
-                </a:solidFill>
-                <a:latin typeface="Arial"/>
-                <a:ea typeface="Arial"/>
-                <a:cs typeface="Arial"/>
-              </a:defRPr>
-            </a:pPr>
-            <a:r>
-              <a:rPr sz="2325" b="0">
-                <a:solidFill>
-                  <a:srgbClr val="52635B"/>
-                </a:solidFill>
-                <a:latin typeface="Arial"/>
-                <a:ea typeface="Arial"/>
-                <a:cs typeface="Arial"/>
-              </a:rPr>
-              <a:t>Ask a question, then follow up using the same conversation.</a:t>
+              <a:defRPr sz="1800" b="1">
+                <a:solidFill>
+                  <a:srgbClr val="397718"/>
+                </a:solidFill>
+                <a:latin typeface="Arial"/>
+                <a:ea typeface="Arial"/>
+                <a:cs typeface="Arial"/>
+              </a:defRPr>
+            </a:pPr>
+            <a:r>
+              <a:rPr sz="1800" b="1">
+                <a:solidFill>
+                  <a:srgbClr val="397718"/>
+                </a:solidFill>
+                <a:latin typeface="Arial"/>
+                <a:ea typeface="Arial"/>
+                <a:cs typeface="Arial"/>
+              </a:rPr>
+              <a:t>Follow-up prompts</a:t>
             </a:r>
           </a:p>
         </p:txBody>
@@ -2573,7 +2568,7 @@
           <p:cNvPr id="6" name="">
             <a:extLst xmlns:a="http://schemas.openxmlformats.org/drawingml/2006/main">
               <a:ext uri="{FF2B5EF4-FFF2-40B4-BE49-F238E27FC236}">
-                <a16:creationId xmlns:a16="http://schemas.microsoft.com/office/drawing/2014/main" id="{4F429311-D77C-4339-8198-FD988739D087}"/>
+                <a16:creationId xmlns:a16="http://schemas.microsoft.com/office/drawing/2014/main" id="{DC7DF2E9-2157-4980-A853-2E47DB704AA3}"/>
               </a:ext>
             </a:extLst>
           </p:cNvPr>
@@ -2584,8 +2579,8 @@
         </p:nvSpPr>
         <p:spPr>
           <a:xfrm xmlns:a="http://schemas.openxmlformats.org/drawingml/2006/main">
-            <a:off x="742950" y="4229100"/>
-            <a:ext cx="10001250" cy="428625"/>
+            <a:off x="762000" y="4048125"/>
+            <a:ext cx="10382250" cy="1238250"/>
           </a:xfrm>
           <a:prstGeom xmlns:a="http://schemas.openxmlformats.org/drawingml/2006/main" prst="rect">
             <a:avLst/>
@@ -2602,25 +2597,48 @@
           <a:lstStyle xmlns:a="http://schemas.openxmlformats.org/drawingml/2006/main"/>
           <a:p xmlns:a="http://schemas.openxmlformats.org/drawingml/2006/main">
             <a:pPr>
-              <a:defRPr sz="1800" b="1">
-                <a:solidFill>
-                  <a:srgbClr val="397718"/>
-                </a:solidFill>
-                <a:latin typeface="Arial"/>
-                <a:ea typeface="Arial"/>
-                <a:cs typeface="Arial"/>
-              </a:defRPr>
-            </a:pPr>
-            <a:r>
-              <a:rPr sz="1800" b="1">
-                <a:solidFill>
-                  <a:srgbClr val="397718"/>
-                </a:solidFill>
-                <a:latin typeface="Arial"/>
-                <a:ea typeface="Arial"/>
-                <a:cs typeface="Arial"/>
-              </a:rPr>
-              <a:t>Example prompt</a:t>
+              <a:defRPr sz="2550" b="0">
+                <a:solidFill>
+                  <a:srgbClr val="19332A"/>
+                </a:solidFill>
+                <a:latin typeface="Arial"/>
+                <a:ea typeface="Arial"/>
+                <a:cs typeface="Arial"/>
+              </a:defRPr>
+            </a:pPr>
+            <a:r>
+              <a:rPr sz="2550" b="0">
+                <a:solidFill>
+                  <a:srgbClr val="19332A"/>
+                </a:solidFill>
+                <a:latin typeface="Arial"/>
+                <a:ea typeface="Arial"/>
+                <a:cs typeface="Arial"/>
+              </a:rPr>
+              <a:t>“Explain it using an everyday analogy.”</a:t>
+            </a:r>
+          </a:p>
+          <a:p xmlns:a="http://schemas.openxmlformats.org/drawingml/2006/main">
+            <a:pPr>
+              <a:defRPr sz="2550" b="0">
+                <a:solidFill>
+                  <a:srgbClr val="19332A"/>
+                </a:solidFill>
+                <a:latin typeface="Arial"/>
+                <a:ea typeface="Arial"/>
+                <a:cs typeface="Arial"/>
+              </a:defRPr>
+            </a:pPr>
+            <a:r>
+              <a:rPr sz="2550" b="0">
+                <a:solidFill>
+                  <a:srgbClr val="19332A"/>
+                </a:solidFill>
+                <a:latin typeface="Arial"/>
+                <a:ea typeface="Arial"/>
+                <a:cs typeface="Arial"/>
+              </a:rPr>
+              <a:t>“Now explain it in two sentences.”</a:t>
             </a:r>
           </a:p>
         </p:txBody>
@@ -2630,7 +2648,7 @@
           <p:cNvPr id="7" name="">
             <a:extLst xmlns:a="http://schemas.openxmlformats.org/drawingml/2006/main">
               <a:ext uri="{FF2B5EF4-FFF2-40B4-BE49-F238E27FC236}">
-                <a16:creationId xmlns:a16="http://schemas.microsoft.com/office/drawing/2014/main" id="{A0CDD502-46EC-4EA3-A214-5DBA8CFE774C}"/>
+                <a16:creationId xmlns:a16="http://schemas.microsoft.com/office/drawing/2014/main" id="{F4380419-D6F6-4756-879B-85801640862D}"/>
               </a:ext>
             </a:extLst>
           </p:cNvPr>
@@ -2641,8 +2659,8 @@
         </p:nvSpPr>
         <p:spPr>
           <a:xfrm xmlns:a="http://schemas.openxmlformats.org/drawingml/2006/main">
-            <a:off x="742950" y="4714875"/>
-            <a:ext cx="10382250" cy="857250"/>
+            <a:off x="762000" y="5486400"/>
+            <a:ext cx="10382250" cy="428625"/>
           </a:xfrm>
           <a:prstGeom xmlns:a="http://schemas.openxmlformats.org/drawingml/2006/main" prst="rect">
             <a:avLst/>
@@ -2659,25 +2677,25 @@
           <a:lstStyle xmlns:a="http://schemas.openxmlformats.org/drawingml/2006/main"/>
           <a:p xmlns:a="http://schemas.openxmlformats.org/drawingml/2006/main">
             <a:pPr>
-              <a:defRPr sz="2250" b="0">
-                <a:solidFill>
-                  <a:srgbClr val="19332A"/>
-                </a:solidFill>
-                <a:latin typeface="Arial"/>
-                <a:ea typeface="Arial"/>
-                <a:cs typeface="Arial"/>
-              </a:defRPr>
-            </a:pPr>
-            <a:r>
-              <a:rPr sz="2250" b="0">
-                <a:solidFill>
-                  <a:srgbClr val="19332A"/>
-                </a:solidFill>
-                <a:latin typeface="Arial"/>
-                <a:ea typeface="Arial"/>
-                <a:cs typeface="Arial"/>
-              </a:rPr>
-              <a:t>“Explain why a boat floats. Then explain it to a ten-year-old.”</a:t>
+              <a:defRPr sz="1875" b="0">
+                <a:solidFill>
+                  <a:srgbClr val="52635B"/>
+                </a:solidFill>
+                <a:latin typeface="Arial"/>
+                <a:ea typeface="Arial"/>
+                <a:cs typeface="Arial"/>
+              </a:defRPr>
+            </a:pPr>
+            <a:r>
+              <a:rPr sz="1875" b="0">
+                <a:solidFill>
+                  <a:srgbClr val="52635B"/>
+                </a:solidFill>
+                <a:latin typeface="Arial"/>
+                <a:ea typeface="Arial"/>
+                <a:cs typeface="Arial"/>
+              </a:rPr>
+              <a:t>SmolLM2-360M Instruct uses the preceding conversation.</a:t>
             </a:r>
           </a:p>
         </p:txBody>
@@ -2687,7 +2705,7 @@
           <p:cNvPr id="8" name="">
             <a:extLst xmlns:a="http://schemas.openxmlformats.org/drawingml/2006/main">
               <a:ext uri="{FF2B5EF4-FFF2-40B4-BE49-F238E27FC236}">
-                <a16:creationId xmlns:a16="http://schemas.microsoft.com/office/drawing/2014/main" id="{B13FA955-27BB-4CD6-869F-075D1E7F9278}"/>
+                <a16:creationId xmlns:a16="http://schemas.microsoft.com/office/drawing/2014/main" id="{30564BD5-2C75-4930-ABF9-A95AAD1481FC}"/>
               </a:ext>
             </a:extLst>
           </p:cNvPr>
@@ -2698,8 +2716,8 @@
         </p:nvSpPr>
         <p:spPr>
           <a:xfrm xmlns:a="http://schemas.openxmlformats.org/drawingml/2006/main">
-            <a:off x="742950" y="5810250"/>
-            <a:ext cx="10382250" cy="400050"/>
+            <a:off x="762000" y="5972175"/>
+            <a:ext cx="10382250" cy="361950"/>
           </a:xfrm>
           <a:prstGeom xmlns:a="http://schemas.openxmlformats.org/drawingml/2006/main" prst="rect">
             <a:avLst/>
@@ -2734,7 +2752,7 @@
                 <a:ea typeface="Arial"/>
                 <a:cs typeface="Arial"/>
               </a:rPr>
-              <a:t>/reset clears the conversation.  /quit returns to the menu.</a:t>
+              <a:t>/reset clears history.  /quit returns to the menu.</a:t>
             </a:r>
           </a:p>
         </p:txBody>
@@ -2742,7 +2760,7 @@
     </p:spTree>
     <p:extLst>
       <p:ext uri="{BB962C8B-B14F-4D97-AF65-F5344CB8AC3E}">
-        <p14:creationId xmlns:p14="http://schemas.microsoft.com/office/powerpoint/2010/main" val="569457690"/>
+        <p14:creationId xmlns:p14="http://schemas.microsoft.com/office/powerpoint/2010/main" val="877704403"/>
       </p:ext>
     </p:extLst>
   </p:cSld>
@@ -2770,10 +2788,10 @@
       </p:grpSpPr>
       <p:sp>
         <p:nvSpPr>
-          <p:cNvPr id="7" name="">
+          <p:cNvPr id="9" name="">
             <a:extLst xmlns:a="http://schemas.openxmlformats.org/drawingml/2006/main">
               <a:ext uri="{FF2B5EF4-FFF2-40B4-BE49-F238E27FC236}">
-                <a16:creationId xmlns:a16="http://schemas.microsoft.com/office/drawing/2014/main" id="{6A5C69FD-BA21-476A-9CCB-30C8A2E084AB}"/>
+                <a16:creationId xmlns:a16="http://schemas.microsoft.com/office/drawing/2014/main" id="{1A118851-3213-492A-8416-31C17F78B841}"/>
               </a:ext>
             </a:extLst>
           </p:cNvPr>
@@ -2830,7 +2848,7 @@
           <p:cNvPr id="2" name="">
             <a:extLst xmlns:a="http://schemas.openxmlformats.org/drawingml/2006/main">
               <a:ext uri="{FF2B5EF4-FFF2-40B4-BE49-F238E27FC236}">
-                <a16:creationId xmlns:a16="http://schemas.microsoft.com/office/drawing/2014/main" id="{9FD13EC2-5E15-4342-98B7-311C8EAC9356}"/>
+                <a16:creationId xmlns:a16="http://schemas.microsoft.com/office/drawing/2014/main" id="{6EEB9B80-2B2C-4A3F-B2E6-43DAA89DE53E}"/>
               </a:ext>
             </a:extLst>
           </p:cNvPr>
@@ -2887,7 +2905,7 @@
           <p:cNvPr id="3" name="">
             <a:extLst xmlns:a="http://schemas.openxmlformats.org/drawingml/2006/main">
               <a:ext uri="{FF2B5EF4-FFF2-40B4-BE49-F238E27FC236}">
-                <a16:creationId xmlns:a16="http://schemas.microsoft.com/office/drawing/2014/main" id="{CCBDF6A7-B7C6-4AA6-BDB6-B25A2ED7622B}"/>
+                <a16:creationId xmlns:a16="http://schemas.microsoft.com/office/drawing/2014/main" id="{38453BDC-CDE5-4AED-A5A9-49DA3D0E8FA1}"/>
               </a:ext>
             </a:extLst>
           </p:cNvPr>
@@ -2944,7 +2962,7 @@
           <p:cNvPr id="4" name="">
             <a:extLst xmlns:a="http://schemas.openxmlformats.org/drawingml/2006/main">
               <a:ext uri="{FF2B5EF4-FFF2-40B4-BE49-F238E27FC236}">
-                <a16:creationId xmlns:a16="http://schemas.microsoft.com/office/drawing/2014/main" id="{EC417A50-22E8-4C4C-9083-F2C46CC2253B}"/>
+                <a16:creationId xmlns:a16="http://schemas.microsoft.com/office/drawing/2014/main" id="{6304F513-C78A-4091-9717-DEDBD1638DB6}"/>
               </a:ext>
             </a:extLst>
           </p:cNvPr>
@@ -2955,8 +2973,8 @@
         </p:nvSpPr>
         <p:spPr>
           <a:xfrm xmlns:a="http://schemas.openxmlformats.org/drawingml/2006/main">
-            <a:off x="714375" y="2238375"/>
-            <a:ext cx="10477500" cy="619125"/>
+            <a:off x="714375" y="2190750"/>
+            <a:ext cx="4667250" cy="619125"/>
           </a:xfrm>
           <a:prstGeom xmlns:a="http://schemas.openxmlformats.org/drawingml/2006/main" prst="rect">
             <a:avLst/>
@@ -2973,17 +2991,17 @@
           <a:lstStyle xmlns:a="http://schemas.openxmlformats.org/drawingml/2006/main"/>
           <a:p xmlns:a="http://schemas.openxmlformats.org/drawingml/2006/main">
             <a:pPr>
-              <a:defRPr sz="2850" b="1">
-                <a:solidFill>
-                  <a:srgbClr val="19332A"/>
-                </a:solidFill>
-                <a:latin typeface="Arial"/>
-                <a:ea typeface="Arial"/>
-                <a:cs typeface="Arial"/>
-              </a:defRPr>
-            </a:pPr>
-            <a:r>
-              <a:rPr sz="2850" b="1">
+              <a:defRPr sz="2550" b="1">
+                <a:solidFill>
+                  <a:srgbClr val="19332A"/>
+                </a:solidFill>
+                <a:latin typeface="Arial"/>
+                <a:ea typeface="Arial"/>
+                <a:cs typeface="Arial"/>
+              </a:defRPr>
+            </a:pPr>
+            <a:r>
+              <a:rPr sz="2550" b="1">
                 <a:solidFill>
                   <a:srgbClr val="19332A"/>
                 </a:solidFill>
@@ -3001,7 +3019,7 @@
           <p:cNvPr id="5" name="">
             <a:extLst xmlns:a="http://schemas.openxmlformats.org/drawingml/2006/main">
               <a:ext uri="{FF2B5EF4-FFF2-40B4-BE49-F238E27FC236}">
-                <a16:creationId xmlns:a16="http://schemas.microsoft.com/office/drawing/2014/main" id="{F83D84A3-2D86-436E-B45B-E8D52E626810}"/>
+                <a16:creationId xmlns:a16="http://schemas.microsoft.com/office/drawing/2014/main" id="{1174FE26-A9FF-44DB-A59D-DC48E7D4CB6E}"/>
               </a:ext>
             </a:extLst>
           </p:cNvPr>
@@ -3012,8 +3030,8 @@
         </p:nvSpPr>
         <p:spPr>
           <a:xfrm xmlns:a="http://schemas.openxmlformats.org/drawingml/2006/main">
-            <a:off x="742950" y="3162300"/>
-            <a:ext cx="10382250" cy="1238250"/>
+            <a:off x="742950" y="3124200"/>
+            <a:ext cx="4667250" cy="904875"/>
           </a:xfrm>
           <a:prstGeom xmlns:a="http://schemas.openxmlformats.org/drawingml/2006/main" prst="rect">
             <a:avLst/>
@@ -3048,7 +3066,7 @@
                 <a:ea typeface="Arial"/>
                 <a:cs typeface="Arial"/>
               </a:rPr>
-              <a:t>Place a cup, bottle or book in view.</a:t>
+              <a:t>Place everyday objects</a:t>
             </a:r>
           </a:p>
           <a:p xmlns:a="http://schemas.openxmlformats.org/drawingml/2006/main">
@@ -3071,7 +3089,7 @@
                 <a:ea typeface="Arial"/>
                 <a:cs typeface="Arial"/>
               </a:rPr>
-              <a:t>The detector labels objects and draws their bounding boxes.</a:t>
+              <a:t>in the camera’s view.</a:t>
             </a:r>
           </a:p>
         </p:txBody>
@@ -3081,7 +3099,7 @@
           <p:cNvPr id="6" name="">
             <a:extLst xmlns:a="http://schemas.openxmlformats.org/drawingml/2006/main">
               <a:ext uri="{FF2B5EF4-FFF2-40B4-BE49-F238E27FC236}">
-                <a16:creationId xmlns:a16="http://schemas.microsoft.com/office/drawing/2014/main" id="{73105845-3C01-4EA7-9D71-67A70EDD4A67}"/>
+                <a16:creationId xmlns:a16="http://schemas.microsoft.com/office/drawing/2014/main" id="{575CCBE0-3033-439B-8EF6-3E4343F55DDE}"/>
               </a:ext>
             </a:extLst>
           </p:cNvPr>
@@ -3092,8 +3110,8 @@
         </p:nvSpPr>
         <p:spPr>
           <a:xfrm xmlns:a="http://schemas.openxmlformats.org/drawingml/2006/main">
-            <a:off x="742950" y="4857750"/>
-            <a:ext cx="10382250" cy="809625"/>
+            <a:off x="742950" y="4467225"/>
+            <a:ext cx="4667250" cy="1238250"/>
           </a:xfrm>
           <a:prstGeom xmlns:a="http://schemas.openxmlformats.org/drawingml/2006/main" prst="rect">
             <a:avLst/>
@@ -3128,7 +3146,132 @@
                 <a:ea typeface="Arial"/>
                 <a:cs typeface="Arial"/>
               </a:rPr>
-              <a:t>Move an object and observe the changing detections.</a:t>
+              <a:t>Move one object.</a:t>
+            </a:r>
+          </a:p>
+          <a:p xmlns:a="http://schemas.openxmlformats.org/drawingml/2006/main">
+            <a:pPr>
+              <a:defRPr sz="2250" b="0">
+                <a:solidFill>
+                  <a:srgbClr val="19332A"/>
+                </a:solidFill>
+                <a:latin typeface="Arial"/>
+                <a:ea typeface="Arial"/>
+                <a:cs typeface="Arial"/>
+              </a:defRPr>
+            </a:pPr>
+            <a:r>
+              <a:rPr sz="2250" b="0">
+                <a:solidFill>
+                  <a:srgbClr val="19332A"/>
+                </a:solidFill>
+                <a:latin typeface="Arial"/>
+                <a:ea typeface="Arial"/>
+                <a:cs typeface="Arial"/>
+              </a:rPr>
+              <a:t>Turn the book sideways.</a:t>
+            </a:r>
+          </a:p>
+          <a:p xmlns:a="http://schemas.openxmlformats.org/drawingml/2006/main">
+            <a:pPr>
+              <a:defRPr sz="2250" b="0">
+                <a:solidFill>
+                  <a:srgbClr val="19332A"/>
+                </a:solidFill>
+                <a:latin typeface="Arial"/>
+                <a:ea typeface="Arial"/>
+                <a:cs typeface="Arial"/>
+              </a:defRPr>
+            </a:pPr>
+            <a:r>
+              <a:rPr sz="2250" b="0">
+                <a:solidFill>
+                  <a:srgbClr val="19332A"/>
+                </a:solidFill>
+                <a:latin typeface="Arial"/>
+                <a:ea typeface="Arial"/>
+                <a:cs typeface="Arial"/>
+              </a:rPr>
+              <a:t>Partly hide the cup.</a:t>
+            </a:r>
+          </a:p>
+        </p:txBody>
+      </p:sp>
+      <p:pic>
+        <p:nvPicPr>
+          <p:cNvPr id="15" name=""/>
+          <p:cNvPicPr>
+            <a:picLocks xmlns:a="http://schemas.openxmlformats.org/drawingml/2006/main" noChangeAspect="1"/>
+          </p:cNvPicPr>
+          <p:nvPr/>
+        </p:nvPicPr>
+        <p:blipFill>
+          <a:blip xmlns:r="http://schemas.openxmlformats.org/officeDocument/2006/relationships" xmlns:a="http://schemas.openxmlformats.org/drawingml/2006/main" r:embed="R73094318d98b4e52"/>
+          <a:stretch xmlns:a="http://schemas.openxmlformats.org/drawingml/2006/main"/>
+        </p:blipFill>
+        <p:spPr>
+          <a:xfrm xmlns:a="http://schemas.openxmlformats.org/drawingml/2006/main">
+            <a:off x="5500688" y="2095500"/>
+            <a:ext cx="6143625" cy="4095750"/>
+          </a:xfrm>
+          <a:prstGeom xmlns:a="http://schemas.openxmlformats.org/drawingml/2006/main" prst="rect">
+            <a:avLst/>
+          </a:prstGeom>
+        </p:spPr>
+      </p:pic>
+      <p:sp>
+        <p:nvSpPr>
+          <p:cNvPr id="8" name="">
+            <a:extLst xmlns:a="http://schemas.openxmlformats.org/drawingml/2006/main">
+              <a:ext uri="{FF2B5EF4-FFF2-40B4-BE49-F238E27FC236}">
+                <a16:creationId xmlns:a16="http://schemas.microsoft.com/office/drawing/2014/main" id="{E26C5B5A-0CCB-4207-917E-465A315814D4}"/>
+              </a:ext>
+            </a:extLst>
+          </p:cNvPr>
+          <p:cNvSpPr>
+            <a:spLocks xmlns:a="http://schemas.openxmlformats.org/drawingml/2006/main" noGrp="1"/>
+          </p:cNvSpPr>
+          <p:nvPr/>
+        </p:nvSpPr>
+        <p:spPr>
+          <a:xfrm xmlns:a="http://schemas.openxmlformats.org/drawingml/2006/main">
+            <a:off x="7762875" y="6162675"/>
+            <a:ext cx="3714750" cy="304800"/>
+          </a:xfrm>
+          <a:prstGeom xmlns:a="http://schemas.openxmlformats.org/drawingml/2006/main" prst="rect">
+            <a:avLst/>
+          </a:prstGeom>
+          <a:noFill xmlns:a="http://schemas.openxmlformats.org/drawingml/2006/main"/>
+          <a:ln xmlns:a="http://schemas.openxmlformats.org/drawingml/2006/main" w="0">
+            <a:noFill/>
+          </a:ln>
+        </p:spPr>
+        <p:txBody>
+          <a:bodyPr xmlns:a="http://schemas.openxmlformats.org/drawingml/2006/main">
+            <a:noAutofit/>
+          </a:bodyPr>
+          <a:lstStyle xmlns:a="http://schemas.openxmlformats.org/drawingml/2006/main"/>
+          <a:p xmlns:a="http://schemas.openxmlformats.org/drawingml/2006/main">
+            <a:pPr>
+              <a:defRPr sz="1425" b="0">
+                <a:solidFill>
+                  <a:srgbClr val="52635B"/>
+                </a:solidFill>
+                <a:latin typeface="Arial"/>
+                <a:ea typeface="Arial"/>
+                <a:cs typeface="Arial"/>
+              </a:defRPr>
+            </a:pPr>
+            <a:r>
+              <a:rPr sz="1425" b="0">
+                <a:solidFill>
+                  <a:srgbClr val="52635B"/>
+                </a:solidFill>
+                <a:latin typeface="Arial"/>
+                <a:ea typeface="Arial"/>
+                <a:cs typeface="Arial"/>
+              </a:rPr>
+              <a:t>Illustrative scene</a:t>
             </a:r>
           </a:p>
         </p:txBody>
@@ -3136,7 +3279,7 @@
     </p:spTree>
     <p:extLst>
       <p:ext uri="{BB962C8B-B14F-4D97-AF65-F5344CB8AC3E}">
-        <p14:creationId xmlns:p14="http://schemas.microsoft.com/office/powerpoint/2010/main" val="824578974"/>
+        <p14:creationId xmlns:p14="http://schemas.microsoft.com/office/powerpoint/2010/main" val="1825567712"/>
       </p:ext>
     </p:extLst>
   </p:cSld>
@@ -3167,7 +3310,7 @@
           <p:cNvPr id="8" name="">
             <a:extLst xmlns:a="http://schemas.openxmlformats.org/drawingml/2006/main">
               <a:ext uri="{FF2B5EF4-FFF2-40B4-BE49-F238E27FC236}">
-                <a16:creationId xmlns:a16="http://schemas.microsoft.com/office/drawing/2014/main" id="{4475033E-A27A-47E0-8256-BF1C0BE8DB6C}"/>
+                <a16:creationId xmlns:a16="http://schemas.microsoft.com/office/drawing/2014/main" id="{F872C1F8-979B-453D-83F8-AC8109025A40}"/>
               </a:ext>
             </a:extLst>
           </p:cNvPr>
@@ -3224,7 +3367,7 @@
           <p:cNvPr id="2" name="">
             <a:extLst xmlns:a="http://schemas.openxmlformats.org/drawingml/2006/main">
               <a:ext uri="{FF2B5EF4-FFF2-40B4-BE49-F238E27FC236}">
-                <a16:creationId xmlns:a16="http://schemas.microsoft.com/office/drawing/2014/main" id="{7B83659D-D52C-4036-8B57-AF70B50C5704}"/>
+                <a16:creationId xmlns:a16="http://schemas.microsoft.com/office/drawing/2014/main" id="{E3ED2FC5-C5E7-422A-9381-EABB7D4552D7}"/>
               </a:ext>
             </a:extLst>
           </p:cNvPr>
@@ -3281,7 +3424,7 @@
           <p:cNvPr id="3" name="">
             <a:extLst xmlns:a="http://schemas.openxmlformats.org/drawingml/2006/main">
               <a:ext uri="{FF2B5EF4-FFF2-40B4-BE49-F238E27FC236}">
-                <a16:creationId xmlns:a16="http://schemas.microsoft.com/office/drawing/2014/main" id="{A34D4FC5-0A2E-4008-BA8D-6C2C6E7D3E42}"/>
+                <a16:creationId xmlns:a16="http://schemas.microsoft.com/office/drawing/2014/main" id="{DC3954B1-F31E-472B-B935-F9BADCDEBF58}"/>
               </a:ext>
             </a:extLst>
           </p:cNvPr>
@@ -3338,7 +3481,7 @@
           <p:cNvPr id="4" name="">
             <a:extLst xmlns:a="http://schemas.openxmlformats.org/drawingml/2006/main">
               <a:ext uri="{FF2B5EF4-FFF2-40B4-BE49-F238E27FC236}">
-                <a16:creationId xmlns:a16="http://schemas.microsoft.com/office/drawing/2014/main" id="{F74A1BA1-9BB7-4207-9C46-61A732751505}"/>
+                <a16:creationId xmlns:a16="http://schemas.microsoft.com/office/drawing/2014/main" id="{79A57515-2A72-4849-BF55-26087EF11690}"/>
               </a:ext>
             </a:extLst>
           </p:cNvPr>
@@ -3395,7 +3538,7 @@
           <p:cNvPr id="5" name="">
             <a:extLst xmlns:a="http://schemas.openxmlformats.org/drawingml/2006/main">
               <a:ext uri="{FF2B5EF4-FFF2-40B4-BE49-F238E27FC236}">
-                <a16:creationId xmlns:a16="http://schemas.microsoft.com/office/drawing/2014/main" id="{E4CBA464-A3B6-4BEE-A228-9BC7CADC63F9}"/>
+                <a16:creationId xmlns:a16="http://schemas.microsoft.com/office/drawing/2014/main" id="{266E8881-10D9-4EB1-AB44-E5389713BAC0}"/>
               </a:ext>
             </a:extLst>
           </p:cNvPr>
@@ -3452,7 +3595,7 @@
           <p:cNvPr id="6" name="">
             <a:extLst xmlns:a="http://schemas.openxmlformats.org/drawingml/2006/main">
               <a:ext uri="{FF2B5EF4-FFF2-40B4-BE49-F238E27FC236}">
-                <a16:creationId xmlns:a16="http://schemas.microsoft.com/office/drawing/2014/main" id="{5E56824F-4581-4FBD-BE5D-E8496C090915}"/>
+                <a16:creationId xmlns:a16="http://schemas.microsoft.com/office/drawing/2014/main" id="{43D78CE4-4746-48EE-8E16-635BB773E516}"/>
               </a:ext>
             </a:extLst>
           </p:cNvPr>
@@ -3509,7 +3652,7 @@
           <p:cNvPr id="7" name="">
             <a:extLst xmlns:a="http://schemas.openxmlformats.org/drawingml/2006/main">
               <a:ext uri="{FF2B5EF4-FFF2-40B4-BE49-F238E27FC236}">
-                <a16:creationId xmlns:a16="http://schemas.microsoft.com/office/drawing/2014/main" id="{71AA32EB-357C-4FB9-9502-E52656974985}"/>
+                <a16:creationId xmlns:a16="http://schemas.microsoft.com/office/drawing/2014/main" id="{64AD9018-6EC6-439C-AC54-6D91A46DC7A0}"/>
               </a:ext>
             </a:extLst>
           </p:cNvPr>
@@ -3564,7 +3707,7 @@
     </p:spTree>
     <p:extLst>
       <p:ext uri="{BB962C8B-B14F-4D97-AF65-F5344CB8AC3E}">
-        <p14:creationId xmlns:p14="http://schemas.microsoft.com/office/powerpoint/2010/main" val="301894402"/>
+        <p14:creationId xmlns:p14="http://schemas.microsoft.com/office/powerpoint/2010/main" val="423495299"/>
       </p:ext>
     </p:extLst>
   </p:cSld>
@@ -3595,7 +3738,7 @@
           <p:cNvPr id="7" name="">
             <a:extLst xmlns:a="http://schemas.openxmlformats.org/drawingml/2006/main">
               <a:ext uri="{FF2B5EF4-FFF2-40B4-BE49-F238E27FC236}">
-                <a16:creationId xmlns:a16="http://schemas.microsoft.com/office/drawing/2014/main" id="{FB2D2FD4-53BB-41CC-9106-A6842E39870B}"/>
+                <a16:creationId xmlns:a16="http://schemas.microsoft.com/office/drawing/2014/main" id="{057EB73E-4C85-4DBC-9A5D-C4E21F7FF413}"/>
               </a:ext>
             </a:extLst>
           </p:cNvPr>
@@ -3652,7 +3795,7 @@
           <p:cNvPr id="2" name="">
             <a:extLst xmlns:a="http://schemas.openxmlformats.org/drawingml/2006/main">
               <a:ext uri="{FF2B5EF4-FFF2-40B4-BE49-F238E27FC236}">
-                <a16:creationId xmlns:a16="http://schemas.microsoft.com/office/drawing/2014/main" id="{82DBC34A-3B8A-4705-A6B2-A8857F401743}"/>
+                <a16:creationId xmlns:a16="http://schemas.microsoft.com/office/drawing/2014/main" id="{43A548ED-0E58-4B8D-B05E-AF8862AD9E90}"/>
               </a:ext>
             </a:extLst>
           </p:cNvPr>
@@ -3709,7 +3852,7 @@
           <p:cNvPr id="3" name="">
             <a:extLst xmlns:a="http://schemas.openxmlformats.org/drawingml/2006/main">
               <a:ext uri="{FF2B5EF4-FFF2-40B4-BE49-F238E27FC236}">
-                <a16:creationId xmlns:a16="http://schemas.microsoft.com/office/drawing/2014/main" id="{B4E3B92C-DCED-44A2-B118-ABBA5DA78EB8}"/>
+                <a16:creationId xmlns:a16="http://schemas.microsoft.com/office/drawing/2014/main" id="{4F665751-E510-46DA-91DC-4B858BA826BC}"/>
               </a:ext>
             </a:extLst>
           </p:cNvPr>
@@ -3766,7 +3909,7 @@
           <p:cNvPr id="4" name="">
             <a:extLst xmlns:a="http://schemas.openxmlformats.org/drawingml/2006/main">
               <a:ext uri="{FF2B5EF4-FFF2-40B4-BE49-F238E27FC236}">
-                <a16:creationId xmlns:a16="http://schemas.microsoft.com/office/drawing/2014/main" id="{FF746789-0AEE-4797-BDA3-7ECB1EFBE81D}"/>
+                <a16:creationId xmlns:a16="http://schemas.microsoft.com/office/drawing/2014/main" id="{B3B66B94-2114-44EE-93B9-23B82F98DCC6}"/>
               </a:ext>
             </a:extLst>
           </p:cNvPr>
@@ -3869,7 +4012,7 @@
           <p:cNvPr id="5" name="">
             <a:extLst xmlns:a="http://schemas.openxmlformats.org/drawingml/2006/main">
               <a:ext uri="{FF2B5EF4-FFF2-40B4-BE49-F238E27FC236}">
-                <a16:creationId xmlns:a16="http://schemas.microsoft.com/office/drawing/2014/main" id="{27BBA290-2F8B-442B-8627-C93B2988F02F}"/>
+                <a16:creationId xmlns:a16="http://schemas.microsoft.com/office/drawing/2014/main" id="{C853A715-EC9F-4A13-A97F-76534F5CA27F}"/>
               </a:ext>
             </a:extLst>
           </p:cNvPr>
@@ -3926,7 +4069,7 @@
           <p:cNvPr id="6" name="">
             <a:extLst xmlns:a="http://schemas.openxmlformats.org/drawingml/2006/main">
               <a:ext uri="{FF2B5EF4-FFF2-40B4-BE49-F238E27FC236}">
-                <a16:creationId xmlns:a16="http://schemas.microsoft.com/office/drawing/2014/main" id="{C028B8CF-D604-4CBD-AEB8-C723F80E830D}"/>
+                <a16:creationId xmlns:a16="http://schemas.microsoft.com/office/drawing/2014/main" id="{C82C83B5-19D1-4B9F-A417-32A020427752}"/>
               </a:ext>
             </a:extLst>
           </p:cNvPr>
@@ -4027,7 +4170,7 @@
     </p:spTree>
     <p:extLst>
       <p:ext uri="{BB962C8B-B14F-4D97-AF65-F5344CB8AC3E}">
-        <p14:creationId xmlns:p14="http://schemas.microsoft.com/office/powerpoint/2010/main" val="475029624"/>
+        <p14:creationId xmlns:p14="http://schemas.microsoft.com/office/powerpoint/2010/main" val="1818541106"/>
       </p:ext>
     </p:extLst>
   </p:cSld>
@@ -4058,7 +4201,7 @@
           <p:cNvPr id="16" name="">
             <a:extLst xmlns:a="http://schemas.openxmlformats.org/drawingml/2006/main">
               <a:ext uri="{FF2B5EF4-FFF2-40B4-BE49-F238E27FC236}">
-                <a16:creationId xmlns:a16="http://schemas.microsoft.com/office/drawing/2014/main" id="{2F794FE6-D3BF-4E6A-8043-2CE914CE13B3}"/>
+                <a16:creationId xmlns:a16="http://schemas.microsoft.com/office/drawing/2014/main" id="{570841B2-C630-41CA-B199-25AE954FAAA3}"/>
               </a:ext>
             </a:extLst>
           </p:cNvPr>
@@ -4115,7 +4258,7 @@
           <p:cNvPr id="2" name="">
             <a:extLst xmlns:a="http://schemas.openxmlformats.org/drawingml/2006/main">
               <a:ext uri="{FF2B5EF4-FFF2-40B4-BE49-F238E27FC236}">
-                <a16:creationId xmlns:a16="http://schemas.microsoft.com/office/drawing/2014/main" id="{855F9725-1ABF-4C2B-A926-5178BB25C8B5}"/>
+                <a16:creationId xmlns:a16="http://schemas.microsoft.com/office/drawing/2014/main" id="{D2CF4FB4-9EC0-4CA8-9342-79ED00AC5988}"/>
               </a:ext>
             </a:extLst>
           </p:cNvPr>
@@ -4172,7 +4315,7 @@
           <p:cNvPr id="3" name="">
             <a:extLst xmlns:a="http://schemas.openxmlformats.org/drawingml/2006/main">
               <a:ext uri="{FF2B5EF4-FFF2-40B4-BE49-F238E27FC236}">
-                <a16:creationId xmlns:a16="http://schemas.microsoft.com/office/drawing/2014/main" id="{E0E94DC1-8F88-4BD8-8D16-87BAB0F82BA4}"/>
+                <a16:creationId xmlns:a16="http://schemas.microsoft.com/office/drawing/2014/main" id="{75BC5BDF-17D0-4FDE-9075-19BCBA997C89}"/>
               </a:ext>
             </a:extLst>
           </p:cNvPr>
@@ -4229,7 +4372,7 @@
           <p:cNvPr id="4" name="">
             <a:extLst xmlns:a="http://schemas.openxmlformats.org/drawingml/2006/main">
               <a:ext uri="{FF2B5EF4-FFF2-40B4-BE49-F238E27FC236}">
-                <a16:creationId xmlns:a16="http://schemas.microsoft.com/office/drawing/2014/main" id="{6B1C4959-E46E-4B04-B4E7-1ABD3FB65B17}"/>
+                <a16:creationId xmlns:a16="http://schemas.microsoft.com/office/drawing/2014/main" id="{1BE126B1-3F1A-486D-8D15-9D8B1CC1D9AA}"/>
               </a:ext>
             </a:extLst>
           </p:cNvPr>
@@ -4286,7 +4429,7 @@
           <p:cNvPr id="5" name="">
             <a:extLst xmlns:a="http://schemas.openxmlformats.org/drawingml/2006/main">
               <a:ext uri="{FF2B5EF4-FFF2-40B4-BE49-F238E27FC236}">
-                <a16:creationId xmlns:a16="http://schemas.microsoft.com/office/drawing/2014/main" id="{37B03A69-42A1-4513-B2FE-9E454172B2D9}"/>
+                <a16:creationId xmlns:a16="http://schemas.microsoft.com/office/drawing/2014/main" id="{EC4D252E-B47C-4D12-8429-80441C884D53}"/>
               </a:ext>
             </a:extLst>
           </p:cNvPr>
@@ -4343,7 +4486,7 @@
           <p:cNvPr id="6" name="">
             <a:extLst xmlns:a="http://schemas.openxmlformats.org/drawingml/2006/main">
               <a:ext uri="{FF2B5EF4-FFF2-40B4-BE49-F238E27FC236}">
-                <a16:creationId xmlns:a16="http://schemas.microsoft.com/office/drawing/2014/main" id="{F5FDACF7-C2D1-4D5D-AC7E-D12F28C96C59}"/>
+                <a16:creationId xmlns:a16="http://schemas.microsoft.com/office/drawing/2014/main" id="{BD6ECBA0-27C3-4771-AF14-2830CAB11714}"/>
               </a:ext>
             </a:extLst>
           </p:cNvPr>
@@ -4400,7 +4543,7 @@
           <p:cNvPr id="7" name="">
             <a:extLst xmlns:a="http://schemas.openxmlformats.org/drawingml/2006/main">
               <a:ext uri="{FF2B5EF4-FFF2-40B4-BE49-F238E27FC236}">
-                <a16:creationId xmlns:a16="http://schemas.microsoft.com/office/drawing/2014/main" id="{6A13E159-5DEE-4A3B-8EB8-0AFF33B5E462}"/>
+                <a16:creationId xmlns:a16="http://schemas.microsoft.com/office/drawing/2014/main" id="{02AC120B-C9CF-4E09-A1AA-C86A1BDCFB7E}"/>
               </a:ext>
             </a:extLst>
           </p:cNvPr>
@@ -4457,7 +4600,7 @@
           <p:cNvPr id="8" name="">
             <a:extLst xmlns:a="http://schemas.openxmlformats.org/drawingml/2006/main">
               <a:ext uri="{FF2B5EF4-FFF2-40B4-BE49-F238E27FC236}">
-                <a16:creationId xmlns:a16="http://schemas.microsoft.com/office/drawing/2014/main" id="{1535AE7B-BC4C-473B-ACD3-B02F7A9DA255}"/>
+                <a16:creationId xmlns:a16="http://schemas.microsoft.com/office/drawing/2014/main" id="{9398397A-C996-4FC0-9E6F-8DA971A9B10F}"/>
               </a:ext>
             </a:extLst>
           </p:cNvPr>
@@ -4514,7 +4657,7 @@
           <p:cNvPr id="9" name="">
             <a:extLst xmlns:a="http://schemas.openxmlformats.org/drawingml/2006/main">
               <a:ext uri="{FF2B5EF4-FFF2-40B4-BE49-F238E27FC236}">
-                <a16:creationId xmlns:a16="http://schemas.microsoft.com/office/drawing/2014/main" id="{85F70AF5-1CF6-41FD-8B6A-9D4F7481F034}"/>
+                <a16:creationId xmlns:a16="http://schemas.microsoft.com/office/drawing/2014/main" id="{6819CFB7-8114-40B7-BF77-34EAA0450718}"/>
               </a:ext>
             </a:extLst>
           </p:cNvPr>
@@ -4571,7 +4714,7 @@
           <p:cNvPr id="10" name="">
             <a:extLst xmlns:a="http://schemas.openxmlformats.org/drawingml/2006/main">
               <a:ext uri="{FF2B5EF4-FFF2-40B4-BE49-F238E27FC236}">
-                <a16:creationId xmlns:a16="http://schemas.microsoft.com/office/drawing/2014/main" id="{E645211D-323B-43D9-B8E0-E2C98F593963}"/>
+                <a16:creationId xmlns:a16="http://schemas.microsoft.com/office/drawing/2014/main" id="{97B886A7-B295-47EF-ABE6-A58B54F0E670}"/>
               </a:ext>
             </a:extLst>
           </p:cNvPr>
@@ -4628,7 +4771,7 @@
           <p:cNvPr id="11" name="">
             <a:extLst xmlns:a="http://schemas.openxmlformats.org/drawingml/2006/main">
               <a:ext uri="{FF2B5EF4-FFF2-40B4-BE49-F238E27FC236}">
-                <a16:creationId xmlns:a16="http://schemas.microsoft.com/office/drawing/2014/main" id="{B8FA2D4E-2298-4731-B6B8-27670A38CB53}"/>
+                <a16:creationId xmlns:a16="http://schemas.microsoft.com/office/drawing/2014/main" id="{9EC601B7-8A8E-4573-8A5C-C0024AAEA1A0}"/>
               </a:ext>
             </a:extLst>
           </p:cNvPr>
@@ -4685,7 +4828,7 @@
           <p:cNvPr id="12" name="">
             <a:extLst xmlns:a="http://schemas.openxmlformats.org/drawingml/2006/main">
               <a:ext uri="{FF2B5EF4-FFF2-40B4-BE49-F238E27FC236}">
-                <a16:creationId xmlns:a16="http://schemas.microsoft.com/office/drawing/2014/main" id="{BA6D389F-4EB9-4422-8825-CD0C8A539F78}"/>
+                <a16:creationId xmlns:a16="http://schemas.microsoft.com/office/drawing/2014/main" id="{33621989-FB65-4B9E-8CC9-F304E5BF10E2}"/>
               </a:ext>
             </a:extLst>
           </p:cNvPr>
@@ -4742,7 +4885,7 @@
           <p:cNvPr id="13" name="">
             <a:extLst xmlns:a="http://schemas.openxmlformats.org/drawingml/2006/main">
               <a:ext uri="{FF2B5EF4-FFF2-40B4-BE49-F238E27FC236}">
-                <a16:creationId xmlns:a16="http://schemas.microsoft.com/office/drawing/2014/main" id="{0C43F97C-4CD6-4986-A219-2C90C8F38446}"/>
+                <a16:creationId xmlns:a16="http://schemas.microsoft.com/office/drawing/2014/main" id="{B3B28C76-CC40-4A9B-9332-28B1E32BBF8B}"/>
               </a:ext>
             </a:extLst>
           </p:cNvPr>
@@ -4799,7 +4942,7 @@
           <p:cNvPr id="14" name="">
             <a:extLst xmlns:a="http://schemas.openxmlformats.org/drawingml/2006/main">
               <a:ext uri="{FF2B5EF4-FFF2-40B4-BE49-F238E27FC236}">
-                <a16:creationId xmlns:a16="http://schemas.microsoft.com/office/drawing/2014/main" id="{213302E3-7D7A-4F61-90FC-2EE0551B44A3}"/>
+                <a16:creationId xmlns:a16="http://schemas.microsoft.com/office/drawing/2014/main" id="{864C2EEC-EB4E-4B5C-967B-C02982CCFA95}"/>
               </a:ext>
             </a:extLst>
           </p:cNvPr>
@@ -4856,7 +4999,7 @@
           <p:cNvPr id="15" name="">
             <a:extLst xmlns:a="http://schemas.openxmlformats.org/drawingml/2006/main">
               <a:ext uri="{FF2B5EF4-FFF2-40B4-BE49-F238E27FC236}">
-                <a16:creationId xmlns:a16="http://schemas.microsoft.com/office/drawing/2014/main" id="{D881F693-8EDA-4F6D-920A-38D2B9C2E009}"/>
+                <a16:creationId xmlns:a16="http://schemas.microsoft.com/office/drawing/2014/main" id="{E8C5613A-725C-4EA5-AD25-44E0B4A3ED92}"/>
               </a:ext>
             </a:extLst>
           </p:cNvPr>
@@ -4911,7 +5054,7 @@
     </p:spTree>
     <p:extLst>
       <p:ext uri="{BB962C8B-B14F-4D97-AF65-F5344CB8AC3E}">
-        <p14:creationId xmlns:p14="http://schemas.microsoft.com/office/powerpoint/2010/main" val="223284993"/>
+        <p14:creationId xmlns:p14="http://schemas.microsoft.com/office/powerpoint/2010/main" val="1443547205"/>
       </p:ext>
     </p:extLst>
   </p:cSld>

</xml_diff>